<commit_message>
Hierarchy, and sim loop and other top level design revisited now to finalize structure, happy overall, moving into GNC and documentation
</commit_message>
<xml_diff>
--- a/docs/Apogee_Progession.pptx
+++ b/docs/Apogee_Progession.pptx
@@ -8,29 +8,32 @@
     <p:sldId id="256" r:id="rId2"/>
     <p:sldId id="257" r:id="rId3"/>
     <p:sldId id="273" r:id="rId4"/>
-    <p:sldId id="274" r:id="rId5"/>
-    <p:sldId id="275" r:id="rId6"/>
-    <p:sldId id="259" r:id="rId7"/>
-    <p:sldId id="265" r:id="rId8"/>
-    <p:sldId id="266" r:id="rId9"/>
-    <p:sldId id="260" r:id="rId10"/>
-    <p:sldId id="267" r:id="rId11"/>
-    <p:sldId id="268" r:id="rId12"/>
-    <p:sldId id="261" r:id="rId13"/>
-    <p:sldId id="271" r:id="rId14"/>
-    <p:sldId id="272" r:id="rId15"/>
-    <p:sldId id="262" r:id="rId16"/>
-    <p:sldId id="269" r:id="rId17"/>
-    <p:sldId id="270" r:id="rId18"/>
-    <p:sldId id="276" r:id="rId19"/>
-    <p:sldId id="277" r:id="rId20"/>
-    <p:sldId id="278" r:id="rId21"/>
-    <p:sldId id="284" r:id="rId22"/>
-    <p:sldId id="283" r:id="rId23"/>
-    <p:sldId id="282" r:id="rId24"/>
-    <p:sldId id="281" r:id="rId25"/>
-    <p:sldId id="279" r:id="rId26"/>
-    <p:sldId id="280" r:id="rId27"/>
+    <p:sldId id="286" r:id="rId5"/>
+    <p:sldId id="287" r:id="rId6"/>
+    <p:sldId id="285" r:id="rId7"/>
+    <p:sldId id="274" r:id="rId8"/>
+    <p:sldId id="275" r:id="rId9"/>
+    <p:sldId id="259" r:id="rId10"/>
+    <p:sldId id="265" r:id="rId11"/>
+    <p:sldId id="266" r:id="rId12"/>
+    <p:sldId id="260" r:id="rId13"/>
+    <p:sldId id="267" r:id="rId14"/>
+    <p:sldId id="268" r:id="rId15"/>
+    <p:sldId id="261" r:id="rId16"/>
+    <p:sldId id="271" r:id="rId17"/>
+    <p:sldId id="272" r:id="rId18"/>
+    <p:sldId id="262" r:id="rId19"/>
+    <p:sldId id="269" r:id="rId20"/>
+    <p:sldId id="270" r:id="rId21"/>
+    <p:sldId id="276" r:id="rId22"/>
+    <p:sldId id="277" r:id="rId23"/>
+    <p:sldId id="278" r:id="rId24"/>
+    <p:sldId id="284" r:id="rId25"/>
+    <p:sldId id="283" r:id="rId26"/>
+    <p:sldId id="282" r:id="rId27"/>
+    <p:sldId id="281" r:id="rId28"/>
+    <p:sldId id="279" r:id="rId29"/>
+    <p:sldId id="280" r:id="rId30"/>
   </p:sldIdLst>
   <p:sldSz cx="12192000" cy="6858000"/>
   <p:notesSz cx="6858000" cy="9144000"/>
@@ -129,13 +132,18 @@
       </a:defRPr>
     </a:lvl9pPr>
   </p:defaultTextStyle>
+  <p:extLst>
+    <p:ext uri="{EFAFB233-063F-42B5-8137-9DF3F51BA10A}">
+      <p15:sldGuideLst xmlns:p15="http://schemas.microsoft.com/office/powerpoint/2012/main"/>
+    </p:ext>
+  </p:extLst>
 </p:presentation>
 </file>
 
 <file path=ppt/revisionInfo.xml><?xml version="1.0" encoding="utf-8"?>
 <p1510:revInfo xmlns:a="http://schemas.openxmlformats.org/drawingml/2006/main" xmlns:r="http://schemas.openxmlformats.org/officeDocument/2006/relationships" xmlns:p1510="http://schemas.microsoft.com/office/powerpoint/2015/10/main">
   <p1510:revLst>
-    <p1510:client id="{9F88DE7B-4153-4DD5-8CD8-49B431BF79F3}" v="4" dt="2026-10-14T01:08:42.617"/>
+    <p1510:client id="{9F88DE7B-4153-4DD5-8CD8-49B431BF79F3}" v="9" dt="2026-10-14T03:59:15.516"/>
   </p1510:revLst>
 </p1510:revInfo>
 </file>
@@ -145,7 +153,7 @@
   <pc:docChgLst>
     <pc:chgData name="Jeremy Jestel" userId="f12305450eb37733" providerId="LiveId" clId="{5A341855-0C93-42C0-8589-13149EEF218B}"/>
     <pc:docChg chg="undo custSel addSld delSld modSld">
-      <pc:chgData name="Jeremy Jestel" userId="f12305450eb37733" providerId="LiveId" clId="{5A341855-0C93-42C0-8589-13149EEF218B}" dt="2026-10-14T01:24:07.984" v="3004" actId="20577"/>
+      <pc:chgData name="Jeremy Jestel" userId="f12305450eb37733" providerId="LiveId" clId="{5A341855-0C93-42C0-8589-13149EEF218B}" dt="2026-10-14T04:11:00.091" v="4483" actId="20577"/>
       <pc:docMkLst>
         <pc:docMk/>
       </pc:docMkLst>
@@ -328,13 +336,13 @@
         </pc:sldMkLst>
       </pc:sldChg>
       <pc:sldChg chg="modSp add mod">
-        <pc:chgData name="Jeremy Jestel" userId="f12305450eb37733" providerId="LiveId" clId="{5A341855-0C93-42C0-8589-13149EEF218B}" dt="2026-10-13T23:50:39.973" v="1729" actId="1076"/>
+        <pc:chgData name="Jeremy Jestel" userId="f12305450eb37733" providerId="LiveId" clId="{5A341855-0C93-42C0-8589-13149EEF218B}" dt="2026-10-14T03:52:04.388" v="3028" actId="20577"/>
         <pc:sldMkLst>
           <pc:docMk/>
           <pc:sldMk cId="2935349719" sldId="273"/>
         </pc:sldMkLst>
         <pc:spChg chg="mod">
-          <ac:chgData name="Jeremy Jestel" userId="f12305450eb37733" providerId="LiveId" clId="{5A341855-0C93-42C0-8589-13149EEF218B}" dt="2026-10-13T23:50:39.973" v="1729" actId="1076"/>
+          <ac:chgData name="Jeremy Jestel" userId="f12305450eb37733" providerId="LiveId" clId="{5A341855-0C93-42C0-8589-13149EEF218B}" dt="2026-10-14T03:52:04.388" v="3028" actId="20577"/>
           <ac:spMkLst>
             <pc:docMk/>
             <pc:sldMk cId="2935349719" sldId="273"/>
@@ -523,6 +531,67 @@
           </ac:spMkLst>
         </pc:spChg>
       </pc:sldChg>
+      <pc:sldChg chg="add">
+        <pc:chgData name="Jeremy Jestel" userId="f12305450eb37733" providerId="LiveId" clId="{5A341855-0C93-42C0-8589-13149EEF218B}" dt="2026-10-14T03:51:54.704" v="3005"/>
+        <pc:sldMkLst>
+          <pc:docMk/>
+          <pc:sldMk cId="3880961570" sldId="285"/>
+        </pc:sldMkLst>
+      </pc:sldChg>
+      <pc:sldChg chg="modSp new mod">
+        <pc:chgData name="Jeremy Jestel" userId="f12305450eb37733" providerId="LiveId" clId="{5A341855-0C93-42C0-8589-13149EEF218B}" dt="2026-10-14T03:59:53.062" v="3661" actId="20577"/>
+        <pc:sldMkLst>
+          <pc:docMk/>
+          <pc:sldMk cId="3139715625" sldId="286"/>
+        </pc:sldMkLst>
+        <pc:spChg chg="mod">
+          <ac:chgData name="Jeremy Jestel" userId="f12305450eb37733" providerId="LiveId" clId="{5A341855-0C93-42C0-8589-13149EEF218B}" dt="2026-10-14T03:52:24.997" v="3044" actId="20577"/>
+          <ac:spMkLst>
+            <pc:docMk/>
+            <pc:sldMk cId="3139715625" sldId="286"/>
+            <ac:spMk id="2" creationId="{9111801B-6A40-1772-640F-C6E216A3ADC1}"/>
+          </ac:spMkLst>
+        </pc:spChg>
+        <pc:spChg chg="mod">
+          <ac:chgData name="Jeremy Jestel" userId="f12305450eb37733" providerId="LiveId" clId="{5A341855-0C93-42C0-8589-13149EEF218B}" dt="2026-10-14T03:59:53.062" v="3661" actId="20577"/>
+          <ac:spMkLst>
+            <pc:docMk/>
+            <pc:sldMk cId="3139715625" sldId="286"/>
+            <ac:spMk id="3" creationId="{9ED41821-5945-F8C7-9445-1A56F43FB387}"/>
+          </ac:spMkLst>
+        </pc:spChg>
+      </pc:sldChg>
+      <pc:sldChg chg="addSp modSp new mod">
+        <pc:chgData name="Jeremy Jestel" userId="f12305450eb37733" providerId="LiveId" clId="{5A341855-0C93-42C0-8589-13149EEF218B}" dt="2026-10-14T04:11:00.091" v="4483" actId="20577"/>
+        <pc:sldMkLst>
+          <pc:docMk/>
+          <pc:sldMk cId="2987790816" sldId="287"/>
+        </pc:sldMkLst>
+        <pc:spChg chg="mod">
+          <ac:chgData name="Jeremy Jestel" userId="f12305450eb37733" providerId="LiveId" clId="{5A341855-0C93-42C0-8589-13149EEF218B}" dt="2026-10-14T04:00:33.124" v="3687" actId="20577"/>
+          <ac:spMkLst>
+            <pc:docMk/>
+            <pc:sldMk cId="2987790816" sldId="287"/>
+            <ac:spMk id="2" creationId="{0EDD1904-E6E4-C5D7-7A69-DDB37B0314C5}"/>
+          </ac:spMkLst>
+        </pc:spChg>
+        <pc:spChg chg="mod">
+          <ac:chgData name="Jeremy Jestel" userId="f12305450eb37733" providerId="LiveId" clId="{5A341855-0C93-42C0-8589-13149EEF218B}" dt="2026-10-14T04:11:00.091" v="4483" actId="20577"/>
+          <ac:spMkLst>
+            <pc:docMk/>
+            <pc:sldMk cId="2987790816" sldId="287"/>
+            <ac:spMk id="3" creationId="{68EDBE33-97E2-A95E-5CF4-85FE479A817D}"/>
+          </ac:spMkLst>
+        </pc:spChg>
+        <pc:picChg chg="add mod">
+          <ac:chgData name="Jeremy Jestel" userId="f12305450eb37733" providerId="LiveId" clId="{5A341855-0C93-42C0-8589-13149EEF218B}" dt="2026-10-14T04:08:11.028" v="3945" actId="1076"/>
+          <ac:picMkLst>
+            <pc:docMk/>
+            <pc:sldMk cId="2987790816" sldId="287"/>
+            <ac:picMk id="5" creationId="{A4BCE60F-1BBF-5539-2529-FA7F7DBC83CB}"/>
+          </ac:picMkLst>
+        </pc:picChg>
+      </pc:sldChg>
     </pc:docChg>
   </pc:docChgLst>
 </pc:chgInfo>
@@ -675,7 +744,7 @@
           <a:p>
             <a:fld id="{CEB632EC-697C-46E2-86FC-E2DD52DD9F70}" type="datetimeFigureOut">
               <a:rPr lang="en-US" smtClean="0"/>
-              <a:t>10/5/2026</a:t>
+              <a:t>10/13/2026</a:t>
             </a:fld>
             <a:endParaRPr lang="en-US"/>
           </a:p>
@@ -873,7 +942,7 @@
           <a:p>
             <a:fld id="{CEB632EC-697C-46E2-86FC-E2DD52DD9F70}" type="datetimeFigureOut">
               <a:rPr lang="en-US" smtClean="0"/>
-              <a:t>10/5/2026</a:t>
+              <a:t>10/13/2026</a:t>
             </a:fld>
             <a:endParaRPr lang="en-US"/>
           </a:p>
@@ -1081,7 +1150,7 @@
           <a:p>
             <a:fld id="{CEB632EC-697C-46E2-86FC-E2DD52DD9F70}" type="datetimeFigureOut">
               <a:rPr lang="en-US" smtClean="0"/>
-              <a:t>10/5/2026</a:t>
+              <a:t>10/13/2026</a:t>
             </a:fld>
             <a:endParaRPr lang="en-US"/>
           </a:p>
@@ -1279,7 +1348,7 @@
           <a:p>
             <a:fld id="{CEB632EC-697C-46E2-86FC-E2DD52DD9F70}" type="datetimeFigureOut">
               <a:rPr lang="en-US" smtClean="0"/>
-              <a:t>10/5/2026</a:t>
+              <a:t>10/13/2026</a:t>
             </a:fld>
             <a:endParaRPr lang="en-US"/>
           </a:p>
@@ -1554,7 +1623,7 @@
           <a:p>
             <a:fld id="{CEB632EC-697C-46E2-86FC-E2DD52DD9F70}" type="datetimeFigureOut">
               <a:rPr lang="en-US" smtClean="0"/>
-              <a:t>10/5/2026</a:t>
+              <a:t>10/13/2026</a:t>
             </a:fld>
             <a:endParaRPr lang="en-US"/>
           </a:p>
@@ -1819,7 +1888,7 @@
           <a:p>
             <a:fld id="{CEB632EC-697C-46E2-86FC-E2DD52DD9F70}" type="datetimeFigureOut">
               <a:rPr lang="en-US" smtClean="0"/>
-              <a:t>10/5/2026</a:t>
+              <a:t>10/13/2026</a:t>
             </a:fld>
             <a:endParaRPr lang="en-US"/>
           </a:p>
@@ -2231,7 +2300,7 @@
           <a:p>
             <a:fld id="{CEB632EC-697C-46E2-86FC-E2DD52DD9F70}" type="datetimeFigureOut">
               <a:rPr lang="en-US" smtClean="0"/>
-              <a:t>10/5/2026</a:t>
+              <a:t>10/13/2026</a:t>
             </a:fld>
             <a:endParaRPr lang="en-US"/>
           </a:p>
@@ -2372,7 +2441,7 @@
           <a:p>
             <a:fld id="{CEB632EC-697C-46E2-86FC-E2DD52DD9F70}" type="datetimeFigureOut">
               <a:rPr lang="en-US" smtClean="0"/>
-              <a:t>10/5/2026</a:t>
+              <a:t>10/13/2026</a:t>
             </a:fld>
             <a:endParaRPr lang="en-US"/>
           </a:p>
@@ -2485,7 +2554,7 @@
           <a:p>
             <a:fld id="{CEB632EC-697C-46E2-86FC-E2DD52DD9F70}" type="datetimeFigureOut">
               <a:rPr lang="en-US" smtClean="0"/>
-              <a:t>10/5/2026</a:t>
+              <a:t>10/13/2026</a:t>
             </a:fld>
             <a:endParaRPr lang="en-US"/>
           </a:p>
@@ -2796,7 +2865,7 @@
           <a:p>
             <a:fld id="{CEB632EC-697C-46E2-86FC-E2DD52DD9F70}" type="datetimeFigureOut">
               <a:rPr lang="en-US" smtClean="0"/>
-              <a:t>10/5/2026</a:t>
+              <a:t>10/13/2026</a:t>
             </a:fld>
             <a:endParaRPr lang="en-US"/>
           </a:p>
@@ -3084,7 +3153,7 @@
           <a:p>
             <a:fld id="{CEB632EC-697C-46E2-86FC-E2DD52DD9F70}" type="datetimeFigureOut">
               <a:rPr lang="en-US" smtClean="0"/>
-              <a:t>10/5/2026</a:t>
+              <a:t>10/13/2026</a:t>
             </a:fld>
             <a:endParaRPr lang="en-US"/>
           </a:p>
@@ -3325,7 +3394,7 @@
           <a:p>
             <a:fld id="{CEB632EC-697C-46E2-86FC-E2DD52DD9F70}" type="datetimeFigureOut">
               <a:rPr lang="en-US" smtClean="0"/>
-              <a:t>10/5/2026</a:t>
+              <a:t>10/13/2026</a:t>
             </a:fld>
             <a:endParaRPr lang="en-US"/>
           </a:p>
@@ -3816,6 +3885,295 @@
         <p:cNvPr id="1" name="">
           <a:extLst>
             <a:ext uri="{FF2B5EF4-FFF2-40B4-BE49-F238E27FC236}">
+              <a16:creationId xmlns:a16="http://schemas.microsoft.com/office/drawing/2014/main" id="{7365EBFC-1256-5E78-F5F3-671A504DEC21}"/>
+            </a:ext>
+          </a:extLst>
+        </p:cNvPr>
+        <p:cNvGrpSpPr/>
+        <p:nvPr/>
+      </p:nvGrpSpPr>
+      <p:grpSpPr>
+        <a:xfrm>
+          <a:off x="0" y="0"/>
+          <a:ext cx="0" cy="0"/>
+          <a:chOff x="0" y="0"/>
+          <a:chExt cx="0" cy="0"/>
+        </a:xfrm>
+      </p:grpSpPr>
+      <p:sp>
+        <p:nvSpPr>
+          <p:cNvPr id="2" name="Title 1">
+            <a:extLst>
+              <a:ext uri="{FF2B5EF4-FFF2-40B4-BE49-F238E27FC236}">
+                <a16:creationId xmlns:a16="http://schemas.microsoft.com/office/drawing/2014/main" id="{3E6CB228-385F-B5F1-42F8-AC0040E8C2EC}"/>
+              </a:ext>
+            </a:extLst>
+          </p:cNvPr>
+          <p:cNvSpPr>
+            <a:spLocks noGrp="1"/>
+          </p:cNvSpPr>
+          <p:nvPr>
+            <p:ph type="title"/>
+          </p:nvPr>
+        </p:nvSpPr>
+        <p:spPr/>
+        <p:txBody>
+          <a:bodyPr/>
+          <a:lstStyle/>
+          <a:p>
+            <a:r>
+              <a:rPr lang="en-US" dirty="0"/>
+              <a:t>Feature Description</a:t>
+            </a:r>
+          </a:p>
+        </p:txBody>
+      </p:sp>
+      <p:sp>
+        <p:nvSpPr>
+          <p:cNvPr id="3" name="Content Placeholder 2">
+            <a:extLst>
+              <a:ext uri="{FF2B5EF4-FFF2-40B4-BE49-F238E27FC236}">
+                <a16:creationId xmlns:a16="http://schemas.microsoft.com/office/drawing/2014/main" id="{7ECE178C-5A02-EBB0-B9DD-067B6F9EAE8A}"/>
+              </a:ext>
+            </a:extLst>
+          </p:cNvPr>
+          <p:cNvSpPr>
+            <a:spLocks noGrp="1"/>
+          </p:cNvSpPr>
+          <p:nvPr>
+            <p:ph idx="1"/>
+          </p:nvPr>
+        </p:nvSpPr>
+        <p:spPr/>
+        <p:txBody>
+          <a:bodyPr/>
+          <a:lstStyle/>
+          <a:p>
+            <a:endParaRPr lang="en-US" dirty="0"/>
+          </a:p>
+        </p:txBody>
+      </p:sp>
+    </p:spTree>
+    <p:extLst>
+      <p:ext uri="{BB962C8B-B14F-4D97-AF65-F5344CB8AC3E}">
+        <p14:creationId xmlns:p14="http://schemas.microsoft.com/office/powerpoint/2010/main" val="2783873779"/>
+      </p:ext>
+    </p:extLst>
+  </p:cSld>
+  <p:clrMapOvr>
+    <a:masterClrMapping/>
+  </p:clrMapOvr>
+</p:sld>
+</file>
+
+<file path=ppt/slides/slide11.xml><?xml version="1.0" encoding="utf-8"?>
+<p:sld xmlns:a="http://schemas.openxmlformats.org/drawingml/2006/main" xmlns:r="http://schemas.openxmlformats.org/officeDocument/2006/relationships" xmlns:p="http://schemas.openxmlformats.org/presentationml/2006/main">
+  <p:cSld>
+    <p:spTree>
+      <p:nvGrpSpPr>
+        <p:cNvPr id="1" name="">
+          <a:extLst>
+            <a:ext uri="{FF2B5EF4-FFF2-40B4-BE49-F238E27FC236}">
+              <a16:creationId xmlns:a16="http://schemas.microsoft.com/office/drawing/2014/main" id="{7C9A7419-5BC5-5DA0-2C42-1A786B2FE457}"/>
+            </a:ext>
+          </a:extLst>
+        </p:cNvPr>
+        <p:cNvGrpSpPr/>
+        <p:nvPr/>
+      </p:nvGrpSpPr>
+      <p:grpSpPr>
+        <a:xfrm>
+          <a:off x="0" y="0"/>
+          <a:ext cx="0" cy="0"/>
+          <a:chOff x="0" y="0"/>
+          <a:chExt cx="0" cy="0"/>
+        </a:xfrm>
+      </p:grpSpPr>
+      <p:sp>
+        <p:nvSpPr>
+          <p:cNvPr id="2" name="Title 1">
+            <a:extLst>
+              <a:ext uri="{FF2B5EF4-FFF2-40B4-BE49-F238E27FC236}">
+                <a16:creationId xmlns:a16="http://schemas.microsoft.com/office/drawing/2014/main" id="{1A1098A0-C42F-F46F-ABAD-E3EA1F74F29A}"/>
+              </a:ext>
+            </a:extLst>
+          </p:cNvPr>
+          <p:cNvSpPr>
+            <a:spLocks noGrp="1"/>
+          </p:cNvSpPr>
+          <p:nvPr>
+            <p:ph type="title"/>
+          </p:nvPr>
+        </p:nvSpPr>
+        <p:spPr/>
+        <p:txBody>
+          <a:bodyPr/>
+          <a:lstStyle/>
+          <a:p>
+            <a:r>
+              <a:rPr lang="en-US" dirty="0"/>
+              <a:t>Developer Notes</a:t>
+            </a:r>
+          </a:p>
+        </p:txBody>
+      </p:sp>
+      <p:sp>
+        <p:nvSpPr>
+          <p:cNvPr id="3" name="Content Placeholder 2">
+            <a:extLst>
+              <a:ext uri="{FF2B5EF4-FFF2-40B4-BE49-F238E27FC236}">
+                <a16:creationId xmlns:a16="http://schemas.microsoft.com/office/drawing/2014/main" id="{6CB7F24B-E6BE-238D-8DCC-6388A26F2BF3}"/>
+              </a:ext>
+            </a:extLst>
+          </p:cNvPr>
+          <p:cNvSpPr>
+            <a:spLocks noGrp="1"/>
+          </p:cNvSpPr>
+          <p:nvPr>
+            <p:ph idx="1"/>
+          </p:nvPr>
+        </p:nvSpPr>
+        <p:spPr/>
+        <p:txBody>
+          <a:bodyPr/>
+          <a:lstStyle/>
+          <a:p>
+            <a:r>
+              <a:rPr lang="en-US" dirty="0"/>
+              <a:t>What is the default coordinate structure for calculations</a:t>
+            </a:r>
+          </a:p>
+          <a:p>
+            <a:r>
+              <a:rPr lang="en-US" dirty="0"/>
+              <a:t>Seems to be R </a:t>
+            </a:r>
+            <a:r>
+              <a:rPr lang="en-US" dirty="0" err="1"/>
+              <a:t>vec</a:t>
+            </a:r>
+            <a:r>
+              <a:rPr lang="en-US" dirty="0"/>
+              <a:t> of ECEF XYZ works, maybe use a NED coords for local</a:t>
+            </a:r>
+          </a:p>
+          <a:p>
+            <a:r>
+              <a:rPr lang="en-US" dirty="0"/>
+              <a:t>Best way to do the </a:t>
+            </a:r>
+            <a:r>
+              <a:rPr lang="en-US" dirty="0" err="1"/>
+              <a:t>lin</a:t>
+            </a:r>
+            <a:r>
+              <a:rPr lang="en-US" dirty="0"/>
+              <a:t> </a:t>
+            </a:r>
+            <a:r>
+              <a:rPr lang="en-US" dirty="0" err="1"/>
+              <a:t>alg</a:t>
+            </a:r>
+            <a:r>
+              <a:rPr lang="en-US" dirty="0"/>
+              <a:t> math for easy vector manipulation in C++</a:t>
+            </a:r>
+          </a:p>
+          <a:p>
+            <a:endParaRPr lang="en-US" dirty="0"/>
+          </a:p>
+        </p:txBody>
+      </p:sp>
+    </p:spTree>
+    <p:extLst>
+      <p:ext uri="{BB962C8B-B14F-4D97-AF65-F5344CB8AC3E}">
+        <p14:creationId xmlns:p14="http://schemas.microsoft.com/office/powerpoint/2010/main" val="1555275095"/>
+      </p:ext>
+    </p:extLst>
+  </p:cSld>
+  <p:clrMapOvr>
+    <a:masterClrMapping/>
+  </p:clrMapOvr>
+</p:sld>
+</file>
+
+<file path=ppt/slides/slide12.xml><?xml version="1.0" encoding="utf-8"?>
+<p:sld xmlns:a="http://schemas.openxmlformats.org/drawingml/2006/main" xmlns:r="http://schemas.openxmlformats.org/officeDocument/2006/relationships" xmlns:p="http://schemas.openxmlformats.org/presentationml/2006/main">
+  <p:cSld>
+    <p:spTree>
+      <p:nvGrpSpPr>
+        <p:cNvPr id="1" name="">
+          <a:extLst>
+            <a:ext uri="{FF2B5EF4-FFF2-40B4-BE49-F238E27FC236}">
+              <a16:creationId xmlns:a16="http://schemas.microsoft.com/office/drawing/2014/main" id="{280BCD6E-9393-77DB-D42F-45B06B7568DC}"/>
+            </a:ext>
+          </a:extLst>
+        </p:cNvPr>
+        <p:cNvGrpSpPr/>
+        <p:nvPr/>
+      </p:nvGrpSpPr>
+      <p:grpSpPr>
+        <a:xfrm>
+          <a:off x="0" y="0"/>
+          <a:ext cx="0" cy="0"/>
+          <a:chOff x="0" y="0"/>
+          <a:chExt cx="0" cy="0"/>
+        </a:xfrm>
+      </p:grpSpPr>
+      <p:sp>
+        <p:nvSpPr>
+          <p:cNvPr id="2" name="Title 1">
+            <a:extLst>
+              <a:ext uri="{FF2B5EF4-FFF2-40B4-BE49-F238E27FC236}">
+                <a16:creationId xmlns:a16="http://schemas.microsoft.com/office/drawing/2014/main" id="{37910598-C7ED-84E2-49E5-F8B92D38D089}"/>
+              </a:ext>
+            </a:extLst>
+          </p:cNvPr>
+          <p:cNvSpPr>
+            <a:spLocks noGrp="1"/>
+          </p:cNvSpPr>
+          <p:nvPr>
+            <p:ph type="title"/>
+          </p:nvPr>
+        </p:nvSpPr>
+        <p:spPr>
+          <a:xfrm>
+            <a:off x="2626057" y="2698892"/>
+            <a:ext cx="10515600" cy="1325563"/>
+          </a:xfrm>
+        </p:spPr>
+        <p:txBody>
+          <a:bodyPr/>
+          <a:lstStyle/>
+          <a:p>
+            <a:r>
+              <a:rPr lang="en-US" dirty="0"/>
+              <a:t>Missile Guidance Without LOS</a:t>
+            </a:r>
+          </a:p>
+        </p:txBody>
+      </p:sp>
+    </p:spTree>
+    <p:extLst>
+      <p:ext uri="{BB962C8B-B14F-4D97-AF65-F5344CB8AC3E}">
+        <p14:creationId xmlns:p14="http://schemas.microsoft.com/office/powerpoint/2010/main" val="1256370275"/>
+      </p:ext>
+    </p:extLst>
+  </p:cSld>
+  <p:clrMapOvr>
+    <a:masterClrMapping/>
+  </p:clrMapOvr>
+</p:sld>
+</file>
+
+<file path=ppt/slides/slide13.xml><?xml version="1.0" encoding="utf-8"?>
+<p:sld xmlns:a="http://schemas.openxmlformats.org/drawingml/2006/main" xmlns:r="http://schemas.openxmlformats.org/officeDocument/2006/relationships" xmlns:p="http://schemas.openxmlformats.org/presentationml/2006/main">
+  <p:cSld>
+    <p:spTree>
+      <p:nvGrpSpPr>
+        <p:cNvPr id="1" name="">
+          <a:extLst>
+            <a:ext uri="{FF2B5EF4-FFF2-40B4-BE49-F238E27FC236}">
               <a16:creationId xmlns:a16="http://schemas.microsoft.com/office/drawing/2014/main" id="{A185A99F-B239-2107-F033-C715A2138B53}"/>
             </a:ext>
           </a:extLst>
@@ -3897,7 +4255,7 @@
 </p:sld>
 </file>
 
-<file path=ppt/slides/slide11.xml><?xml version="1.0" encoding="utf-8"?>
+<file path=ppt/slides/slide14.xml><?xml version="1.0" encoding="utf-8"?>
 <p:sld xmlns:a="http://schemas.openxmlformats.org/drawingml/2006/main" xmlns:r="http://schemas.openxmlformats.org/officeDocument/2006/relationships" xmlns:p="http://schemas.openxmlformats.org/presentationml/2006/main">
   <p:cSld>
     <p:spTree>
@@ -3986,7 +4344,7 @@
 </p:sld>
 </file>
 
-<file path=ppt/slides/slide12.xml><?xml version="1.0" encoding="utf-8"?>
+<file path=ppt/slides/slide15.xml><?xml version="1.0" encoding="utf-8"?>
 <p:sld xmlns:a="http://schemas.openxmlformats.org/drawingml/2006/main" xmlns:r="http://schemas.openxmlformats.org/officeDocument/2006/relationships" xmlns:p="http://schemas.openxmlformats.org/presentationml/2006/main">
   <p:cSld>
     <p:spTree>
@@ -4055,7 +4413,7 @@
 </p:sld>
 </file>
 
-<file path=ppt/slides/slide13.xml><?xml version="1.0" encoding="utf-8"?>
+<file path=ppt/slides/slide16.xml><?xml version="1.0" encoding="utf-8"?>
 <p:sld xmlns:a="http://schemas.openxmlformats.org/drawingml/2006/main" xmlns:r="http://schemas.openxmlformats.org/officeDocument/2006/relationships" xmlns:p="http://schemas.openxmlformats.org/presentationml/2006/main">
   <p:cSld>
     <p:spTree>
@@ -4144,7 +4502,7 @@
 </p:sld>
 </file>
 
-<file path=ppt/slides/slide14.xml><?xml version="1.0" encoding="utf-8"?>
+<file path=ppt/slides/slide17.xml><?xml version="1.0" encoding="utf-8"?>
 <p:sld xmlns:a="http://schemas.openxmlformats.org/drawingml/2006/main" xmlns:r="http://schemas.openxmlformats.org/officeDocument/2006/relationships" xmlns:p="http://schemas.openxmlformats.org/presentationml/2006/main">
   <p:cSld>
     <p:spTree>
@@ -4233,7 +4591,7 @@
 </p:sld>
 </file>
 
-<file path=ppt/slides/slide15.xml><?xml version="1.0" encoding="utf-8"?>
+<file path=ppt/slides/slide18.xml><?xml version="1.0" encoding="utf-8"?>
 <p:sld xmlns:a="http://schemas.openxmlformats.org/drawingml/2006/main" xmlns:r="http://schemas.openxmlformats.org/officeDocument/2006/relationships" xmlns:p="http://schemas.openxmlformats.org/presentationml/2006/main">
   <p:cSld>
     <p:spTree>
@@ -4302,7 +4660,7 @@
 </p:sld>
 </file>
 
-<file path=ppt/slides/slide16.xml><?xml version="1.0" encoding="utf-8"?>
+<file path=ppt/slides/slide19.xml><?xml version="1.0" encoding="utf-8"?>
 <p:sld xmlns:a="http://schemas.openxmlformats.org/drawingml/2006/main" xmlns:r="http://schemas.openxmlformats.org/officeDocument/2006/relationships" xmlns:p="http://schemas.openxmlformats.org/presentationml/2006/main">
   <p:cSld>
     <p:spTree>
@@ -4382,253 +4740,6 @@
     <p:extLst>
       <p:ext uri="{BB962C8B-B14F-4D97-AF65-F5344CB8AC3E}">
         <p14:creationId xmlns:p14="http://schemas.microsoft.com/office/powerpoint/2010/main" val="1515804299"/>
-      </p:ext>
-    </p:extLst>
-  </p:cSld>
-  <p:clrMapOvr>
-    <a:masterClrMapping/>
-  </p:clrMapOvr>
-</p:sld>
-</file>
-
-<file path=ppt/slides/slide17.xml><?xml version="1.0" encoding="utf-8"?>
-<p:sld xmlns:a="http://schemas.openxmlformats.org/drawingml/2006/main" xmlns:r="http://schemas.openxmlformats.org/officeDocument/2006/relationships" xmlns:p="http://schemas.openxmlformats.org/presentationml/2006/main">
-  <p:cSld>
-    <p:spTree>
-      <p:nvGrpSpPr>
-        <p:cNvPr id="1" name="">
-          <a:extLst>
-            <a:ext uri="{FF2B5EF4-FFF2-40B4-BE49-F238E27FC236}">
-              <a16:creationId xmlns:a16="http://schemas.microsoft.com/office/drawing/2014/main" id="{F843A5F4-DF64-F696-21A9-BF70F464230F}"/>
-            </a:ext>
-          </a:extLst>
-        </p:cNvPr>
-        <p:cNvGrpSpPr/>
-        <p:nvPr/>
-      </p:nvGrpSpPr>
-      <p:grpSpPr>
-        <a:xfrm>
-          <a:off x="0" y="0"/>
-          <a:ext cx="0" cy="0"/>
-          <a:chOff x="0" y="0"/>
-          <a:chExt cx="0" cy="0"/>
-        </a:xfrm>
-      </p:grpSpPr>
-      <p:sp>
-        <p:nvSpPr>
-          <p:cNvPr id="2" name="Title 1">
-            <a:extLst>
-              <a:ext uri="{FF2B5EF4-FFF2-40B4-BE49-F238E27FC236}">
-                <a16:creationId xmlns:a16="http://schemas.microsoft.com/office/drawing/2014/main" id="{1FDCEB75-C879-DA8C-4012-BCC72FBA4A57}"/>
-              </a:ext>
-            </a:extLst>
-          </p:cNvPr>
-          <p:cNvSpPr>
-            <a:spLocks noGrp="1"/>
-          </p:cNvSpPr>
-          <p:nvPr>
-            <p:ph type="title"/>
-          </p:nvPr>
-        </p:nvSpPr>
-        <p:spPr/>
-        <p:txBody>
-          <a:bodyPr/>
-          <a:lstStyle/>
-          <a:p>
-            <a:r>
-              <a:rPr lang="en-US" dirty="0"/>
-              <a:t>Developer Notes</a:t>
-            </a:r>
-          </a:p>
-        </p:txBody>
-      </p:sp>
-      <p:sp>
-        <p:nvSpPr>
-          <p:cNvPr id="3" name="Content Placeholder 2">
-            <a:extLst>
-              <a:ext uri="{FF2B5EF4-FFF2-40B4-BE49-F238E27FC236}">
-                <a16:creationId xmlns:a16="http://schemas.microsoft.com/office/drawing/2014/main" id="{D276B888-82BA-0A56-7C73-EA28DEBF8589}"/>
-              </a:ext>
-            </a:extLst>
-          </p:cNvPr>
-          <p:cNvSpPr>
-            <a:spLocks noGrp="1"/>
-          </p:cNvSpPr>
-          <p:nvPr>
-            <p:ph idx="1"/>
-          </p:nvPr>
-        </p:nvSpPr>
-        <p:spPr/>
-        <p:txBody>
-          <a:bodyPr/>
-          <a:lstStyle/>
-          <a:p>
-            <a:endParaRPr lang="en-US" dirty="0"/>
-          </a:p>
-        </p:txBody>
-      </p:sp>
-    </p:spTree>
-    <p:extLst>
-      <p:ext uri="{BB962C8B-B14F-4D97-AF65-F5344CB8AC3E}">
-        <p14:creationId xmlns:p14="http://schemas.microsoft.com/office/powerpoint/2010/main" val="2745004807"/>
-      </p:ext>
-    </p:extLst>
-  </p:cSld>
-  <p:clrMapOvr>
-    <a:masterClrMapping/>
-  </p:clrMapOvr>
-</p:sld>
-</file>
-
-<file path=ppt/slides/slide18.xml><?xml version="1.0" encoding="utf-8"?>
-<p:sld xmlns:a="http://schemas.openxmlformats.org/drawingml/2006/main" xmlns:r="http://schemas.openxmlformats.org/officeDocument/2006/relationships" xmlns:p="http://schemas.openxmlformats.org/presentationml/2006/main">
-  <p:cSld>
-    <p:spTree>
-      <p:nvGrpSpPr>
-        <p:cNvPr id="1" name="">
-          <a:extLst>
-            <a:ext uri="{FF2B5EF4-FFF2-40B4-BE49-F238E27FC236}">
-              <a16:creationId xmlns:a16="http://schemas.microsoft.com/office/drawing/2014/main" id="{1F574AB5-8927-6407-4843-86E7067B70BC}"/>
-            </a:ext>
-          </a:extLst>
-        </p:cNvPr>
-        <p:cNvGrpSpPr/>
-        <p:nvPr/>
-      </p:nvGrpSpPr>
-      <p:grpSpPr>
-        <a:xfrm>
-          <a:off x="0" y="0"/>
-          <a:ext cx="0" cy="0"/>
-          <a:chOff x="0" y="0"/>
-          <a:chExt cx="0" cy="0"/>
-        </a:xfrm>
-      </p:grpSpPr>
-      <p:sp>
-        <p:nvSpPr>
-          <p:cNvPr id="2" name="Title 1">
-            <a:extLst>
-              <a:ext uri="{FF2B5EF4-FFF2-40B4-BE49-F238E27FC236}">
-                <a16:creationId xmlns:a16="http://schemas.microsoft.com/office/drawing/2014/main" id="{E0E0C3D2-95B6-BA3D-1CD6-628D1FADD14F}"/>
-              </a:ext>
-            </a:extLst>
-          </p:cNvPr>
-          <p:cNvSpPr>
-            <a:spLocks noGrp="1"/>
-          </p:cNvSpPr>
-          <p:nvPr>
-            <p:ph type="title"/>
-          </p:nvPr>
-        </p:nvSpPr>
-        <p:spPr>
-          <a:xfrm>
-            <a:off x="4216021" y="2473704"/>
-            <a:ext cx="4805149" cy="1325563"/>
-          </a:xfrm>
-        </p:spPr>
-        <p:txBody>
-          <a:bodyPr/>
-          <a:lstStyle/>
-          <a:p>
-            <a:r>
-              <a:rPr lang="en-US" dirty="0"/>
-              <a:t>C++ Structure</a:t>
-            </a:r>
-          </a:p>
-        </p:txBody>
-      </p:sp>
-    </p:spTree>
-    <p:extLst>
-      <p:ext uri="{BB962C8B-B14F-4D97-AF65-F5344CB8AC3E}">
-        <p14:creationId xmlns:p14="http://schemas.microsoft.com/office/powerpoint/2010/main" val="1321306593"/>
-      </p:ext>
-    </p:extLst>
-  </p:cSld>
-  <p:clrMapOvr>
-    <a:masterClrMapping/>
-  </p:clrMapOvr>
-</p:sld>
-</file>
-
-<file path=ppt/slides/slide19.xml><?xml version="1.0" encoding="utf-8"?>
-<p:sld xmlns:a="http://schemas.openxmlformats.org/drawingml/2006/main" xmlns:r="http://schemas.openxmlformats.org/officeDocument/2006/relationships" xmlns:p="http://schemas.openxmlformats.org/presentationml/2006/main">
-  <p:cSld>
-    <p:spTree>
-      <p:nvGrpSpPr>
-        <p:cNvPr id="1" name="">
-          <a:extLst>
-            <a:ext uri="{FF2B5EF4-FFF2-40B4-BE49-F238E27FC236}">
-              <a16:creationId xmlns:a16="http://schemas.microsoft.com/office/drawing/2014/main" id="{5D1355F9-A3F1-EA34-AC4A-DEA240A71283}"/>
-            </a:ext>
-          </a:extLst>
-        </p:cNvPr>
-        <p:cNvGrpSpPr/>
-        <p:nvPr/>
-      </p:nvGrpSpPr>
-      <p:grpSpPr>
-        <a:xfrm>
-          <a:off x="0" y="0"/>
-          <a:ext cx="0" cy="0"/>
-          <a:chOff x="0" y="0"/>
-          <a:chExt cx="0" cy="0"/>
-        </a:xfrm>
-      </p:grpSpPr>
-      <p:sp>
-        <p:nvSpPr>
-          <p:cNvPr id="2" name="Title 1">
-            <a:extLst>
-              <a:ext uri="{FF2B5EF4-FFF2-40B4-BE49-F238E27FC236}">
-                <a16:creationId xmlns:a16="http://schemas.microsoft.com/office/drawing/2014/main" id="{6CA8248B-3F51-B58F-DBC9-0A845F22D6B9}"/>
-              </a:ext>
-            </a:extLst>
-          </p:cNvPr>
-          <p:cNvSpPr>
-            <a:spLocks noGrp="1"/>
-          </p:cNvSpPr>
-          <p:nvPr>
-            <p:ph type="title"/>
-          </p:nvPr>
-        </p:nvSpPr>
-        <p:spPr/>
-        <p:txBody>
-          <a:bodyPr/>
-          <a:lstStyle/>
-          <a:p>
-            <a:r>
-              <a:rPr lang="en-US" dirty="0"/>
-              <a:t>Feature Description</a:t>
-            </a:r>
-          </a:p>
-        </p:txBody>
-      </p:sp>
-      <p:sp>
-        <p:nvSpPr>
-          <p:cNvPr id="3" name="Content Placeholder 2">
-            <a:extLst>
-              <a:ext uri="{FF2B5EF4-FFF2-40B4-BE49-F238E27FC236}">
-                <a16:creationId xmlns:a16="http://schemas.microsoft.com/office/drawing/2014/main" id="{2943CE73-65EA-5E35-086A-D1D1A65E87D2}"/>
-              </a:ext>
-            </a:extLst>
-          </p:cNvPr>
-          <p:cNvSpPr>
-            <a:spLocks noGrp="1"/>
-          </p:cNvSpPr>
-          <p:nvPr>
-            <p:ph idx="1"/>
-          </p:nvPr>
-        </p:nvSpPr>
-        <p:spPr/>
-        <p:txBody>
-          <a:bodyPr/>
-          <a:lstStyle/>
-          <a:p>
-            <a:endParaRPr lang="en-US" dirty="0"/>
-          </a:p>
-        </p:txBody>
-      </p:sp>
-    </p:spTree>
-    <p:extLst>
-      <p:ext uri="{BB962C8B-B14F-4D97-AF65-F5344CB8AC3E}">
-        <p14:creationId xmlns:p14="http://schemas.microsoft.com/office/powerpoint/2010/main" val="1907109724"/>
       </p:ext>
     </p:extLst>
   </p:cSld>
@@ -4738,6 +4849,253 @@
         <p:cNvPr id="1" name="">
           <a:extLst>
             <a:ext uri="{FF2B5EF4-FFF2-40B4-BE49-F238E27FC236}">
+              <a16:creationId xmlns:a16="http://schemas.microsoft.com/office/drawing/2014/main" id="{F843A5F4-DF64-F696-21A9-BF70F464230F}"/>
+            </a:ext>
+          </a:extLst>
+        </p:cNvPr>
+        <p:cNvGrpSpPr/>
+        <p:nvPr/>
+      </p:nvGrpSpPr>
+      <p:grpSpPr>
+        <a:xfrm>
+          <a:off x="0" y="0"/>
+          <a:ext cx="0" cy="0"/>
+          <a:chOff x="0" y="0"/>
+          <a:chExt cx="0" cy="0"/>
+        </a:xfrm>
+      </p:grpSpPr>
+      <p:sp>
+        <p:nvSpPr>
+          <p:cNvPr id="2" name="Title 1">
+            <a:extLst>
+              <a:ext uri="{FF2B5EF4-FFF2-40B4-BE49-F238E27FC236}">
+                <a16:creationId xmlns:a16="http://schemas.microsoft.com/office/drawing/2014/main" id="{1FDCEB75-C879-DA8C-4012-BCC72FBA4A57}"/>
+              </a:ext>
+            </a:extLst>
+          </p:cNvPr>
+          <p:cNvSpPr>
+            <a:spLocks noGrp="1"/>
+          </p:cNvSpPr>
+          <p:nvPr>
+            <p:ph type="title"/>
+          </p:nvPr>
+        </p:nvSpPr>
+        <p:spPr/>
+        <p:txBody>
+          <a:bodyPr/>
+          <a:lstStyle/>
+          <a:p>
+            <a:r>
+              <a:rPr lang="en-US" dirty="0"/>
+              <a:t>Developer Notes</a:t>
+            </a:r>
+          </a:p>
+        </p:txBody>
+      </p:sp>
+      <p:sp>
+        <p:nvSpPr>
+          <p:cNvPr id="3" name="Content Placeholder 2">
+            <a:extLst>
+              <a:ext uri="{FF2B5EF4-FFF2-40B4-BE49-F238E27FC236}">
+                <a16:creationId xmlns:a16="http://schemas.microsoft.com/office/drawing/2014/main" id="{D276B888-82BA-0A56-7C73-EA28DEBF8589}"/>
+              </a:ext>
+            </a:extLst>
+          </p:cNvPr>
+          <p:cNvSpPr>
+            <a:spLocks noGrp="1"/>
+          </p:cNvSpPr>
+          <p:nvPr>
+            <p:ph idx="1"/>
+          </p:nvPr>
+        </p:nvSpPr>
+        <p:spPr/>
+        <p:txBody>
+          <a:bodyPr/>
+          <a:lstStyle/>
+          <a:p>
+            <a:endParaRPr lang="en-US" dirty="0"/>
+          </a:p>
+        </p:txBody>
+      </p:sp>
+    </p:spTree>
+    <p:extLst>
+      <p:ext uri="{BB962C8B-B14F-4D97-AF65-F5344CB8AC3E}">
+        <p14:creationId xmlns:p14="http://schemas.microsoft.com/office/powerpoint/2010/main" val="2745004807"/>
+      </p:ext>
+    </p:extLst>
+  </p:cSld>
+  <p:clrMapOvr>
+    <a:masterClrMapping/>
+  </p:clrMapOvr>
+</p:sld>
+</file>
+
+<file path=ppt/slides/slide21.xml><?xml version="1.0" encoding="utf-8"?>
+<p:sld xmlns:a="http://schemas.openxmlformats.org/drawingml/2006/main" xmlns:r="http://schemas.openxmlformats.org/officeDocument/2006/relationships" xmlns:p="http://schemas.openxmlformats.org/presentationml/2006/main">
+  <p:cSld>
+    <p:spTree>
+      <p:nvGrpSpPr>
+        <p:cNvPr id="1" name="">
+          <a:extLst>
+            <a:ext uri="{FF2B5EF4-FFF2-40B4-BE49-F238E27FC236}">
+              <a16:creationId xmlns:a16="http://schemas.microsoft.com/office/drawing/2014/main" id="{1F574AB5-8927-6407-4843-86E7067B70BC}"/>
+            </a:ext>
+          </a:extLst>
+        </p:cNvPr>
+        <p:cNvGrpSpPr/>
+        <p:nvPr/>
+      </p:nvGrpSpPr>
+      <p:grpSpPr>
+        <a:xfrm>
+          <a:off x="0" y="0"/>
+          <a:ext cx="0" cy="0"/>
+          <a:chOff x="0" y="0"/>
+          <a:chExt cx="0" cy="0"/>
+        </a:xfrm>
+      </p:grpSpPr>
+      <p:sp>
+        <p:nvSpPr>
+          <p:cNvPr id="2" name="Title 1">
+            <a:extLst>
+              <a:ext uri="{FF2B5EF4-FFF2-40B4-BE49-F238E27FC236}">
+                <a16:creationId xmlns:a16="http://schemas.microsoft.com/office/drawing/2014/main" id="{E0E0C3D2-95B6-BA3D-1CD6-628D1FADD14F}"/>
+              </a:ext>
+            </a:extLst>
+          </p:cNvPr>
+          <p:cNvSpPr>
+            <a:spLocks noGrp="1"/>
+          </p:cNvSpPr>
+          <p:nvPr>
+            <p:ph type="title"/>
+          </p:nvPr>
+        </p:nvSpPr>
+        <p:spPr>
+          <a:xfrm>
+            <a:off x="4216021" y="2473704"/>
+            <a:ext cx="4805149" cy="1325563"/>
+          </a:xfrm>
+        </p:spPr>
+        <p:txBody>
+          <a:bodyPr/>
+          <a:lstStyle/>
+          <a:p>
+            <a:r>
+              <a:rPr lang="en-US" dirty="0"/>
+              <a:t>C++ Structure</a:t>
+            </a:r>
+          </a:p>
+        </p:txBody>
+      </p:sp>
+    </p:spTree>
+    <p:extLst>
+      <p:ext uri="{BB962C8B-B14F-4D97-AF65-F5344CB8AC3E}">
+        <p14:creationId xmlns:p14="http://schemas.microsoft.com/office/powerpoint/2010/main" val="1321306593"/>
+      </p:ext>
+    </p:extLst>
+  </p:cSld>
+  <p:clrMapOvr>
+    <a:masterClrMapping/>
+  </p:clrMapOvr>
+</p:sld>
+</file>
+
+<file path=ppt/slides/slide22.xml><?xml version="1.0" encoding="utf-8"?>
+<p:sld xmlns:a="http://schemas.openxmlformats.org/drawingml/2006/main" xmlns:r="http://schemas.openxmlformats.org/officeDocument/2006/relationships" xmlns:p="http://schemas.openxmlformats.org/presentationml/2006/main">
+  <p:cSld>
+    <p:spTree>
+      <p:nvGrpSpPr>
+        <p:cNvPr id="1" name="">
+          <a:extLst>
+            <a:ext uri="{FF2B5EF4-FFF2-40B4-BE49-F238E27FC236}">
+              <a16:creationId xmlns:a16="http://schemas.microsoft.com/office/drawing/2014/main" id="{5D1355F9-A3F1-EA34-AC4A-DEA240A71283}"/>
+            </a:ext>
+          </a:extLst>
+        </p:cNvPr>
+        <p:cNvGrpSpPr/>
+        <p:nvPr/>
+      </p:nvGrpSpPr>
+      <p:grpSpPr>
+        <a:xfrm>
+          <a:off x="0" y="0"/>
+          <a:ext cx="0" cy="0"/>
+          <a:chOff x="0" y="0"/>
+          <a:chExt cx="0" cy="0"/>
+        </a:xfrm>
+      </p:grpSpPr>
+      <p:sp>
+        <p:nvSpPr>
+          <p:cNvPr id="2" name="Title 1">
+            <a:extLst>
+              <a:ext uri="{FF2B5EF4-FFF2-40B4-BE49-F238E27FC236}">
+                <a16:creationId xmlns:a16="http://schemas.microsoft.com/office/drawing/2014/main" id="{6CA8248B-3F51-B58F-DBC9-0A845F22D6B9}"/>
+              </a:ext>
+            </a:extLst>
+          </p:cNvPr>
+          <p:cNvSpPr>
+            <a:spLocks noGrp="1"/>
+          </p:cNvSpPr>
+          <p:nvPr>
+            <p:ph type="title"/>
+          </p:nvPr>
+        </p:nvSpPr>
+        <p:spPr/>
+        <p:txBody>
+          <a:bodyPr/>
+          <a:lstStyle/>
+          <a:p>
+            <a:r>
+              <a:rPr lang="en-US" dirty="0"/>
+              <a:t>Feature Description</a:t>
+            </a:r>
+          </a:p>
+        </p:txBody>
+      </p:sp>
+      <p:sp>
+        <p:nvSpPr>
+          <p:cNvPr id="3" name="Content Placeholder 2">
+            <a:extLst>
+              <a:ext uri="{FF2B5EF4-FFF2-40B4-BE49-F238E27FC236}">
+                <a16:creationId xmlns:a16="http://schemas.microsoft.com/office/drawing/2014/main" id="{2943CE73-65EA-5E35-086A-D1D1A65E87D2}"/>
+              </a:ext>
+            </a:extLst>
+          </p:cNvPr>
+          <p:cNvSpPr>
+            <a:spLocks noGrp="1"/>
+          </p:cNvSpPr>
+          <p:nvPr>
+            <p:ph idx="1"/>
+          </p:nvPr>
+        </p:nvSpPr>
+        <p:spPr/>
+        <p:txBody>
+          <a:bodyPr/>
+          <a:lstStyle/>
+          <a:p>
+            <a:endParaRPr lang="en-US" dirty="0"/>
+          </a:p>
+        </p:txBody>
+      </p:sp>
+    </p:spTree>
+    <p:extLst>
+      <p:ext uri="{BB962C8B-B14F-4D97-AF65-F5344CB8AC3E}">
+        <p14:creationId xmlns:p14="http://schemas.microsoft.com/office/powerpoint/2010/main" val="1907109724"/>
+      </p:ext>
+    </p:extLst>
+  </p:cSld>
+  <p:clrMapOvr>
+    <a:masterClrMapping/>
+  </p:clrMapOvr>
+</p:sld>
+</file>
+
+<file path=ppt/slides/slide23.xml><?xml version="1.0" encoding="utf-8"?>
+<p:sld xmlns:a="http://schemas.openxmlformats.org/drawingml/2006/main" xmlns:r="http://schemas.openxmlformats.org/officeDocument/2006/relationships" xmlns:p="http://schemas.openxmlformats.org/presentationml/2006/main">
+  <p:cSld>
+    <p:spTree>
+      <p:nvGrpSpPr>
+        <p:cNvPr id="1" name="">
+          <a:extLst>
+            <a:ext uri="{FF2B5EF4-FFF2-40B4-BE49-F238E27FC236}">
               <a16:creationId xmlns:a16="http://schemas.microsoft.com/office/drawing/2014/main" id="{7181E654-3B5C-5EE3-5500-207BC84F7F4E}"/>
             </a:ext>
           </a:extLst>
@@ -4855,318 +5213,6 @@
     <p:extLst>
       <p:ext uri="{BB962C8B-B14F-4D97-AF65-F5344CB8AC3E}">
         <p14:creationId xmlns:p14="http://schemas.microsoft.com/office/powerpoint/2010/main" val="2306170173"/>
-      </p:ext>
-    </p:extLst>
-  </p:cSld>
-  <p:clrMapOvr>
-    <a:masterClrMapping/>
-  </p:clrMapOvr>
-</p:sld>
-</file>
-
-<file path=ppt/slides/slide21.xml><?xml version="1.0" encoding="utf-8"?>
-<p:sld xmlns:a="http://schemas.openxmlformats.org/drawingml/2006/main" xmlns:r="http://schemas.openxmlformats.org/officeDocument/2006/relationships" xmlns:p="http://schemas.openxmlformats.org/presentationml/2006/main">
-  <p:cSld>
-    <p:spTree>
-      <p:nvGrpSpPr>
-        <p:cNvPr id="1" name=""/>
-        <p:cNvGrpSpPr/>
-        <p:nvPr/>
-      </p:nvGrpSpPr>
-      <p:grpSpPr>
-        <a:xfrm>
-          <a:off x="0" y="0"/>
-          <a:ext cx="0" cy="0"/>
-          <a:chOff x="0" y="0"/>
-          <a:chExt cx="0" cy="0"/>
-        </a:xfrm>
-      </p:grpSpPr>
-      <p:sp>
-        <p:nvSpPr>
-          <p:cNvPr id="2" name="Title 1">
-            <a:extLst>
-              <a:ext uri="{FF2B5EF4-FFF2-40B4-BE49-F238E27FC236}">
-                <a16:creationId xmlns:a16="http://schemas.microsoft.com/office/drawing/2014/main" id="{F893E47E-0152-DBA2-F5C6-81C9CDF39D31}"/>
-              </a:ext>
-            </a:extLst>
-          </p:cNvPr>
-          <p:cNvSpPr>
-            <a:spLocks noGrp="1"/>
-          </p:cNvSpPr>
-          <p:nvPr>
-            <p:ph type="title"/>
-          </p:nvPr>
-        </p:nvSpPr>
-        <p:spPr>
-          <a:xfrm>
-            <a:off x="838200" y="2535119"/>
-            <a:ext cx="10515600" cy="1325563"/>
-          </a:xfrm>
-        </p:spPr>
-        <p:txBody>
-          <a:bodyPr/>
-          <a:lstStyle/>
-          <a:p>
-            <a:pPr algn="ctr"/>
-            <a:r>
-              <a:rPr lang="en-US" dirty="0"/>
-              <a:t>Problems Overcome</a:t>
-            </a:r>
-          </a:p>
-        </p:txBody>
-      </p:sp>
-    </p:spTree>
-    <p:extLst>
-      <p:ext uri="{BB962C8B-B14F-4D97-AF65-F5344CB8AC3E}">
-        <p14:creationId xmlns:p14="http://schemas.microsoft.com/office/powerpoint/2010/main" val="2641203556"/>
-      </p:ext>
-    </p:extLst>
-  </p:cSld>
-  <p:clrMapOvr>
-    <a:masterClrMapping/>
-  </p:clrMapOvr>
-</p:sld>
-</file>
-
-<file path=ppt/slides/slide22.xml><?xml version="1.0" encoding="utf-8"?>
-<p:sld xmlns:a="http://schemas.openxmlformats.org/drawingml/2006/main" xmlns:r="http://schemas.openxmlformats.org/officeDocument/2006/relationships" xmlns:p="http://schemas.openxmlformats.org/presentationml/2006/main">
-  <p:cSld>
-    <p:spTree>
-      <p:nvGrpSpPr>
-        <p:cNvPr id="1" name=""/>
-        <p:cNvGrpSpPr/>
-        <p:nvPr/>
-      </p:nvGrpSpPr>
-      <p:grpSpPr>
-        <a:xfrm>
-          <a:off x="0" y="0"/>
-          <a:ext cx="0" cy="0"/>
-          <a:chOff x="0" y="0"/>
-          <a:chExt cx="0" cy="0"/>
-        </a:xfrm>
-      </p:grpSpPr>
-      <p:sp>
-        <p:nvSpPr>
-          <p:cNvPr id="2" name="Title 1">
-            <a:extLst>
-              <a:ext uri="{FF2B5EF4-FFF2-40B4-BE49-F238E27FC236}">
-                <a16:creationId xmlns:a16="http://schemas.microsoft.com/office/drawing/2014/main" id="{B8475666-74FD-6490-7B22-B1FC1E75E04E}"/>
-              </a:ext>
-            </a:extLst>
-          </p:cNvPr>
-          <p:cNvSpPr>
-            <a:spLocks noGrp="1"/>
-          </p:cNvSpPr>
-          <p:nvPr>
-            <p:ph type="title"/>
-          </p:nvPr>
-        </p:nvSpPr>
-        <p:spPr/>
-        <p:txBody>
-          <a:bodyPr/>
-          <a:lstStyle/>
-          <a:p>
-            <a:r>
-              <a:rPr lang="en-US" dirty="0"/>
-              <a:t>Earth Occlusion of LOS</a:t>
-            </a:r>
-          </a:p>
-        </p:txBody>
-      </p:sp>
-      <p:sp>
-        <p:nvSpPr>
-          <p:cNvPr id="3" name="Content Placeholder 2">
-            <a:extLst>
-              <a:ext uri="{FF2B5EF4-FFF2-40B4-BE49-F238E27FC236}">
-                <a16:creationId xmlns:a16="http://schemas.microsoft.com/office/drawing/2014/main" id="{AD609CE9-6468-D8EE-A7B7-4ADA8A032E0F}"/>
-              </a:ext>
-            </a:extLst>
-          </p:cNvPr>
-          <p:cNvSpPr>
-            <a:spLocks noGrp="1"/>
-          </p:cNvSpPr>
-          <p:nvPr>
-            <p:ph idx="1"/>
-          </p:nvPr>
-        </p:nvSpPr>
-        <p:spPr/>
-        <p:txBody>
-          <a:bodyPr>
-            <a:normAutofit/>
-          </a:bodyPr>
-          <a:lstStyle/>
-          <a:p>
-            <a:r>
-              <a:rPr lang="en-US" sz="1800" dirty="0"/>
-              <a:t>How do I calculate whether or not 2 bodies (points) have LOS or are occluded by the earth using </a:t>
-            </a:r>
-            <a:r>
-              <a:rPr lang="en-US" sz="1800" dirty="0" err="1"/>
-              <a:t>lin</a:t>
-            </a:r>
-            <a:r>
-              <a:rPr lang="en-US" sz="1800" dirty="0"/>
-              <a:t> </a:t>
-            </a:r>
-            <a:r>
-              <a:rPr lang="en-US" sz="1800" dirty="0" err="1"/>
-              <a:t>alg</a:t>
-            </a:r>
-            <a:r>
-              <a:rPr lang="en-US" sz="1800" dirty="0"/>
-              <a:t>?</a:t>
-            </a:r>
-          </a:p>
-          <a:p>
-            <a:r>
-              <a:rPr lang="en-US" sz="1800" dirty="0"/>
-              <a:t>Pointing Vector is d =  B-A  </a:t>
-            </a:r>
-          </a:p>
-          <a:p>
-            <a:r>
-              <a:rPr lang="en-US" sz="1800" dirty="0"/>
-              <a:t>Treat vector pointing A to B is D(t) = ||A + td||</a:t>
-            </a:r>
-          </a:p>
-          <a:p>
-            <a:r>
-              <a:rPr lang="en-US" sz="1800" dirty="0"/>
-              <a:t>Minimizing the square has simpler math properties, would have to use chain rule without square</a:t>
-            </a:r>
-          </a:p>
-          <a:p>
-            <a:r>
-              <a:rPr lang="en-US" sz="1800" dirty="0"/>
-              <a:t>D^2(t)= A dot A + 2t (A dot d) + t^2 (d dot d)  Squaring norm is same as dotting norm with self</a:t>
-            </a:r>
-          </a:p>
-          <a:p>
-            <a:r>
-              <a:rPr lang="en-US" sz="1800" dirty="0"/>
-              <a:t>d/dt D^2’(t) = 2t (d dot d) + 2 (A dot d)</a:t>
-            </a:r>
-          </a:p>
-          <a:p>
-            <a:r>
-              <a:rPr lang="en-US" sz="1800" dirty="0"/>
-              <a:t>0 = 2t (d dot d) + 2 (A dot d)</a:t>
-            </a:r>
-          </a:p>
-          <a:p>
-            <a:r>
-              <a:rPr lang="en-US" sz="1800" dirty="0"/>
-              <a:t>-(A dot d)= t(d dot d)    Can do division because dot products are scalar output</a:t>
-            </a:r>
-          </a:p>
-          <a:p>
-            <a:r>
-              <a:rPr lang="en-US" sz="1800" dirty="0"/>
-              <a:t>t = - (A dot d) / ||d||^2       d dot d is a norm squared</a:t>
-            </a:r>
-          </a:p>
-          <a:p>
-            <a:r>
-              <a:rPr lang="en-US" sz="1800" dirty="0"/>
-              <a:t>Can then calculate that point and if its norm is &lt; radius of </a:t>
-            </a:r>
-            <a:r>
-              <a:rPr lang="en-US" sz="1800"/>
-              <a:t>earth then no LOS</a:t>
-            </a:r>
-            <a:endParaRPr lang="en-US" sz="1800" dirty="0"/>
-          </a:p>
-          <a:p>
-            <a:endParaRPr lang="en-US" sz="1800" dirty="0"/>
-          </a:p>
-          <a:p>
-            <a:endParaRPr lang="en-US" sz="1800" dirty="0"/>
-          </a:p>
-          <a:p>
-            <a:endParaRPr lang="en-US" sz="1800" dirty="0"/>
-          </a:p>
-          <a:p>
-            <a:endParaRPr lang="en-US" sz="1800" dirty="0"/>
-          </a:p>
-          <a:p>
-            <a:endParaRPr lang="en-US" sz="1800" dirty="0"/>
-          </a:p>
-          <a:p>
-            <a:endParaRPr lang="en-US" sz="1800" dirty="0"/>
-          </a:p>
-        </p:txBody>
-      </p:sp>
-    </p:spTree>
-    <p:extLst>
-      <p:ext uri="{BB962C8B-B14F-4D97-AF65-F5344CB8AC3E}">
-        <p14:creationId xmlns:p14="http://schemas.microsoft.com/office/powerpoint/2010/main" val="4060347343"/>
-      </p:ext>
-    </p:extLst>
-  </p:cSld>
-  <p:clrMapOvr>
-    <a:masterClrMapping/>
-  </p:clrMapOvr>
-</p:sld>
-</file>
-
-<file path=ppt/slides/slide23.xml><?xml version="1.0" encoding="utf-8"?>
-<p:sld xmlns:a="http://schemas.openxmlformats.org/drawingml/2006/main" xmlns:r="http://schemas.openxmlformats.org/officeDocument/2006/relationships" xmlns:p="http://schemas.openxmlformats.org/presentationml/2006/main">
-  <p:cSld>
-    <p:spTree>
-      <p:nvGrpSpPr>
-        <p:cNvPr id="1" name=""/>
-        <p:cNvGrpSpPr/>
-        <p:nvPr/>
-      </p:nvGrpSpPr>
-      <p:grpSpPr>
-        <a:xfrm>
-          <a:off x="0" y="0"/>
-          <a:ext cx="0" cy="0"/>
-          <a:chOff x="0" y="0"/>
-          <a:chExt cx="0" cy="0"/>
-        </a:xfrm>
-      </p:grpSpPr>
-      <p:sp>
-        <p:nvSpPr>
-          <p:cNvPr id="2" name="Title 1">
-            <a:extLst>
-              <a:ext uri="{FF2B5EF4-FFF2-40B4-BE49-F238E27FC236}">
-                <a16:creationId xmlns:a16="http://schemas.microsoft.com/office/drawing/2014/main" id="{2BD7E637-0A0C-B2FC-AE0E-35E5AF1998A5}"/>
-              </a:ext>
-            </a:extLst>
-          </p:cNvPr>
-          <p:cNvSpPr>
-            <a:spLocks noGrp="1"/>
-          </p:cNvSpPr>
-          <p:nvPr>
-            <p:ph type="title"/>
-          </p:nvPr>
-        </p:nvSpPr>
-        <p:spPr>
-          <a:xfrm>
-            <a:off x="4352499" y="2705716"/>
-            <a:ext cx="4882941" cy="1325563"/>
-          </a:xfrm>
-        </p:spPr>
-        <p:txBody>
-          <a:bodyPr/>
-          <a:lstStyle/>
-          <a:p>
-            <a:r>
-              <a:rPr lang="en-US" dirty="0" err="1"/>
-              <a:t>Misc</a:t>
-            </a:r>
-            <a:r>
-              <a:rPr lang="en-US" dirty="0"/>
-              <a:t> Loose Ends</a:t>
-            </a:r>
-          </a:p>
-        </p:txBody>
-      </p:sp>
-    </p:spTree>
-    <p:extLst>
-      <p:ext uri="{BB962C8B-B14F-4D97-AF65-F5344CB8AC3E}">
-        <p14:creationId xmlns:p14="http://schemas.microsoft.com/office/powerpoint/2010/main" val="1216898861"/>
       </p:ext>
     </p:extLst>
   </p:cSld>
@@ -5198,7 +5244,7 @@
           <p:cNvPr id="2" name="Title 1">
             <a:extLst>
               <a:ext uri="{FF2B5EF4-FFF2-40B4-BE49-F238E27FC236}">
-                <a16:creationId xmlns:a16="http://schemas.microsoft.com/office/drawing/2014/main" id="{269FB068-6AD7-6770-B2A7-107A9F4366FC}"/>
+                <a16:creationId xmlns:a16="http://schemas.microsoft.com/office/drawing/2014/main" id="{F893E47E-0152-DBA2-F5C6-81C9CDF39D31}"/>
               </a:ext>
             </a:extLst>
           </p:cNvPr>
@@ -5209,62 +5255,28 @@
             <p:ph type="title"/>
           </p:nvPr>
         </p:nvSpPr>
-        <p:spPr/>
-        <p:txBody>
-          <a:bodyPr/>
-          <a:lstStyle/>
-          <a:p>
+        <p:spPr>
+          <a:xfrm>
+            <a:off x="838200" y="2535119"/>
+            <a:ext cx="10515600" cy="1325563"/>
+          </a:xfrm>
+        </p:spPr>
+        <p:txBody>
+          <a:bodyPr/>
+          <a:lstStyle/>
+          <a:p>
+            <a:pPr algn="ctr"/>
             <a:r>
               <a:rPr lang="en-US" dirty="0"/>
-              <a:t>Coding</a:t>
-            </a:r>
-          </a:p>
-        </p:txBody>
-      </p:sp>
-      <p:sp>
-        <p:nvSpPr>
-          <p:cNvPr id="3" name="Content Placeholder 2">
-            <a:extLst>
-              <a:ext uri="{FF2B5EF4-FFF2-40B4-BE49-F238E27FC236}">
-                <a16:creationId xmlns:a16="http://schemas.microsoft.com/office/drawing/2014/main" id="{857A8299-9CED-A1FE-0C2C-CB75D4FCE0BB}"/>
-              </a:ext>
-            </a:extLst>
-          </p:cNvPr>
-          <p:cNvSpPr>
-            <a:spLocks noGrp="1"/>
-          </p:cNvSpPr>
-          <p:nvPr>
-            <p:ph idx="1"/>
-          </p:nvPr>
-        </p:nvSpPr>
-        <p:spPr/>
-        <p:txBody>
-          <a:bodyPr/>
-          <a:lstStyle/>
-          <a:p>
-            <a:pPr marL="0" indent="0">
-              <a:buNone/>
-            </a:pPr>
-            <a:r>
-              <a:rPr lang="en-US" dirty="0"/>
-              <a:t>Const Expr</a:t>
-            </a:r>
-          </a:p>
-          <a:p>
-            <a:pPr marL="0" indent="0">
-              <a:buNone/>
-            </a:pPr>
-            <a:endParaRPr lang="en-US" dirty="0"/>
-          </a:p>
-          <a:p>
-            <a:endParaRPr lang="en-US" dirty="0"/>
+              <a:t>Problems Overcome</a:t>
+            </a:r>
           </a:p>
         </p:txBody>
       </p:sp>
     </p:spTree>
     <p:extLst>
       <p:ext uri="{BB962C8B-B14F-4D97-AF65-F5344CB8AC3E}">
-        <p14:creationId xmlns:p14="http://schemas.microsoft.com/office/powerpoint/2010/main" val="4128986287"/>
+        <p14:creationId xmlns:p14="http://schemas.microsoft.com/office/powerpoint/2010/main" val="2641203556"/>
       </p:ext>
     </p:extLst>
   </p:cSld>
@@ -5296,6 +5308,347 @@
           <p:cNvPr id="2" name="Title 1">
             <a:extLst>
               <a:ext uri="{FF2B5EF4-FFF2-40B4-BE49-F238E27FC236}">
+                <a16:creationId xmlns:a16="http://schemas.microsoft.com/office/drawing/2014/main" id="{B8475666-74FD-6490-7B22-B1FC1E75E04E}"/>
+              </a:ext>
+            </a:extLst>
+          </p:cNvPr>
+          <p:cNvSpPr>
+            <a:spLocks noGrp="1"/>
+          </p:cNvSpPr>
+          <p:nvPr>
+            <p:ph type="title"/>
+          </p:nvPr>
+        </p:nvSpPr>
+        <p:spPr/>
+        <p:txBody>
+          <a:bodyPr/>
+          <a:lstStyle/>
+          <a:p>
+            <a:r>
+              <a:rPr lang="en-US" dirty="0"/>
+              <a:t>Earth Occlusion of LOS</a:t>
+            </a:r>
+          </a:p>
+        </p:txBody>
+      </p:sp>
+      <p:sp>
+        <p:nvSpPr>
+          <p:cNvPr id="3" name="Content Placeholder 2">
+            <a:extLst>
+              <a:ext uri="{FF2B5EF4-FFF2-40B4-BE49-F238E27FC236}">
+                <a16:creationId xmlns:a16="http://schemas.microsoft.com/office/drawing/2014/main" id="{AD609CE9-6468-D8EE-A7B7-4ADA8A032E0F}"/>
+              </a:ext>
+            </a:extLst>
+          </p:cNvPr>
+          <p:cNvSpPr>
+            <a:spLocks noGrp="1"/>
+          </p:cNvSpPr>
+          <p:nvPr>
+            <p:ph idx="1"/>
+          </p:nvPr>
+        </p:nvSpPr>
+        <p:spPr/>
+        <p:txBody>
+          <a:bodyPr>
+            <a:normAutofit/>
+          </a:bodyPr>
+          <a:lstStyle/>
+          <a:p>
+            <a:r>
+              <a:rPr lang="en-US" sz="1800" dirty="0"/>
+              <a:t>How do I calculate whether or not 2 bodies (points) have LOS or are occluded by the earth using </a:t>
+            </a:r>
+            <a:r>
+              <a:rPr lang="en-US" sz="1800" dirty="0" err="1"/>
+              <a:t>lin</a:t>
+            </a:r>
+            <a:r>
+              <a:rPr lang="en-US" sz="1800" dirty="0"/>
+              <a:t> </a:t>
+            </a:r>
+            <a:r>
+              <a:rPr lang="en-US" sz="1800" dirty="0" err="1"/>
+              <a:t>alg</a:t>
+            </a:r>
+            <a:r>
+              <a:rPr lang="en-US" sz="1800" dirty="0"/>
+              <a:t>?</a:t>
+            </a:r>
+          </a:p>
+          <a:p>
+            <a:r>
+              <a:rPr lang="en-US" sz="1800" dirty="0"/>
+              <a:t>Pointing Vector is d =  B-A  </a:t>
+            </a:r>
+          </a:p>
+          <a:p>
+            <a:r>
+              <a:rPr lang="en-US" sz="1800" dirty="0"/>
+              <a:t>Treat vector pointing A to B is D(t) = ||A + td||</a:t>
+            </a:r>
+          </a:p>
+          <a:p>
+            <a:r>
+              <a:rPr lang="en-US" sz="1800" dirty="0"/>
+              <a:t>Minimizing the square has simpler math properties, would have to use chain rule without square</a:t>
+            </a:r>
+          </a:p>
+          <a:p>
+            <a:r>
+              <a:rPr lang="en-US" sz="1800" dirty="0"/>
+              <a:t>D^2(t)= A dot A + 2t (A dot d) + t^2 (d dot d)  Squaring norm is same as dotting norm with self</a:t>
+            </a:r>
+          </a:p>
+          <a:p>
+            <a:r>
+              <a:rPr lang="en-US" sz="1800" dirty="0"/>
+              <a:t>d/dt D^2’(t) = 2t (d dot d) + 2 (A dot d)</a:t>
+            </a:r>
+          </a:p>
+          <a:p>
+            <a:r>
+              <a:rPr lang="en-US" sz="1800" dirty="0"/>
+              <a:t>0 = 2t (d dot d) + 2 (A dot d)</a:t>
+            </a:r>
+          </a:p>
+          <a:p>
+            <a:r>
+              <a:rPr lang="en-US" sz="1800" dirty="0"/>
+              <a:t>-(A dot d)= t(d dot d)    Can do division because dot products are scalar output</a:t>
+            </a:r>
+          </a:p>
+          <a:p>
+            <a:r>
+              <a:rPr lang="en-US" sz="1800" dirty="0"/>
+              <a:t>t = - (A dot d) / ||d||^2       d dot d is a norm squared</a:t>
+            </a:r>
+          </a:p>
+          <a:p>
+            <a:r>
+              <a:rPr lang="en-US" sz="1800" dirty="0"/>
+              <a:t>Can then calculate that point and if its norm is &lt; radius of earth then no LOS</a:t>
+            </a:r>
+          </a:p>
+          <a:p>
+            <a:endParaRPr lang="en-US" sz="1800" dirty="0"/>
+          </a:p>
+          <a:p>
+            <a:endParaRPr lang="en-US" sz="1800" dirty="0"/>
+          </a:p>
+          <a:p>
+            <a:endParaRPr lang="en-US" sz="1800" dirty="0"/>
+          </a:p>
+          <a:p>
+            <a:endParaRPr lang="en-US" sz="1800" dirty="0"/>
+          </a:p>
+          <a:p>
+            <a:endParaRPr lang="en-US" sz="1800" dirty="0"/>
+          </a:p>
+          <a:p>
+            <a:endParaRPr lang="en-US" sz="1800" dirty="0"/>
+          </a:p>
+        </p:txBody>
+      </p:sp>
+    </p:spTree>
+    <p:extLst>
+      <p:ext uri="{BB962C8B-B14F-4D97-AF65-F5344CB8AC3E}">
+        <p14:creationId xmlns:p14="http://schemas.microsoft.com/office/powerpoint/2010/main" val="4060347343"/>
+      </p:ext>
+    </p:extLst>
+  </p:cSld>
+  <p:clrMapOvr>
+    <a:masterClrMapping/>
+  </p:clrMapOvr>
+</p:sld>
+</file>
+
+<file path=ppt/slides/slide26.xml><?xml version="1.0" encoding="utf-8"?>
+<p:sld xmlns:a="http://schemas.openxmlformats.org/drawingml/2006/main" xmlns:r="http://schemas.openxmlformats.org/officeDocument/2006/relationships" xmlns:p="http://schemas.openxmlformats.org/presentationml/2006/main">
+  <p:cSld>
+    <p:spTree>
+      <p:nvGrpSpPr>
+        <p:cNvPr id="1" name=""/>
+        <p:cNvGrpSpPr/>
+        <p:nvPr/>
+      </p:nvGrpSpPr>
+      <p:grpSpPr>
+        <a:xfrm>
+          <a:off x="0" y="0"/>
+          <a:ext cx="0" cy="0"/>
+          <a:chOff x="0" y="0"/>
+          <a:chExt cx="0" cy="0"/>
+        </a:xfrm>
+      </p:grpSpPr>
+      <p:sp>
+        <p:nvSpPr>
+          <p:cNvPr id="2" name="Title 1">
+            <a:extLst>
+              <a:ext uri="{FF2B5EF4-FFF2-40B4-BE49-F238E27FC236}">
+                <a16:creationId xmlns:a16="http://schemas.microsoft.com/office/drawing/2014/main" id="{2BD7E637-0A0C-B2FC-AE0E-35E5AF1998A5}"/>
+              </a:ext>
+            </a:extLst>
+          </p:cNvPr>
+          <p:cNvSpPr>
+            <a:spLocks noGrp="1"/>
+          </p:cNvSpPr>
+          <p:nvPr>
+            <p:ph type="title"/>
+          </p:nvPr>
+        </p:nvSpPr>
+        <p:spPr>
+          <a:xfrm>
+            <a:off x="4352499" y="2705716"/>
+            <a:ext cx="4882941" cy="1325563"/>
+          </a:xfrm>
+        </p:spPr>
+        <p:txBody>
+          <a:bodyPr/>
+          <a:lstStyle/>
+          <a:p>
+            <a:r>
+              <a:rPr lang="en-US" dirty="0" err="1"/>
+              <a:t>Misc</a:t>
+            </a:r>
+            <a:r>
+              <a:rPr lang="en-US" dirty="0"/>
+              <a:t> Loose Ends</a:t>
+            </a:r>
+          </a:p>
+        </p:txBody>
+      </p:sp>
+    </p:spTree>
+    <p:extLst>
+      <p:ext uri="{BB962C8B-B14F-4D97-AF65-F5344CB8AC3E}">
+        <p14:creationId xmlns:p14="http://schemas.microsoft.com/office/powerpoint/2010/main" val="1216898861"/>
+      </p:ext>
+    </p:extLst>
+  </p:cSld>
+  <p:clrMapOvr>
+    <a:masterClrMapping/>
+  </p:clrMapOvr>
+</p:sld>
+</file>
+
+<file path=ppt/slides/slide27.xml><?xml version="1.0" encoding="utf-8"?>
+<p:sld xmlns:a="http://schemas.openxmlformats.org/drawingml/2006/main" xmlns:r="http://schemas.openxmlformats.org/officeDocument/2006/relationships" xmlns:p="http://schemas.openxmlformats.org/presentationml/2006/main">
+  <p:cSld>
+    <p:spTree>
+      <p:nvGrpSpPr>
+        <p:cNvPr id="1" name=""/>
+        <p:cNvGrpSpPr/>
+        <p:nvPr/>
+      </p:nvGrpSpPr>
+      <p:grpSpPr>
+        <a:xfrm>
+          <a:off x="0" y="0"/>
+          <a:ext cx="0" cy="0"/>
+          <a:chOff x="0" y="0"/>
+          <a:chExt cx="0" cy="0"/>
+        </a:xfrm>
+      </p:grpSpPr>
+      <p:sp>
+        <p:nvSpPr>
+          <p:cNvPr id="2" name="Title 1">
+            <a:extLst>
+              <a:ext uri="{FF2B5EF4-FFF2-40B4-BE49-F238E27FC236}">
+                <a16:creationId xmlns:a16="http://schemas.microsoft.com/office/drawing/2014/main" id="{269FB068-6AD7-6770-B2A7-107A9F4366FC}"/>
+              </a:ext>
+            </a:extLst>
+          </p:cNvPr>
+          <p:cNvSpPr>
+            <a:spLocks noGrp="1"/>
+          </p:cNvSpPr>
+          <p:nvPr>
+            <p:ph type="title"/>
+          </p:nvPr>
+        </p:nvSpPr>
+        <p:spPr/>
+        <p:txBody>
+          <a:bodyPr/>
+          <a:lstStyle/>
+          <a:p>
+            <a:r>
+              <a:rPr lang="en-US" dirty="0"/>
+              <a:t>Coding</a:t>
+            </a:r>
+          </a:p>
+        </p:txBody>
+      </p:sp>
+      <p:sp>
+        <p:nvSpPr>
+          <p:cNvPr id="3" name="Content Placeholder 2">
+            <a:extLst>
+              <a:ext uri="{FF2B5EF4-FFF2-40B4-BE49-F238E27FC236}">
+                <a16:creationId xmlns:a16="http://schemas.microsoft.com/office/drawing/2014/main" id="{857A8299-9CED-A1FE-0C2C-CB75D4FCE0BB}"/>
+              </a:ext>
+            </a:extLst>
+          </p:cNvPr>
+          <p:cNvSpPr>
+            <a:spLocks noGrp="1"/>
+          </p:cNvSpPr>
+          <p:nvPr>
+            <p:ph idx="1"/>
+          </p:nvPr>
+        </p:nvSpPr>
+        <p:spPr/>
+        <p:txBody>
+          <a:bodyPr/>
+          <a:lstStyle/>
+          <a:p>
+            <a:pPr marL="0" indent="0">
+              <a:buNone/>
+            </a:pPr>
+            <a:r>
+              <a:rPr lang="en-US" dirty="0"/>
+              <a:t>Const Expr</a:t>
+            </a:r>
+          </a:p>
+          <a:p>
+            <a:pPr marL="0" indent="0">
+              <a:buNone/>
+            </a:pPr>
+            <a:endParaRPr lang="en-US" dirty="0"/>
+          </a:p>
+          <a:p>
+            <a:endParaRPr lang="en-US" dirty="0"/>
+          </a:p>
+        </p:txBody>
+      </p:sp>
+    </p:spTree>
+    <p:extLst>
+      <p:ext uri="{BB962C8B-B14F-4D97-AF65-F5344CB8AC3E}">
+        <p14:creationId xmlns:p14="http://schemas.microsoft.com/office/powerpoint/2010/main" val="4128986287"/>
+      </p:ext>
+    </p:extLst>
+  </p:cSld>
+  <p:clrMapOvr>
+    <a:masterClrMapping/>
+  </p:clrMapOvr>
+</p:sld>
+</file>
+
+<file path=ppt/slides/slide28.xml><?xml version="1.0" encoding="utf-8"?>
+<p:sld xmlns:a="http://schemas.openxmlformats.org/drawingml/2006/main" xmlns:r="http://schemas.openxmlformats.org/officeDocument/2006/relationships" xmlns:p="http://schemas.openxmlformats.org/presentationml/2006/main">
+  <p:cSld>
+    <p:spTree>
+      <p:nvGrpSpPr>
+        <p:cNvPr id="1" name=""/>
+        <p:cNvGrpSpPr/>
+        <p:nvPr/>
+      </p:nvGrpSpPr>
+      <p:grpSpPr>
+        <a:xfrm>
+          <a:off x="0" y="0"/>
+          <a:ext cx="0" cy="0"/>
+          <a:chOff x="0" y="0"/>
+          <a:chExt cx="0" cy="0"/>
+        </a:xfrm>
+      </p:grpSpPr>
+      <p:sp>
+        <p:nvSpPr>
+          <p:cNvPr id="2" name="Title 1">
+            <a:extLst>
+              <a:ext uri="{FF2B5EF4-FFF2-40B4-BE49-F238E27FC236}">
                 <a16:creationId xmlns:a16="http://schemas.microsoft.com/office/drawing/2014/main" id="{18DE167B-A416-AF8F-041B-A98D78C25FB2}"/>
               </a:ext>
             </a:extLst>
@@ -5332,7 +5685,7 @@
 </p:sld>
 </file>
 
-<file path=ppt/slides/slide26.xml><?xml version="1.0" encoding="utf-8"?>
+<file path=ppt/slides/slide29.xml><?xml version="1.0" encoding="utf-8"?>
 <p:sld xmlns:a="http://schemas.openxmlformats.org/drawingml/2006/main" xmlns:r="http://schemas.openxmlformats.org/officeDocument/2006/relationships" xmlns:p="http://schemas.openxmlformats.org/presentationml/2006/main">
   <p:cSld>
     <p:spTree>
@@ -5471,7 +5824,7 @@
           <a:p>
             <a:r>
               <a:rPr lang="en-US" dirty="0"/>
-              <a:t>Coordinate Systems And Transforms</a:t>
+              <a:t>Simulation Architecture</a:t>
             </a:r>
           </a:p>
         </p:txBody>
@@ -5490,6 +5843,384 @@
 </file>
 
 <file path=ppt/slides/slide4.xml><?xml version="1.0" encoding="utf-8"?>
+<p:sld xmlns:a="http://schemas.openxmlformats.org/drawingml/2006/main" xmlns:r="http://schemas.openxmlformats.org/officeDocument/2006/relationships" xmlns:p="http://schemas.openxmlformats.org/presentationml/2006/main">
+  <p:cSld>
+    <p:spTree>
+      <p:nvGrpSpPr>
+        <p:cNvPr id="1" name=""/>
+        <p:cNvGrpSpPr/>
+        <p:nvPr/>
+      </p:nvGrpSpPr>
+      <p:grpSpPr>
+        <a:xfrm>
+          <a:off x="0" y="0"/>
+          <a:ext cx="0" cy="0"/>
+          <a:chOff x="0" y="0"/>
+          <a:chExt cx="0" cy="0"/>
+        </a:xfrm>
+      </p:grpSpPr>
+      <p:sp>
+        <p:nvSpPr>
+          <p:cNvPr id="2" name="Title 1">
+            <a:extLst>
+              <a:ext uri="{FF2B5EF4-FFF2-40B4-BE49-F238E27FC236}">
+                <a16:creationId xmlns:a16="http://schemas.microsoft.com/office/drawing/2014/main" id="{9111801B-6A40-1772-640F-C6E216A3ADC1}"/>
+              </a:ext>
+            </a:extLst>
+          </p:cNvPr>
+          <p:cNvSpPr>
+            <a:spLocks noGrp="1"/>
+          </p:cNvSpPr>
+          <p:nvPr>
+            <p:ph type="title"/>
+          </p:nvPr>
+        </p:nvSpPr>
+        <p:spPr/>
+        <p:txBody>
+          <a:bodyPr/>
+          <a:lstStyle/>
+          <a:p>
+            <a:r>
+              <a:rPr lang="en-US" dirty="0"/>
+              <a:t>Main Sim Loop</a:t>
+            </a:r>
+          </a:p>
+        </p:txBody>
+      </p:sp>
+      <p:sp>
+        <p:nvSpPr>
+          <p:cNvPr id="3" name="Content Placeholder 2">
+            <a:extLst>
+              <a:ext uri="{FF2B5EF4-FFF2-40B4-BE49-F238E27FC236}">
+                <a16:creationId xmlns:a16="http://schemas.microsoft.com/office/drawing/2014/main" id="{9ED41821-5945-F8C7-9445-1A56F43FB387}"/>
+              </a:ext>
+            </a:extLst>
+          </p:cNvPr>
+          <p:cNvSpPr>
+            <a:spLocks noGrp="1"/>
+          </p:cNvSpPr>
+          <p:nvPr>
+            <p:ph idx="1"/>
+          </p:nvPr>
+        </p:nvSpPr>
+        <p:spPr/>
+        <p:txBody>
+          <a:bodyPr>
+            <a:normAutofit/>
+          </a:bodyPr>
+          <a:lstStyle/>
+          <a:p>
+            <a:r>
+              <a:rPr lang="en-US" sz="1400" dirty="0"/>
+              <a:t>Create Entities from scenario saved or from manually changing parameters</a:t>
+            </a:r>
+          </a:p>
+          <a:p>
+            <a:r>
+              <a:rPr lang="en-US" sz="1400" dirty="0"/>
+              <a:t>Loop through all timesteps</a:t>
+            </a:r>
+          </a:p>
+          <a:p>
+            <a:pPr lvl="1"/>
+            <a:r>
+              <a:rPr lang="en-US" sz="1400" dirty="0"/>
+              <a:t>Loop through all entities</a:t>
+            </a:r>
+          </a:p>
+          <a:p>
+            <a:pPr lvl="2"/>
+            <a:r>
+              <a:rPr lang="en-US" sz="1400" dirty="0" err="1"/>
+              <a:t>System.Update</a:t>
+            </a:r>
+            <a:r>
+              <a:rPr lang="en-US" sz="1400" dirty="0"/>
+              <a:t>() (Sensors, Guidance, Estimation, Controls)</a:t>
+            </a:r>
+            <a:endParaRPr lang="en-US" sz="1000" dirty="0"/>
+          </a:p>
+          <a:p>
+            <a:pPr lvl="2"/>
+            <a:r>
+              <a:rPr lang="en-US" sz="1400" dirty="0"/>
+              <a:t>Each system has if statements to decide which models and functions to use to get its outputs</a:t>
+            </a:r>
+          </a:p>
+          <a:p>
+            <a:pPr lvl="2"/>
+            <a:endParaRPr lang="en-US" sz="1000" dirty="0"/>
+          </a:p>
+          <a:p>
+            <a:pPr lvl="2"/>
+            <a:r>
+              <a:rPr lang="en-US" sz="1400" dirty="0" err="1"/>
+              <a:t>System.Log</a:t>
+            </a:r>
+            <a:r>
+              <a:rPr lang="en-US" sz="1400" dirty="0"/>
+              <a:t>() (Telemetry)</a:t>
+            </a:r>
+          </a:p>
+          <a:p>
+            <a:pPr lvl="2"/>
+            <a:r>
+              <a:rPr lang="en-US" sz="1400" dirty="0" err="1"/>
+              <a:t>System.Step</a:t>
+            </a:r>
+            <a:r>
+              <a:rPr lang="en-US" sz="1400" dirty="0"/>
+              <a:t>() (Motion)</a:t>
+            </a:r>
+          </a:p>
+          <a:p>
+            <a:pPr lvl="2"/>
+            <a:r>
+              <a:rPr lang="en-US" sz="1400" dirty="0"/>
+              <a:t>Update Global time</a:t>
+            </a:r>
+          </a:p>
+          <a:p>
+            <a:pPr lvl="2"/>
+            <a:endParaRPr lang="en-US" sz="1400" dirty="0"/>
+          </a:p>
+          <a:p>
+            <a:pPr lvl="2"/>
+            <a:endParaRPr lang="en-US" sz="1000" dirty="0"/>
+          </a:p>
+          <a:p>
+            <a:pPr lvl="2"/>
+            <a:endParaRPr lang="en-US" sz="1400" dirty="0"/>
+          </a:p>
+        </p:txBody>
+      </p:sp>
+    </p:spTree>
+    <p:extLst>
+      <p:ext uri="{BB962C8B-B14F-4D97-AF65-F5344CB8AC3E}">
+        <p14:creationId xmlns:p14="http://schemas.microsoft.com/office/powerpoint/2010/main" val="3139715625"/>
+      </p:ext>
+    </p:extLst>
+  </p:cSld>
+  <p:clrMapOvr>
+    <a:masterClrMapping/>
+  </p:clrMapOvr>
+</p:sld>
+</file>
+
+<file path=ppt/slides/slide5.xml><?xml version="1.0" encoding="utf-8"?>
+<p:sld xmlns:a="http://schemas.openxmlformats.org/drawingml/2006/main" xmlns:r="http://schemas.openxmlformats.org/officeDocument/2006/relationships" xmlns:p="http://schemas.openxmlformats.org/presentationml/2006/main">
+  <p:cSld>
+    <p:spTree>
+      <p:nvGrpSpPr>
+        <p:cNvPr id="1" name=""/>
+        <p:cNvGrpSpPr/>
+        <p:nvPr/>
+      </p:nvGrpSpPr>
+      <p:grpSpPr>
+        <a:xfrm>
+          <a:off x="0" y="0"/>
+          <a:ext cx="0" cy="0"/>
+          <a:chOff x="0" y="0"/>
+          <a:chExt cx="0" cy="0"/>
+        </a:xfrm>
+      </p:grpSpPr>
+      <p:sp>
+        <p:nvSpPr>
+          <p:cNvPr id="2" name="Title 1">
+            <a:extLst>
+              <a:ext uri="{FF2B5EF4-FFF2-40B4-BE49-F238E27FC236}">
+                <a16:creationId xmlns:a16="http://schemas.microsoft.com/office/drawing/2014/main" id="{0EDD1904-E6E4-C5D7-7A69-DDB37B0314C5}"/>
+              </a:ext>
+            </a:extLst>
+          </p:cNvPr>
+          <p:cNvSpPr>
+            <a:spLocks noGrp="1"/>
+          </p:cNvSpPr>
+          <p:nvPr>
+            <p:ph type="title"/>
+          </p:nvPr>
+        </p:nvSpPr>
+        <p:spPr/>
+        <p:txBody>
+          <a:bodyPr/>
+          <a:lstStyle/>
+          <a:p>
+            <a:r>
+              <a:rPr lang="en-US" dirty="0"/>
+              <a:t>Hierarchy</a:t>
+            </a:r>
+          </a:p>
+        </p:txBody>
+      </p:sp>
+      <p:sp>
+        <p:nvSpPr>
+          <p:cNvPr id="3" name="Content Placeholder 2">
+            <a:extLst>
+              <a:ext uri="{FF2B5EF4-FFF2-40B4-BE49-F238E27FC236}">
+                <a16:creationId xmlns:a16="http://schemas.microsoft.com/office/drawing/2014/main" id="{68EDBE33-97E2-A95E-5CF4-85FE479A817D}"/>
+              </a:ext>
+            </a:extLst>
+          </p:cNvPr>
+          <p:cNvSpPr>
+            <a:spLocks noGrp="1"/>
+          </p:cNvSpPr>
+          <p:nvPr>
+            <p:ph idx="1"/>
+          </p:nvPr>
+        </p:nvSpPr>
+        <p:spPr/>
+        <p:txBody>
+          <a:bodyPr/>
+          <a:lstStyle/>
+          <a:p>
+            <a:r>
+              <a:rPr lang="en-US" dirty="0"/>
+              <a:t>Entities are the top level objects with components that have state with systems which manipulate that state</a:t>
+            </a:r>
+          </a:p>
+          <a:p>
+            <a:r>
+              <a:rPr lang="en-US" dirty="0"/>
+              <a:t>Entities have initial state and optional list of components, (kinematics, radar, guidance)</a:t>
+            </a:r>
+          </a:p>
+          <a:p>
+            <a:r>
+              <a:rPr lang="en-US" dirty="0"/>
+              <a:t>Similar to work project, have standalone function for each component update, loops entities and if entity has that component then execute that string of updates, further customization done there via if </a:t>
+            </a:r>
+            <a:r>
+              <a:rPr lang="en-US" dirty="0" err="1"/>
+              <a:t>entity.motion_model.orbital</a:t>
+            </a:r>
+            <a:r>
+              <a:rPr lang="en-US" dirty="0"/>
+              <a:t>,  call system that takes in current kinematic state and control  and outputs the new </a:t>
+            </a:r>
+            <a:r>
+              <a:rPr lang="en-US"/>
+              <a:t>state with just math</a:t>
+            </a:r>
+            <a:endParaRPr lang="en-US" dirty="0"/>
+          </a:p>
+          <a:p>
+            <a:endParaRPr lang="en-US" dirty="0"/>
+          </a:p>
+        </p:txBody>
+      </p:sp>
+      <p:pic>
+        <p:nvPicPr>
+          <p:cNvPr id="5" name="Picture 4">
+            <a:extLst>
+              <a:ext uri="{FF2B5EF4-FFF2-40B4-BE49-F238E27FC236}">
+                <a16:creationId xmlns:a16="http://schemas.microsoft.com/office/drawing/2014/main" id="{A4BCE60F-1BBF-5539-2529-FA7F7DBC83CB}"/>
+              </a:ext>
+            </a:extLst>
+          </p:cNvPr>
+          <p:cNvPicPr>
+            <a:picLocks noChangeAspect="1"/>
+          </p:cNvPicPr>
+          <p:nvPr/>
+        </p:nvPicPr>
+        <p:blipFill>
+          <a:blip r:embed="rId2"/>
+          <a:stretch>
+            <a:fillRect/>
+          </a:stretch>
+        </p:blipFill>
+        <p:spPr>
+          <a:xfrm>
+            <a:off x="9600694" y="3198966"/>
+            <a:ext cx="2257442" cy="3162323"/>
+          </a:xfrm>
+          <a:prstGeom prst="rect">
+            <a:avLst/>
+          </a:prstGeom>
+        </p:spPr>
+      </p:pic>
+    </p:spTree>
+    <p:extLst>
+      <p:ext uri="{BB962C8B-B14F-4D97-AF65-F5344CB8AC3E}">
+        <p14:creationId xmlns:p14="http://schemas.microsoft.com/office/powerpoint/2010/main" val="2987790816"/>
+      </p:ext>
+    </p:extLst>
+  </p:cSld>
+  <p:clrMapOvr>
+    <a:masterClrMapping/>
+  </p:clrMapOvr>
+</p:sld>
+</file>
+
+<file path=ppt/slides/slide6.xml><?xml version="1.0" encoding="utf-8"?>
+<p:sld xmlns:a="http://schemas.openxmlformats.org/drawingml/2006/main" xmlns:r="http://schemas.openxmlformats.org/officeDocument/2006/relationships" xmlns:p="http://schemas.openxmlformats.org/presentationml/2006/main">
+  <p:cSld>
+    <p:spTree>
+      <p:nvGrpSpPr>
+        <p:cNvPr id="1" name="">
+          <a:extLst>
+            <a:ext uri="{FF2B5EF4-FFF2-40B4-BE49-F238E27FC236}">
+              <a16:creationId xmlns:a16="http://schemas.microsoft.com/office/drawing/2014/main" id="{360F2A73-CDA1-6738-DF8D-3C4BC56B86D1}"/>
+            </a:ext>
+          </a:extLst>
+        </p:cNvPr>
+        <p:cNvGrpSpPr/>
+        <p:nvPr/>
+      </p:nvGrpSpPr>
+      <p:grpSpPr>
+        <a:xfrm>
+          <a:off x="0" y="0"/>
+          <a:ext cx="0" cy="0"/>
+          <a:chOff x="0" y="0"/>
+          <a:chExt cx="0" cy="0"/>
+        </a:xfrm>
+      </p:grpSpPr>
+      <p:sp>
+        <p:nvSpPr>
+          <p:cNvPr id="2" name="Title 1">
+            <a:extLst>
+              <a:ext uri="{FF2B5EF4-FFF2-40B4-BE49-F238E27FC236}">
+                <a16:creationId xmlns:a16="http://schemas.microsoft.com/office/drawing/2014/main" id="{9599C586-2035-EA6D-CAB5-46E59D735DAE}"/>
+              </a:ext>
+            </a:extLst>
+          </p:cNvPr>
+          <p:cNvSpPr>
+            <a:spLocks noGrp="1"/>
+          </p:cNvSpPr>
+          <p:nvPr>
+            <p:ph type="title"/>
+          </p:nvPr>
+        </p:nvSpPr>
+        <p:spPr>
+          <a:xfrm>
+            <a:off x="1834487" y="2712540"/>
+            <a:ext cx="10515600" cy="1325563"/>
+          </a:xfrm>
+        </p:spPr>
+        <p:txBody>
+          <a:bodyPr/>
+          <a:lstStyle/>
+          <a:p>
+            <a:r>
+              <a:rPr lang="en-US" dirty="0"/>
+              <a:t>Coordinate Systems And Transforms</a:t>
+            </a:r>
+          </a:p>
+        </p:txBody>
+      </p:sp>
+    </p:spTree>
+    <p:extLst>
+      <p:ext uri="{BB962C8B-B14F-4D97-AF65-F5344CB8AC3E}">
+        <p14:creationId xmlns:p14="http://schemas.microsoft.com/office/powerpoint/2010/main" val="3880961570"/>
+      </p:ext>
+    </p:extLst>
+  </p:cSld>
+  <p:clrMapOvr>
+    <a:masterClrMapping/>
+  </p:clrMapOvr>
+</p:sld>
+</file>
+
+<file path=ppt/slides/slide7.xml><?xml version="1.0" encoding="utf-8"?>
 <p:sld xmlns:a="http://schemas.openxmlformats.org/drawingml/2006/main" xmlns:r="http://schemas.openxmlformats.org/officeDocument/2006/relationships" xmlns:p="http://schemas.openxmlformats.org/presentationml/2006/main">
   <p:cSld>
     <p:spTree>
@@ -5595,7 +6326,7 @@
 </p:sld>
 </file>
 
-<file path=ppt/slides/slide5.xml><?xml version="1.0" encoding="utf-8"?>
+<file path=ppt/slides/slide8.xml><?xml version="1.0" encoding="utf-8"?>
 <p:sld xmlns:a="http://schemas.openxmlformats.org/drawingml/2006/main" xmlns:r="http://schemas.openxmlformats.org/officeDocument/2006/relationships" xmlns:p="http://schemas.openxmlformats.org/presentationml/2006/main">
   <p:cSld>
     <p:spTree>
@@ -5705,7 +6436,7 @@
 </p:sld>
 </file>
 
-<file path=ppt/slides/slide6.xml><?xml version="1.0" encoding="utf-8"?>
+<file path=ppt/slides/slide9.xml><?xml version="1.0" encoding="utf-8"?>
 <p:sld xmlns:a="http://schemas.openxmlformats.org/drawingml/2006/main" xmlns:r="http://schemas.openxmlformats.org/officeDocument/2006/relationships" xmlns:p="http://schemas.openxmlformats.org/presentationml/2006/main">
   <p:cSld>
     <p:spTree>
@@ -5759,295 +6490,6 @@
     <p:extLst>
       <p:ext uri="{BB962C8B-B14F-4D97-AF65-F5344CB8AC3E}">
         <p14:creationId xmlns:p14="http://schemas.microsoft.com/office/powerpoint/2010/main" val="497690451"/>
-      </p:ext>
-    </p:extLst>
-  </p:cSld>
-  <p:clrMapOvr>
-    <a:masterClrMapping/>
-  </p:clrMapOvr>
-</p:sld>
-</file>
-
-<file path=ppt/slides/slide7.xml><?xml version="1.0" encoding="utf-8"?>
-<p:sld xmlns:a="http://schemas.openxmlformats.org/drawingml/2006/main" xmlns:r="http://schemas.openxmlformats.org/officeDocument/2006/relationships" xmlns:p="http://schemas.openxmlformats.org/presentationml/2006/main">
-  <p:cSld>
-    <p:spTree>
-      <p:nvGrpSpPr>
-        <p:cNvPr id="1" name="">
-          <a:extLst>
-            <a:ext uri="{FF2B5EF4-FFF2-40B4-BE49-F238E27FC236}">
-              <a16:creationId xmlns:a16="http://schemas.microsoft.com/office/drawing/2014/main" id="{7365EBFC-1256-5E78-F5F3-671A504DEC21}"/>
-            </a:ext>
-          </a:extLst>
-        </p:cNvPr>
-        <p:cNvGrpSpPr/>
-        <p:nvPr/>
-      </p:nvGrpSpPr>
-      <p:grpSpPr>
-        <a:xfrm>
-          <a:off x="0" y="0"/>
-          <a:ext cx="0" cy="0"/>
-          <a:chOff x="0" y="0"/>
-          <a:chExt cx="0" cy="0"/>
-        </a:xfrm>
-      </p:grpSpPr>
-      <p:sp>
-        <p:nvSpPr>
-          <p:cNvPr id="2" name="Title 1">
-            <a:extLst>
-              <a:ext uri="{FF2B5EF4-FFF2-40B4-BE49-F238E27FC236}">
-                <a16:creationId xmlns:a16="http://schemas.microsoft.com/office/drawing/2014/main" id="{3E6CB228-385F-B5F1-42F8-AC0040E8C2EC}"/>
-              </a:ext>
-            </a:extLst>
-          </p:cNvPr>
-          <p:cNvSpPr>
-            <a:spLocks noGrp="1"/>
-          </p:cNvSpPr>
-          <p:nvPr>
-            <p:ph type="title"/>
-          </p:nvPr>
-        </p:nvSpPr>
-        <p:spPr/>
-        <p:txBody>
-          <a:bodyPr/>
-          <a:lstStyle/>
-          <a:p>
-            <a:r>
-              <a:rPr lang="en-US" dirty="0"/>
-              <a:t>Feature Description</a:t>
-            </a:r>
-          </a:p>
-        </p:txBody>
-      </p:sp>
-      <p:sp>
-        <p:nvSpPr>
-          <p:cNvPr id="3" name="Content Placeholder 2">
-            <a:extLst>
-              <a:ext uri="{FF2B5EF4-FFF2-40B4-BE49-F238E27FC236}">
-                <a16:creationId xmlns:a16="http://schemas.microsoft.com/office/drawing/2014/main" id="{7ECE178C-5A02-EBB0-B9DD-067B6F9EAE8A}"/>
-              </a:ext>
-            </a:extLst>
-          </p:cNvPr>
-          <p:cNvSpPr>
-            <a:spLocks noGrp="1"/>
-          </p:cNvSpPr>
-          <p:nvPr>
-            <p:ph idx="1"/>
-          </p:nvPr>
-        </p:nvSpPr>
-        <p:spPr/>
-        <p:txBody>
-          <a:bodyPr/>
-          <a:lstStyle/>
-          <a:p>
-            <a:endParaRPr lang="en-US" dirty="0"/>
-          </a:p>
-        </p:txBody>
-      </p:sp>
-    </p:spTree>
-    <p:extLst>
-      <p:ext uri="{BB962C8B-B14F-4D97-AF65-F5344CB8AC3E}">
-        <p14:creationId xmlns:p14="http://schemas.microsoft.com/office/powerpoint/2010/main" val="2783873779"/>
-      </p:ext>
-    </p:extLst>
-  </p:cSld>
-  <p:clrMapOvr>
-    <a:masterClrMapping/>
-  </p:clrMapOvr>
-</p:sld>
-</file>
-
-<file path=ppt/slides/slide8.xml><?xml version="1.0" encoding="utf-8"?>
-<p:sld xmlns:a="http://schemas.openxmlformats.org/drawingml/2006/main" xmlns:r="http://schemas.openxmlformats.org/officeDocument/2006/relationships" xmlns:p="http://schemas.openxmlformats.org/presentationml/2006/main">
-  <p:cSld>
-    <p:spTree>
-      <p:nvGrpSpPr>
-        <p:cNvPr id="1" name="">
-          <a:extLst>
-            <a:ext uri="{FF2B5EF4-FFF2-40B4-BE49-F238E27FC236}">
-              <a16:creationId xmlns:a16="http://schemas.microsoft.com/office/drawing/2014/main" id="{7C9A7419-5BC5-5DA0-2C42-1A786B2FE457}"/>
-            </a:ext>
-          </a:extLst>
-        </p:cNvPr>
-        <p:cNvGrpSpPr/>
-        <p:nvPr/>
-      </p:nvGrpSpPr>
-      <p:grpSpPr>
-        <a:xfrm>
-          <a:off x="0" y="0"/>
-          <a:ext cx="0" cy="0"/>
-          <a:chOff x="0" y="0"/>
-          <a:chExt cx="0" cy="0"/>
-        </a:xfrm>
-      </p:grpSpPr>
-      <p:sp>
-        <p:nvSpPr>
-          <p:cNvPr id="2" name="Title 1">
-            <a:extLst>
-              <a:ext uri="{FF2B5EF4-FFF2-40B4-BE49-F238E27FC236}">
-                <a16:creationId xmlns:a16="http://schemas.microsoft.com/office/drawing/2014/main" id="{1A1098A0-C42F-F46F-ABAD-E3EA1F74F29A}"/>
-              </a:ext>
-            </a:extLst>
-          </p:cNvPr>
-          <p:cNvSpPr>
-            <a:spLocks noGrp="1"/>
-          </p:cNvSpPr>
-          <p:nvPr>
-            <p:ph type="title"/>
-          </p:nvPr>
-        </p:nvSpPr>
-        <p:spPr/>
-        <p:txBody>
-          <a:bodyPr/>
-          <a:lstStyle/>
-          <a:p>
-            <a:r>
-              <a:rPr lang="en-US" dirty="0"/>
-              <a:t>Developer Notes</a:t>
-            </a:r>
-          </a:p>
-        </p:txBody>
-      </p:sp>
-      <p:sp>
-        <p:nvSpPr>
-          <p:cNvPr id="3" name="Content Placeholder 2">
-            <a:extLst>
-              <a:ext uri="{FF2B5EF4-FFF2-40B4-BE49-F238E27FC236}">
-                <a16:creationId xmlns:a16="http://schemas.microsoft.com/office/drawing/2014/main" id="{6CB7F24B-E6BE-238D-8DCC-6388A26F2BF3}"/>
-              </a:ext>
-            </a:extLst>
-          </p:cNvPr>
-          <p:cNvSpPr>
-            <a:spLocks noGrp="1"/>
-          </p:cNvSpPr>
-          <p:nvPr>
-            <p:ph idx="1"/>
-          </p:nvPr>
-        </p:nvSpPr>
-        <p:spPr/>
-        <p:txBody>
-          <a:bodyPr/>
-          <a:lstStyle/>
-          <a:p>
-            <a:r>
-              <a:rPr lang="en-US" dirty="0"/>
-              <a:t>What is the default coordinate structure for calculations</a:t>
-            </a:r>
-          </a:p>
-          <a:p>
-            <a:r>
-              <a:rPr lang="en-US" dirty="0"/>
-              <a:t>Seems to be R </a:t>
-            </a:r>
-            <a:r>
-              <a:rPr lang="en-US" dirty="0" err="1"/>
-              <a:t>vec</a:t>
-            </a:r>
-            <a:r>
-              <a:rPr lang="en-US" dirty="0"/>
-              <a:t> of ECEF XYZ works, maybe use a NED coords for local</a:t>
-            </a:r>
-          </a:p>
-          <a:p>
-            <a:r>
-              <a:rPr lang="en-US" dirty="0"/>
-              <a:t>Best way to do the </a:t>
-            </a:r>
-            <a:r>
-              <a:rPr lang="en-US" dirty="0" err="1"/>
-              <a:t>lin</a:t>
-            </a:r>
-            <a:r>
-              <a:rPr lang="en-US" dirty="0"/>
-              <a:t> </a:t>
-            </a:r>
-            <a:r>
-              <a:rPr lang="en-US" dirty="0" err="1"/>
-              <a:t>alg</a:t>
-            </a:r>
-            <a:r>
-              <a:rPr lang="en-US" dirty="0"/>
-              <a:t> math for easy vector manipulation in C++</a:t>
-            </a:r>
-          </a:p>
-          <a:p>
-            <a:endParaRPr lang="en-US" dirty="0"/>
-          </a:p>
-        </p:txBody>
-      </p:sp>
-    </p:spTree>
-    <p:extLst>
-      <p:ext uri="{BB962C8B-B14F-4D97-AF65-F5344CB8AC3E}">
-        <p14:creationId xmlns:p14="http://schemas.microsoft.com/office/powerpoint/2010/main" val="1555275095"/>
-      </p:ext>
-    </p:extLst>
-  </p:cSld>
-  <p:clrMapOvr>
-    <a:masterClrMapping/>
-  </p:clrMapOvr>
-</p:sld>
-</file>
-
-<file path=ppt/slides/slide9.xml><?xml version="1.0" encoding="utf-8"?>
-<p:sld xmlns:a="http://schemas.openxmlformats.org/drawingml/2006/main" xmlns:r="http://schemas.openxmlformats.org/officeDocument/2006/relationships" xmlns:p="http://schemas.openxmlformats.org/presentationml/2006/main">
-  <p:cSld>
-    <p:spTree>
-      <p:nvGrpSpPr>
-        <p:cNvPr id="1" name="">
-          <a:extLst>
-            <a:ext uri="{FF2B5EF4-FFF2-40B4-BE49-F238E27FC236}">
-              <a16:creationId xmlns:a16="http://schemas.microsoft.com/office/drawing/2014/main" id="{280BCD6E-9393-77DB-D42F-45B06B7568DC}"/>
-            </a:ext>
-          </a:extLst>
-        </p:cNvPr>
-        <p:cNvGrpSpPr/>
-        <p:nvPr/>
-      </p:nvGrpSpPr>
-      <p:grpSpPr>
-        <a:xfrm>
-          <a:off x="0" y="0"/>
-          <a:ext cx="0" cy="0"/>
-          <a:chOff x="0" y="0"/>
-          <a:chExt cx="0" cy="0"/>
-        </a:xfrm>
-      </p:grpSpPr>
-      <p:sp>
-        <p:nvSpPr>
-          <p:cNvPr id="2" name="Title 1">
-            <a:extLst>
-              <a:ext uri="{FF2B5EF4-FFF2-40B4-BE49-F238E27FC236}">
-                <a16:creationId xmlns:a16="http://schemas.microsoft.com/office/drawing/2014/main" id="{37910598-C7ED-84E2-49E5-F8B92D38D089}"/>
-              </a:ext>
-            </a:extLst>
-          </p:cNvPr>
-          <p:cNvSpPr>
-            <a:spLocks noGrp="1"/>
-          </p:cNvSpPr>
-          <p:nvPr>
-            <p:ph type="title"/>
-          </p:nvPr>
-        </p:nvSpPr>
-        <p:spPr>
-          <a:xfrm>
-            <a:off x="2626057" y="2698892"/>
-            <a:ext cx="10515600" cy="1325563"/>
-          </a:xfrm>
-        </p:spPr>
-        <p:txBody>
-          <a:bodyPr/>
-          <a:lstStyle/>
-          <a:p>
-            <a:r>
-              <a:rPr lang="en-US" dirty="0"/>
-              <a:t>Missile Guidance Without LOS</a:t>
-            </a:r>
-          </a:p>
-        </p:txBody>
-      </p:sp>
-    </p:spTree>
-    <p:extLst>
-      <p:ext uri="{BB962C8B-B14F-4D97-AF65-F5344CB8AC3E}">
-        <p14:creationId xmlns:p14="http://schemas.microsoft.com/office/powerpoint/2010/main" val="1256370275"/>
       </p:ext>
     </p:extLst>
   </p:cSld>

</xml_diff>

<commit_message>
Massive file hierarchy overhaul but very happy with outcome, modular base for growing the math and states is in good shape, next redefining entities based on states and models.
</commit_message>
<xml_diff>
--- a/docs/Apogee_Progession.pptx
+++ b/docs/Apogee_Progession.pptx
@@ -10,30 +10,32 @@
     <p:sldId id="273" r:id="rId4"/>
     <p:sldId id="286" r:id="rId5"/>
     <p:sldId id="287" r:id="rId6"/>
-    <p:sldId id="285" r:id="rId7"/>
-    <p:sldId id="274" r:id="rId8"/>
-    <p:sldId id="275" r:id="rId9"/>
-    <p:sldId id="259" r:id="rId10"/>
-    <p:sldId id="265" r:id="rId11"/>
-    <p:sldId id="266" r:id="rId12"/>
-    <p:sldId id="260" r:id="rId13"/>
-    <p:sldId id="267" r:id="rId14"/>
-    <p:sldId id="268" r:id="rId15"/>
-    <p:sldId id="261" r:id="rId16"/>
-    <p:sldId id="271" r:id="rId17"/>
-    <p:sldId id="272" r:id="rId18"/>
-    <p:sldId id="262" r:id="rId19"/>
-    <p:sldId id="269" r:id="rId20"/>
-    <p:sldId id="270" r:id="rId21"/>
-    <p:sldId id="276" r:id="rId22"/>
-    <p:sldId id="277" r:id="rId23"/>
-    <p:sldId id="278" r:id="rId24"/>
-    <p:sldId id="284" r:id="rId25"/>
-    <p:sldId id="283" r:id="rId26"/>
-    <p:sldId id="282" r:id="rId27"/>
-    <p:sldId id="281" r:id="rId28"/>
-    <p:sldId id="279" r:id="rId29"/>
-    <p:sldId id="280" r:id="rId30"/>
+    <p:sldId id="288" r:id="rId7"/>
+    <p:sldId id="289" r:id="rId8"/>
+    <p:sldId id="285" r:id="rId9"/>
+    <p:sldId id="274" r:id="rId10"/>
+    <p:sldId id="275" r:id="rId11"/>
+    <p:sldId id="259" r:id="rId12"/>
+    <p:sldId id="265" r:id="rId13"/>
+    <p:sldId id="266" r:id="rId14"/>
+    <p:sldId id="260" r:id="rId15"/>
+    <p:sldId id="267" r:id="rId16"/>
+    <p:sldId id="268" r:id="rId17"/>
+    <p:sldId id="261" r:id="rId18"/>
+    <p:sldId id="271" r:id="rId19"/>
+    <p:sldId id="272" r:id="rId20"/>
+    <p:sldId id="262" r:id="rId21"/>
+    <p:sldId id="269" r:id="rId22"/>
+    <p:sldId id="270" r:id="rId23"/>
+    <p:sldId id="276" r:id="rId24"/>
+    <p:sldId id="277" r:id="rId25"/>
+    <p:sldId id="278" r:id="rId26"/>
+    <p:sldId id="284" r:id="rId27"/>
+    <p:sldId id="283" r:id="rId28"/>
+    <p:sldId id="282" r:id="rId29"/>
+    <p:sldId id="281" r:id="rId30"/>
+    <p:sldId id="279" r:id="rId31"/>
+    <p:sldId id="280" r:id="rId32"/>
   </p:sldIdLst>
   <p:sldSz cx="12192000" cy="6858000"/>
   <p:notesSz cx="6858000" cy="9144000"/>
@@ -153,7 +155,7 @@
   <pc:docChgLst>
     <pc:chgData name="Jeremy Jestel" userId="f12305450eb37733" providerId="LiveId" clId="{5A341855-0C93-42C0-8589-13149EEF218B}"/>
     <pc:docChg chg="undo custSel addSld delSld modSld">
-      <pc:chgData name="Jeremy Jestel" userId="f12305450eb37733" providerId="LiveId" clId="{5A341855-0C93-42C0-8589-13149EEF218B}" dt="2026-10-14T04:11:00.091" v="4483" actId="20577"/>
+      <pc:chgData name="Jeremy Jestel" userId="f12305450eb37733" providerId="LiveId" clId="{5A341855-0C93-42C0-8589-13149EEF218B}" dt="2026-10-15T04:01:05.072" v="7212" actId="20577"/>
       <pc:docMkLst>
         <pc:docMk/>
       </pc:docMkLst>
@@ -592,6 +594,60 @@
           </ac:picMkLst>
         </pc:picChg>
       </pc:sldChg>
+      <pc:sldChg chg="addSp modSp new mod">
+        <pc:chgData name="Jeremy Jestel" userId="f12305450eb37733" providerId="LiveId" clId="{5A341855-0C93-42C0-8589-13149EEF218B}" dt="2026-10-15T03:28:47.777" v="5330" actId="1076"/>
+        <pc:sldMkLst>
+          <pc:docMk/>
+          <pc:sldMk cId="1674698795" sldId="288"/>
+        </pc:sldMkLst>
+        <pc:spChg chg="mod">
+          <ac:chgData name="Jeremy Jestel" userId="f12305450eb37733" providerId="LiveId" clId="{5A341855-0C93-42C0-8589-13149EEF218B}" dt="2026-10-15T02:44:06.080" v="4530" actId="20577"/>
+          <ac:spMkLst>
+            <pc:docMk/>
+            <pc:sldMk cId="1674698795" sldId="288"/>
+            <ac:spMk id="2" creationId="{B2C25C08-D46B-8138-F854-C2438DECAA08}"/>
+          </ac:spMkLst>
+        </pc:spChg>
+        <pc:spChg chg="mod">
+          <ac:chgData name="Jeremy Jestel" userId="f12305450eb37733" providerId="LiveId" clId="{5A341855-0C93-42C0-8589-13149EEF218B}" dt="2026-10-15T03:28:43.140" v="5328" actId="14100"/>
+          <ac:spMkLst>
+            <pc:docMk/>
+            <pc:sldMk cId="1674698795" sldId="288"/>
+            <ac:spMk id="3" creationId="{D94C250C-222A-E5E7-DD61-BB50BE20F8E7}"/>
+          </ac:spMkLst>
+        </pc:spChg>
+        <pc:picChg chg="add mod">
+          <ac:chgData name="Jeremy Jestel" userId="f12305450eb37733" providerId="LiveId" clId="{5A341855-0C93-42C0-8589-13149EEF218B}" dt="2026-10-15T03:28:47.777" v="5330" actId="1076"/>
+          <ac:picMkLst>
+            <pc:docMk/>
+            <pc:sldMk cId="1674698795" sldId="288"/>
+            <ac:picMk id="5" creationId="{DB01CAA7-E986-8685-6273-B6099C7A7E48}"/>
+          </ac:picMkLst>
+        </pc:picChg>
+      </pc:sldChg>
+      <pc:sldChg chg="modSp new mod">
+        <pc:chgData name="Jeremy Jestel" userId="f12305450eb37733" providerId="LiveId" clId="{5A341855-0C93-42C0-8589-13149EEF218B}" dt="2026-10-15T04:01:05.072" v="7212" actId="20577"/>
+        <pc:sldMkLst>
+          <pc:docMk/>
+          <pc:sldMk cId="1222222787" sldId="289"/>
+        </pc:sldMkLst>
+        <pc:spChg chg="mod">
+          <ac:chgData name="Jeremy Jestel" userId="f12305450eb37733" providerId="LiveId" clId="{5A341855-0C93-42C0-8589-13149EEF218B}" dt="2026-10-15T03:47:37.039" v="5415" actId="20577"/>
+          <ac:spMkLst>
+            <pc:docMk/>
+            <pc:sldMk cId="1222222787" sldId="289"/>
+            <ac:spMk id="2" creationId="{8ACA08C1-3158-975D-F9F6-24CED5953318}"/>
+          </ac:spMkLst>
+        </pc:spChg>
+        <pc:spChg chg="mod">
+          <ac:chgData name="Jeremy Jestel" userId="f12305450eb37733" providerId="LiveId" clId="{5A341855-0C93-42C0-8589-13149EEF218B}" dt="2026-10-15T04:01:05.072" v="7212" actId="20577"/>
+          <ac:spMkLst>
+            <pc:docMk/>
+            <pc:sldMk cId="1222222787" sldId="289"/>
+            <ac:spMk id="3" creationId="{139C2602-2F68-2D6D-FBD7-8AE223D1861D}"/>
+          </ac:spMkLst>
+        </pc:spChg>
+      </pc:sldChg>
     </pc:docChg>
   </pc:docChgLst>
 </pc:chgInfo>
@@ -744,7 +800,7 @@
           <a:p>
             <a:fld id="{CEB632EC-697C-46E2-86FC-E2DD52DD9F70}" type="datetimeFigureOut">
               <a:rPr lang="en-US" smtClean="0"/>
-              <a:t>10/13/2026</a:t>
+              <a:t>10/14/2026</a:t>
             </a:fld>
             <a:endParaRPr lang="en-US"/>
           </a:p>
@@ -942,7 +998,7 @@
           <a:p>
             <a:fld id="{CEB632EC-697C-46E2-86FC-E2DD52DD9F70}" type="datetimeFigureOut">
               <a:rPr lang="en-US" smtClean="0"/>
-              <a:t>10/13/2026</a:t>
+              <a:t>10/14/2026</a:t>
             </a:fld>
             <a:endParaRPr lang="en-US"/>
           </a:p>
@@ -1150,7 +1206,7 @@
           <a:p>
             <a:fld id="{CEB632EC-697C-46E2-86FC-E2DD52DD9F70}" type="datetimeFigureOut">
               <a:rPr lang="en-US" smtClean="0"/>
-              <a:t>10/13/2026</a:t>
+              <a:t>10/14/2026</a:t>
             </a:fld>
             <a:endParaRPr lang="en-US"/>
           </a:p>
@@ -1348,7 +1404,7 @@
           <a:p>
             <a:fld id="{CEB632EC-697C-46E2-86FC-E2DD52DD9F70}" type="datetimeFigureOut">
               <a:rPr lang="en-US" smtClean="0"/>
-              <a:t>10/13/2026</a:t>
+              <a:t>10/14/2026</a:t>
             </a:fld>
             <a:endParaRPr lang="en-US"/>
           </a:p>
@@ -1623,7 +1679,7 @@
           <a:p>
             <a:fld id="{CEB632EC-697C-46E2-86FC-E2DD52DD9F70}" type="datetimeFigureOut">
               <a:rPr lang="en-US" smtClean="0"/>
-              <a:t>10/13/2026</a:t>
+              <a:t>10/14/2026</a:t>
             </a:fld>
             <a:endParaRPr lang="en-US"/>
           </a:p>
@@ -1888,7 +1944,7 @@
           <a:p>
             <a:fld id="{CEB632EC-697C-46E2-86FC-E2DD52DD9F70}" type="datetimeFigureOut">
               <a:rPr lang="en-US" smtClean="0"/>
-              <a:t>10/13/2026</a:t>
+              <a:t>10/14/2026</a:t>
             </a:fld>
             <a:endParaRPr lang="en-US"/>
           </a:p>
@@ -2300,7 +2356,7 @@
           <a:p>
             <a:fld id="{CEB632EC-697C-46E2-86FC-E2DD52DD9F70}" type="datetimeFigureOut">
               <a:rPr lang="en-US" smtClean="0"/>
-              <a:t>10/13/2026</a:t>
+              <a:t>10/14/2026</a:t>
             </a:fld>
             <a:endParaRPr lang="en-US"/>
           </a:p>
@@ -2441,7 +2497,7 @@
           <a:p>
             <a:fld id="{CEB632EC-697C-46E2-86FC-E2DD52DD9F70}" type="datetimeFigureOut">
               <a:rPr lang="en-US" smtClean="0"/>
-              <a:t>10/13/2026</a:t>
+              <a:t>10/14/2026</a:t>
             </a:fld>
             <a:endParaRPr lang="en-US"/>
           </a:p>
@@ -2554,7 +2610,7 @@
           <a:p>
             <a:fld id="{CEB632EC-697C-46E2-86FC-E2DD52DD9F70}" type="datetimeFigureOut">
               <a:rPr lang="en-US" smtClean="0"/>
-              <a:t>10/13/2026</a:t>
+              <a:t>10/14/2026</a:t>
             </a:fld>
             <a:endParaRPr lang="en-US"/>
           </a:p>
@@ -2865,7 +2921,7 @@
           <a:p>
             <a:fld id="{CEB632EC-697C-46E2-86FC-E2DD52DD9F70}" type="datetimeFigureOut">
               <a:rPr lang="en-US" smtClean="0"/>
-              <a:t>10/13/2026</a:t>
+              <a:t>10/14/2026</a:t>
             </a:fld>
             <a:endParaRPr lang="en-US"/>
           </a:p>
@@ -3153,7 +3209,7 @@
           <a:p>
             <a:fld id="{CEB632EC-697C-46E2-86FC-E2DD52DD9F70}" type="datetimeFigureOut">
               <a:rPr lang="en-US" smtClean="0"/>
-              <a:t>10/13/2026</a:t>
+              <a:t>10/14/2026</a:t>
             </a:fld>
             <a:endParaRPr lang="en-US"/>
           </a:p>
@@ -3394,7 +3450,7 @@
           <a:p>
             <a:fld id="{CEB632EC-697C-46E2-86FC-E2DD52DD9F70}" type="datetimeFigureOut">
               <a:rPr lang="en-US" smtClean="0"/>
-              <a:t>10/13/2026</a:t>
+              <a:t>10/14/2026</a:t>
             </a:fld>
             <a:endParaRPr lang="en-US"/>
           </a:p>
@@ -3885,6 +3941,179 @@
         <p:cNvPr id="1" name="">
           <a:extLst>
             <a:ext uri="{FF2B5EF4-FFF2-40B4-BE49-F238E27FC236}">
+              <a16:creationId xmlns:a16="http://schemas.microsoft.com/office/drawing/2014/main" id="{DA4D5631-0A62-AB59-D727-76A1E8FD3F2F}"/>
+            </a:ext>
+          </a:extLst>
+        </p:cNvPr>
+        <p:cNvGrpSpPr/>
+        <p:nvPr/>
+      </p:nvGrpSpPr>
+      <p:grpSpPr>
+        <a:xfrm>
+          <a:off x="0" y="0"/>
+          <a:ext cx="0" cy="0"/>
+          <a:chOff x="0" y="0"/>
+          <a:chExt cx="0" cy="0"/>
+        </a:xfrm>
+      </p:grpSpPr>
+      <p:sp>
+        <p:nvSpPr>
+          <p:cNvPr id="2" name="Title 1">
+            <a:extLst>
+              <a:ext uri="{FF2B5EF4-FFF2-40B4-BE49-F238E27FC236}">
+                <a16:creationId xmlns:a16="http://schemas.microsoft.com/office/drawing/2014/main" id="{461F6BEA-5B2C-497A-78C4-B6E376BDA52B}"/>
+              </a:ext>
+            </a:extLst>
+          </p:cNvPr>
+          <p:cNvSpPr>
+            <a:spLocks noGrp="1"/>
+          </p:cNvSpPr>
+          <p:nvPr>
+            <p:ph type="title"/>
+          </p:nvPr>
+        </p:nvSpPr>
+        <p:spPr/>
+        <p:txBody>
+          <a:bodyPr/>
+          <a:lstStyle/>
+          <a:p>
+            <a:r>
+              <a:rPr lang="en-US" dirty="0"/>
+              <a:t>Developer Notes</a:t>
+            </a:r>
+          </a:p>
+        </p:txBody>
+      </p:sp>
+      <p:sp>
+        <p:nvSpPr>
+          <p:cNvPr id="3" name="Content Placeholder 2">
+            <a:extLst>
+              <a:ext uri="{FF2B5EF4-FFF2-40B4-BE49-F238E27FC236}">
+                <a16:creationId xmlns:a16="http://schemas.microsoft.com/office/drawing/2014/main" id="{6BD1868D-38D3-020B-42CE-2B1B0BDDBE23}"/>
+              </a:ext>
+            </a:extLst>
+          </p:cNvPr>
+          <p:cNvSpPr>
+            <a:spLocks noGrp="1"/>
+          </p:cNvSpPr>
+          <p:nvPr>
+            <p:ph idx="1"/>
+          </p:nvPr>
+        </p:nvSpPr>
+        <p:spPr/>
+        <p:txBody>
+          <a:bodyPr/>
+          <a:lstStyle/>
+          <a:p>
+            <a:r>
+              <a:rPr lang="en-US" dirty="0"/>
+              <a:t>ECI versus ECEF</a:t>
+            </a:r>
+          </a:p>
+          <a:p>
+            <a:r>
+              <a:rPr lang="en-US" dirty="0"/>
+              <a:t>ENU versus NED</a:t>
+            </a:r>
+          </a:p>
+          <a:p>
+            <a:r>
+              <a:rPr lang="en-US" dirty="0"/>
+              <a:t>Since only 3 DOF assumption is pointing and velocity vector are same, important for prop nav and radar</a:t>
+            </a:r>
+          </a:p>
+          <a:p>
+            <a:r>
+              <a:rPr lang="en-US" dirty="0"/>
+              <a:t>Kinematic State</a:t>
+            </a:r>
+          </a:p>
+        </p:txBody>
+      </p:sp>
+    </p:spTree>
+    <p:extLst>
+      <p:ext uri="{BB962C8B-B14F-4D97-AF65-F5344CB8AC3E}">
+        <p14:creationId xmlns:p14="http://schemas.microsoft.com/office/powerpoint/2010/main" val="74780814"/>
+      </p:ext>
+    </p:extLst>
+  </p:cSld>
+  <p:clrMapOvr>
+    <a:masterClrMapping/>
+  </p:clrMapOvr>
+</p:sld>
+</file>
+
+<file path=ppt/slides/slide11.xml><?xml version="1.0" encoding="utf-8"?>
+<p:sld xmlns:a="http://schemas.openxmlformats.org/drawingml/2006/main" xmlns:r="http://schemas.openxmlformats.org/officeDocument/2006/relationships" xmlns:p="http://schemas.openxmlformats.org/presentationml/2006/main">
+  <p:cSld>
+    <p:spTree>
+      <p:nvGrpSpPr>
+        <p:cNvPr id="1" name=""/>
+        <p:cNvGrpSpPr/>
+        <p:nvPr/>
+      </p:nvGrpSpPr>
+      <p:grpSpPr>
+        <a:xfrm>
+          <a:off x="0" y="0"/>
+          <a:ext cx="0" cy="0"/>
+          <a:chOff x="0" y="0"/>
+          <a:chExt cx="0" cy="0"/>
+        </a:xfrm>
+      </p:grpSpPr>
+      <p:sp>
+        <p:nvSpPr>
+          <p:cNvPr id="2" name="Title 1">
+            <a:extLst>
+              <a:ext uri="{FF2B5EF4-FFF2-40B4-BE49-F238E27FC236}">
+                <a16:creationId xmlns:a16="http://schemas.microsoft.com/office/drawing/2014/main" id="{123AF59F-86A0-A19D-E1F2-A72865B6DB78}"/>
+              </a:ext>
+            </a:extLst>
+          </p:cNvPr>
+          <p:cNvSpPr>
+            <a:spLocks noGrp="1"/>
+          </p:cNvSpPr>
+          <p:nvPr>
+            <p:ph type="title"/>
+          </p:nvPr>
+        </p:nvSpPr>
+        <p:spPr>
+          <a:xfrm>
+            <a:off x="2776183" y="2766218"/>
+            <a:ext cx="10515600" cy="1325563"/>
+          </a:xfrm>
+        </p:spPr>
+        <p:txBody>
+          <a:bodyPr/>
+          <a:lstStyle/>
+          <a:p>
+            <a:r>
+              <a:rPr lang="en-US" dirty="0"/>
+              <a:t>Missile Guidance With LOS</a:t>
+            </a:r>
+          </a:p>
+        </p:txBody>
+      </p:sp>
+    </p:spTree>
+    <p:extLst>
+      <p:ext uri="{BB962C8B-B14F-4D97-AF65-F5344CB8AC3E}">
+        <p14:creationId xmlns:p14="http://schemas.microsoft.com/office/powerpoint/2010/main" val="497690451"/>
+      </p:ext>
+    </p:extLst>
+  </p:cSld>
+  <p:clrMapOvr>
+    <a:masterClrMapping/>
+  </p:clrMapOvr>
+</p:sld>
+</file>
+
+<file path=ppt/slides/slide12.xml><?xml version="1.0" encoding="utf-8"?>
+<p:sld xmlns:a="http://schemas.openxmlformats.org/drawingml/2006/main" xmlns:r="http://schemas.openxmlformats.org/officeDocument/2006/relationships" xmlns:p="http://schemas.openxmlformats.org/presentationml/2006/main">
+  <p:cSld>
+    <p:spTree>
+      <p:nvGrpSpPr>
+        <p:cNvPr id="1" name="">
+          <a:extLst>
+            <a:ext uri="{FF2B5EF4-FFF2-40B4-BE49-F238E27FC236}">
               <a16:creationId xmlns:a16="http://schemas.microsoft.com/office/drawing/2014/main" id="{7365EBFC-1256-5E78-F5F3-671A504DEC21}"/>
             </a:ext>
           </a:extLst>
@@ -3966,7 +4195,7 @@
 </p:sld>
 </file>
 
-<file path=ppt/slides/slide11.xml><?xml version="1.0" encoding="utf-8"?>
+<file path=ppt/slides/slide13.xml><?xml version="1.0" encoding="utf-8"?>
 <p:sld xmlns:a="http://schemas.openxmlformats.org/drawingml/2006/main" xmlns:r="http://schemas.openxmlformats.org/officeDocument/2006/relationships" xmlns:p="http://schemas.openxmlformats.org/presentationml/2006/main">
   <p:cSld>
     <p:spTree>
@@ -4097,7 +4326,7 @@
 </p:sld>
 </file>
 
-<file path=ppt/slides/slide12.xml><?xml version="1.0" encoding="utf-8"?>
+<file path=ppt/slides/slide14.xml><?xml version="1.0" encoding="utf-8"?>
 <p:sld xmlns:a="http://schemas.openxmlformats.org/drawingml/2006/main" xmlns:r="http://schemas.openxmlformats.org/officeDocument/2006/relationships" xmlns:p="http://schemas.openxmlformats.org/presentationml/2006/main">
   <p:cSld>
     <p:spTree>
@@ -4166,7 +4395,7 @@
 </p:sld>
 </file>
 
-<file path=ppt/slides/slide13.xml><?xml version="1.0" encoding="utf-8"?>
+<file path=ppt/slides/slide15.xml><?xml version="1.0" encoding="utf-8"?>
 <p:sld xmlns:a="http://schemas.openxmlformats.org/drawingml/2006/main" xmlns:r="http://schemas.openxmlformats.org/officeDocument/2006/relationships" xmlns:p="http://schemas.openxmlformats.org/presentationml/2006/main">
   <p:cSld>
     <p:spTree>
@@ -4255,7 +4484,7 @@
 </p:sld>
 </file>
 
-<file path=ppt/slides/slide14.xml><?xml version="1.0" encoding="utf-8"?>
+<file path=ppt/slides/slide16.xml><?xml version="1.0" encoding="utf-8"?>
 <p:sld xmlns:a="http://schemas.openxmlformats.org/drawingml/2006/main" xmlns:r="http://schemas.openxmlformats.org/officeDocument/2006/relationships" xmlns:p="http://schemas.openxmlformats.org/presentationml/2006/main">
   <p:cSld>
     <p:spTree>
@@ -4344,7 +4573,7 @@
 </p:sld>
 </file>
 
-<file path=ppt/slides/slide15.xml><?xml version="1.0" encoding="utf-8"?>
+<file path=ppt/slides/slide17.xml><?xml version="1.0" encoding="utf-8"?>
 <p:sld xmlns:a="http://schemas.openxmlformats.org/drawingml/2006/main" xmlns:r="http://schemas.openxmlformats.org/officeDocument/2006/relationships" xmlns:p="http://schemas.openxmlformats.org/presentationml/2006/main">
   <p:cSld>
     <p:spTree>
@@ -4413,7 +4642,7 @@
 </p:sld>
 </file>
 
-<file path=ppt/slides/slide16.xml><?xml version="1.0" encoding="utf-8"?>
+<file path=ppt/slides/slide18.xml><?xml version="1.0" encoding="utf-8"?>
 <p:sld xmlns:a="http://schemas.openxmlformats.org/drawingml/2006/main" xmlns:r="http://schemas.openxmlformats.org/officeDocument/2006/relationships" xmlns:p="http://schemas.openxmlformats.org/presentationml/2006/main">
   <p:cSld>
     <p:spTree>
@@ -4502,7 +4731,7 @@
 </p:sld>
 </file>
 
-<file path=ppt/slides/slide17.xml><?xml version="1.0" encoding="utf-8"?>
+<file path=ppt/slides/slide19.xml><?xml version="1.0" encoding="utf-8"?>
 <p:sld xmlns:a="http://schemas.openxmlformats.org/drawingml/2006/main" xmlns:r="http://schemas.openxmlformats.org/officeDocument/2006/relationships" xmlns:p="http://schemas.openxmlformats.org/presentationml/2006/main">
   <p:cSld>
     <p:spTree>
@@ -4582,164 +4811,6 @@
     <p:extLst>
       <p:ext uri="{BB962C8B-B14F-4D97-AF65-F5344CB8AC3E}">
         <p14:creationId xmlns:p14="http://schemas.microsoft.com/office/powerpoint/2010/main" val="1431625114"/>
-      </p:ext>
-    </p:extLst>
-  </p:cSld>
-  <p:clrMapOvr>
-    <a:masterClrMapping/>
-  </p:clrMapOvr>
-</p:sld>
-</file>
-
-<file path=ppt/slides/slide18.xml><?xml version="1.0" encoding="utf-8"?>
-<p:sld xmlns:a="http://schemas.openxmlformats.org/drawingml/2006/main" xmlns:r="http://schemas.openxmlformats.org/officeDocument/2006/relationships" xmlns:p="http://schemas.openxmlformats.org/presentationml/2006/main">
-  <p:cSld>
-    <p:spTree>
-      <p:nvGrpSpPr>
-        <p:cNvPr id="1" name="">
-          <a:extLst>
-            <a:ext uri="{FF2B5EF4-FFF2-40B4-BE49-F238E27FC236}">
-              <a16:creationId xmlns:a16="http://schemas.microsoft.com/office/drawing/2014/main" id="{109DF938-1D1D-0678-51F7-F5DED296A21F}"/>
-            </a:ext>
-          </a:extLst>
-        </p:cNvPr>
-        <p:cNvGrpSpPr/>
-        <p:nvPr/>
-      </p:nvGrpSpPr>
-      <p:grpSpPr>
-        <a:xfrm>
-          <a:off x="0" y="0"/>
-          <a:ext cx="0" cy="0"/>
-          <a:chOff x="0" y="0"/>
-          <a:chExt cx="0" cy="0"/>
-        </a:xfrm>
-      </p:grpSpPr>
-      <p:sp>
-        <p:nvSpPr>
-          <p:cNvPr id="2" name="Title 1">
-            <a:extLst>
-              <a:ext uri="{FF2B5EF4-FFF2-40B4-BE49-F238E27FC236}">
-                <a16:creationId xmlns:a16="http://schemas.microsoft.com/office/drawing/2014/main" id="{15C0FA39-8116-D64A-21F6-420A283F0048}"/>
-              </a:ext>
-            </a:extLst>
-          </p:cNvPr>
-          <p:cNvSpPr>
-            <a:spLocks noGrp="1"/>
-          </p:cNvSpPr>
-          <p:nvPr>
-            <p:ph type="title"/>
-          </p:nvPr>
-        </p:nvSpPr>
-        <p:spPr>
-          <a:xfrm>
-            <a:off x="4502624" y="2507824"/>
-            <a:ext cx="10515600" cy="1325563"/>
-          </a:xfrm>
-        </p:spPr>
-        <p:txBody>
-          <a:bodyPr/>
-          <a:lstStyle/>
-          <a:p>
-            <a:r>
-              <a:rPr lang="en-US" dirty="0"/>
-              <a:t>Satellite orbit</a:t>
-            </a:r>
-          </a:p>
-        </p:txBody>
-      </p:sp>
-    </p:spTree>
-    <p:extLst>
-      <p:ext uri="{BB962C8B-B14F-4D97-AF65-F5344CB8AC3E}">
-        <p14:creationId xmlns:p14="http://schemas.microsoft.com/office/powerpoint/2010/main" val="2635012408"/>
-      </p:ext>
-    </p:extLst>
-  </p:cSld>
-  <p:clrMapOvr>
-    <a:masterClrMapping/>
-  </p:clrMapOvr>
-</p:sld>
-</file>
-
-<file path=ppt/slides/slide19.xml><?xml version="1.0" encoding="utf-8"?>
-<p:sld xmlns:a="http://schemas.openxmlformats.org/drawingml/2006/main" xmlns:r="http://schemas.openxmlformats.org/officeDocument/2006/relationships" xmlns:p="http://schemas.openxmlformats.org/presentationml/2006/main">
-  <p:cSld>
-    <p:spTree>
-      <p:nvGrpSpPr>
-        <p:cNvPr id="1" name="">
-          <a:extLst>
-            <a:ext uri="{FF2B5EF4-FFF2-40B4-BE49-F238E27FC236}">
-              <a16:creationId xmlns:a16="http://schemas.microsoft.com/office/drawing/2014/main" id="{3F370C48-ECDF-4E43-486E-0629FDC61A7D}"/>
-            </a:ext>
-          </a:extLst>
-        </p:cNvPr>
-        <p:cNvGrpSpPr/>
-        <p:nvPr/>
-      </p:nvGrpSpPr>
-      <p:grpSpPr>
-        <a:xfrm>
-          <a:off x="0" y="0"/>
-          <a:ext cx="0" cy="0"/>
-          <a:chOff x="0" y="0"/>
-          <a:chExt cx="0" cy="0"/>
-        </a:xfrm>
-      </p:grpSpPr>
-      <p:sp>
-        <p:nvSpPr>
-          <p:cNvPr id="2" name="Title 1">
-            <a:extLst>
-              <a:ext uri="{FF2B5EF4-FFF2-40B4-BE49-F238E27FC236}">
-                <a16:creationId xmlns:a16="http://schemas.microsoft.com/office/drawing/2014/main" id="{ACB229D4-F69F-15CA-0AAF-D09012C9537C}"/>
-              </a:ext>
-            </a:extLst>
-          </p:cNvPr>
-          <p:cNvSpPr>
-            <a:spLocks noGrp="1"/>
-          </p:cNvSpPr>
-          <p:nvPr>
-            <p:ph type="title"/>
-          </p:nvPr>
-        </p:nvSpPr>
-        <p:spPr/>
-        <p:txBody>
-          <a:bodyPr/>
-          <a:lstStyle/>
-          <a:p>
-            <a:r>
-              <a:rPr lang="en-US" dirty="0"/>
-              <a:t>Feature Description</a:t>
-            </a:r>
-          </a:p>
-        </p:txBody>
-      </p:sp>
-      <p:sp>
-        <p:nvSpPr>
-          <p:cNvPr id="3" name="Content Placeholder 2">
-            <a:extLst>
-              <a:ext uri="{FF2B5EF4-FFF2-40B4-BE49-F238E27FC236}">
-                <a16:creationId xmlns:a16="http://schemas.microsoft.com/office/drawing/2014/main" id="{CE153657-B0F4-5F3B-6EA0-FA0E61D0D061}"/>
-              </a:ext>
-            </a:extLst>
-          </p:cNvPr>
-          <p:cNvSpPr>
-            <a:spLocks noGrp="1"/>
-          </p:cNvSpPr>
-          <p:nvPr>
-            <p:ph idx="1"/>
-          </p:nvPr>
-        </p:nvSpPr>
-        <p:spPr/>
-        <p:txBody>
-          <a:bodyPr/>
-          <a:lstStyle/>
-          <a:p>
-            <a:endParaRPr lang="en-US" dirty="0"/>
-          </a:p>
-        </p:txBody>
-      </p:sp>
-    </p:spTree>
-    <p:extLst>
-      <p:ext uri="{BB962C8B-B14F-4D97-AF65-F5344CB8AC3E}">
-        <p14:creationId xmlns:p14="http://schemas.microsoft.com/office/powerpoint/2010/main" val="1515804299"/>
       </p:ext>
     </p:extLst>
   </p:cSld>
@@ -4849,6 +4920,164 @@
         <p:cNvPr id="1" name="">
           <a:extLst>
             <a:ext uri="{FF2B5EF4-FFF2-40B4-BE49-F238E27FC236}">
+              <a16:creationId xmlns:a16="http://schemas.microsoft.com/office/drawing/2014/main" id="{109DF938-1D1D-0678-51F7-F5DED296A21F}"/>
+            </a:ext>
+          </a:extLst>
+        </p:cNvPr>
+        <p:cNvGrpSpPr/>
+        <p:nvPr/>
+      </p:nvGrpSpPr>
+      <p:grpSpPr>
+        <a:xfrm>
+          <a:off x="0" y="0"/>
+          <a:ext cx="0" cy="0"/>
+          <a:chOff x="0" y="0"/>
+          <a:chExt cx="0" cy="0"/>
+        </a:xfrm>
+      </p:grpSpPr>
+      <p:sp>
+        <p:nvSpPr>
+          <p:cNvPr id="2" name="Title 1">
+            <a:extLst>
+              <a:ext uri="{FF2B5EF4-FFF2-40B4-BE49-F238E27FC236}">
+                <a16:creationId xmlns:a16="http://schemas.microsoft.com/office/drawing/2014/main" id="{15C0FA39-8116-D64A-21F6-420A283F0048}"/>
+              </a:ext>
+            </a:extLst>
+          </p:cNvPr>
+          <p:cNvSpPr>
+            <a:spLocks noGrp="1"/>
+          </p:cNvSpPr>
+          <p:nvPr>
+            <p:ph type="title"/>
+          </p:nvPr>
+        </p:nvSpPr>
+        <p:spPr>
+          <a:xfrm>
+            <a:off x="4502624" y="2507824"/>
+            <a:ext cx="10515600" cy="1325563"/>
+          </a:xfrm>
+        </p:spPr>
+        <p:txBody>
+          <a:bodyPr/>
+          <a:lstStyle/>
+          <a:p>
+            <a:r>
+              <a:rPr lang="en-US" dirty="0"/>
+              <a:t>Satellite orbit</a:t>
+            </a:r>
+          </a:p>
+        </p:txBody>
+      </p:sp>
+    </p:spTree>
+    <p:extLst>
+      <p:ext uri="{BB962C8B-B14F-4D97-AF65-F5344CB8AC3E}">
+        <p14:creationId xmlns:p14="http://schemas.microsoft.com/office/powerpoint/2010/main" val="2635012408"/>
+      </p:ext>
+    </p:extLst>
+  </p:cSld>
+  <p:clrMapOvr>
+    <a:masterClrMapping/>
+  </p:clrMapOvr>
+</p:sld>
+</file>
+
+<file path=ppt/slides/slide21.xml><?xml version="1.0" encoding="utf-8"?>
+<p:sld xmlns:a="http://schemas.openxmlformats.org/drawingml/2006/main" xmlns:r="http://schemas.openxmlformats.org/officeDocument/2006/relationships" xmlns:p="http://schemas.openxmlformats.org/presentationml/2006/main">
+  <p:cSld>
+    <p:spTree>
+      <p:nvGrpSpPr>
+        <p:cNvPr id="1" name="">
+          <a:extLst>
+            <a:ext uri="{FF2B5EF4-FFF2-40B4-BE49-F238E27FC236}">
+              <a16:creationId xmlns:a16="http://schemas.microsoft.com/office/drawing/2014/main" id="{3F370C48-ECDF-4E43-486E-0629FDC61A7D}"/>
+            </a:ext>
+          </a:extLst>
+        </p:cNvPr>
+        <p:cNvGrpSpPr/>
+        <p:nvPr/>
+      </p:nvGrpSpPr>
+      <p:grpSpPr>
+        <a:xfrm>
+          <a:off x="0" y="0"/>
+          <a:ext cx="0" cy="0"/>
+          <a:chOff x="0" y="0"/>
+          <a:chExt cx="0" cy="0"/>
+        </a:xfrm>
+      </p:grpSpPr>
+      <p:sp>
+        <p:nvSpPr>
+          <p:cNvPr id="2" name="Title 1">
+            <a:extLst>
+              <a:ext uri="{FF2B5EF4-FFF2-40B4-BE49-F238E27FC236}">
+                <a16:creationId xmlns:a16="http://schemas.microsoft.com/office/drawing/2014/main" id="{ACB229D4-F69F-15CA-0AAF-D09012C9537C}"/>
+              </a:ext>
+            </a:extLst>
+          </p:cNvPr>
+          <p:cNvSpPr>
+            <a:spLocks noGrp="1"/>
+          </p:cNvSpPr>
+          <p:nvPr>
+            <p:ph type="title"/>
+          </p:nvPr>
+        </p:nvSpPr>
+        <p:spPr/>
+        <p:txBody>
+          <a:bodyPr/>
+          <a:lstStyle/>
+          <a:p>
+            <a:r>
+              <a:rPr lang="en-US" dirty="0"/>
+              <a:t>Feature Description</a:t>
+            </a:r>
+          </a:p>
+        </p:txBody>
+      </p:sp>
+      <p:sp>
+        <p:nvSpPr>
+          <p:cNvPr id="3" name="Content Placeholder 2">
+            <a:extLst>
+              <a:ext uri="{FF2B5EF4-FFF2-40B4-BE49-F238E27FC236}">
+                <a16:creationId xmlns:a16="http://schemas.microsoft.com/office/drawing/2014/main" id="{CE153657-B0F4-5F3B-6EA0-FA0E61D0D061}"/>
+              </a:ext>
+            </a:extLst>
+          </p:cNvPr>
+          <p:cNvSpPr>
+            <a:spLocks noGrp="1"/>
+          </p:cNvSpPr>
+          <p:nvPr>
+            <p:ph idx="1"/>
+          </p:nvPr>
+        </p:nvSpPr>
+        <p:spPr/>
+        <p:txBody>
+          <a:bodyPr/>
+          <a:lstStyle/>
+          <a:p>
+            <a:endParaRPr lang="en-US" dirty="0"/>
+          </a:p>
+        </p:txBody>
+      </p:sp>
+    </p:spTree>
+    <p:extLst>
+      <p:ext uri="{BB962C8B-B14F-4D97-AF65-F5344CB8AC3E}">
+        <p14:creationId xmlns:p14="http://schemas.microsoft.com/office/powerpoint/2010/main" val="1515804299"/>
+      </p:ext>
+    </p:extLst>
+  </p:cSld>
+  <p:clrMapOvr>
+    <a:masterClrMapping/>
+  </p:clrMapOvr>
+</p:sld>
+</file>
+
+<file path=ppt/slides/slide22.xml><?xml version="1.0" encoding="utf-8"?>
+<p:sld xmlns:a="http://schemas.openxmlformats.org/drawingml/2006/main" xmlns:r="http://schemas.openxmlformats.org/officeDocument/2006/relationships" xmlns:p="http://schemas.openxmlformats.org/presentationml/2006/main">
+  <p:cSld>
+    <p:spTree>
+      <p:nvGrpSpPr>
+        <p:cNvPr id="1" name="">
+          <a:extLst>
+            <a:ext uri="{FF2B5EF4-FFF2-40B4-BE49-F238E27FC236}">
               <a16:creationId xmlns:a16="http://schemas.microsoft.com/office/drawing/2014/main" id="{F843A5F4-DF64-F696-21A9-BF70F464230F}"/>
             </a:ext>
           </a:extLst>
@@ -4930,7 +5159,7 @@
 </p:sld>
 </file>
 
-<file path=ppt/slides/slide21.xml><?xml version="1.0" encoding="utf-8"?>
+<file path=ppt/slides/slide23.xml><?xml version="1.0" encoding="utf-8"?>
 <p:sld xmlns:a="http://schemas.openxmlformats.org/drawingml/2006/main" xmlns:r="http://schemas.openxmlformats.org/officeDocument/2006/relationships" xmlns:p="http://schemas.openxmlformats.org/presentationml/2006/main">
   <p:cSld>
     <p:spTree>
@@ -4999,7 +5228,7 @@
 </p:sld>
 </file>
 
-<file path=ppt/slides/slide22.xml><?xml version="1.0" encoding="utf-8"?>
+<file path=ppt/slides/slide24.xml><?xml version="1.0" encoding="utf-8"?>
 <p:sld xmlns:a="http://schemas.openxmlformats.org/drawingml/2006/main" xmlns:r="http://schemas.openxmlformats.org/officeDocument/2006/relationships" xmlns:p="http://schemas.openxmlformats.org/presentationml/2006/main">
   <p:cSld>
     <p:spTree>
@@ -5088,7 +5317,7 @@
 </p:sld>
 </file>
 
-<file path=ppt/slides/slide23.xml><?xml version="1.0" encoding="utf-8"?>
+<file path=ppt/slides/slide25.xml><?xml version="1.0" encoding="utf-8"?>
 <p:sld xmlns:a="http://schemas.openxmlformats.org/drawingml/2006/main" xmlns:r="http://schemas.openxmlformats.org/officeDocument/2006/relationships" xmlns:p="http://schemas.openxmlformats.org/presentationml/2006/main">
   <p:cSld>
     <p:spTree>
@@ -5213,246 +5442,6 @@
     <p:extLst>
       <p:ext uri="{BB962C8B-B14F-4D97-AF65-F5344CB8AC3E}">
         <p14:creationId xmlns:p14="http://schemas.microsoft.com/office/powerpoint/2010/main" val="2306170173"/>
-      </p:ext>
-    </p:extLst>
-  </p:cSld>
-  <p:clrMapOvr>
-    <a:masterClrMapping/>
-  </p:clrMapOvr>
-</p:sld>
-</file>
-
-<file path=ppt/slides/slide24.xml><?xml version="1.0" encoding="utf-8"?>
-<p:sld xmlns:a="http://schemas.openxmlformats.org/drawingml/2006/main" xmlns:r="http://schemas.openxmlformats.org/officeDocument/2006/relationships" xmlns:p="http://schemas.openxmlformats.org/presentationml/2006/main">
-  <p:cSld>
-    <p:spTree>
-      <p:nvGrpSpPr>
-        <p:cNvPr id="1" name=""/>
-        <p:cNvGrpSpPr/>
-        <p:nvPr/>
-      </p:nvGrpSpPr>
-      <p:grpSpPr>
-        <a:xfrm>
-          <a:off x="0" y="0"/>
-          <a:ext cx="0" cy="0"/>
-          <a:chOff x="0" y="0"/>
-          <a:chExt cx="0" cy="0"/>
-        </a:xfrm>
-      </p:grpSpPr>
-      <p:sp>
-        <p:nvSpPr>
-          <p:cNvPr id="2" name="Title 1">
-            <a:extLst>
-              <a:ext uri="{FF2B5EF4-FFF2-40B4-BE49-F238E27FC236}">
-                <a16:creationId xmlns:a16="http://schemas.microsoft.com/office/drawing/2014/main" id="{F893E47E-0152-DBA2-F5C6-81C9CDF39D31}"/>
-              </a:ext>
-            </a:extLst>
-          </p:cNvPr>
-          <p:cNvSpPr>
-            <a:spLocks noGrp="1"/>
-          </p:cNvSpPr>
-          <p:nvPr>
-            <p:ph type="title"/>
-          </p:nvPr>
-        </p:nvSpPr>
-        <p:spPr>
-          <a:xfrm>
-            <a:off x="838200" y="2535119"/>
-            <a:ext cx="10515600" cy="1325563"/>
-          </a:xfrm>
-        </p:spPr>
-        <p:txBody>
-          <a:bodyPr/>
-          <a:lstStyle/>
-          <a:p>
-            <a:pPr algn="ctr"/>
-            <a:r>
-              <a:rPr lang="en-US" dirty="0"/>
-              <a:t>Problems Overcome</a:t>
-            </a:r>
-          </a:p>
-        </p:txBody>
-      </p:sp>
-    </p:spTree>
-    <p:extLst>
-      <p:ext uri="{BB962C8B-B14F-4D97-AF65-F5344CB8AC3E}">
-        <p14:creationId xmlns:p14="http://schemas.microsoft.com/office/powerpoint/2010/main" val="2641203556"/>
-      </p:ext>
-    </p:extLst>
-  </p:cSld>
-  <p:clrMapOvr>
-    <a:masterClrMapping/>
-  </p:clrMapOvr>
-</p:sld>
-</file>
-
-<file path=ppt/slides/slide25.xml><?xml version="1.0" encoding="utf-8"?>
-<p:sld xmlns:a="http://schemas.openxmlformats.org/drawingml/2006/main" xmlns:r="http://schemas.openxmlformats.org/officeDocument/2006/relationships" xmlns:p="http://schemas.openxmlformats.org/presentationml/2006/main">
-  <p:cSld>
-    <p:spTree>
-      <p:nvGrpSpPr>
-        <p:cNvPr id="1" name=""/>
-        <p:cNvGrpSpPr/>
-        <p:nvPr/>
-      </p:nvGrpSpPr>
-      <p:grpSpPr>
-        <a:xfrm>
-          <a:off x="0" y="0"/>
-          <a:ext cx="0" cy="0"/>
-          <a:chOff x="0" y="0"/>
-          <a:chExt cx="0" cy="0"/>
-        </a:xfrm>
-      </p:grpSpPr>
-      <p:sp>
-        <p:nvSpPr>
-          <p:cNvPr id="2" name="Title 1">
-            <a:extLst>
-              <a:ext uri="{FF2B5EF4-FFF2-40B4-BE49-F238E27FC236}">
-                <a16:creationId xmlns:a16="http://schemas.microsoft.com/office/drawing/2014/main" id="{B8475666-74FD-6490-7B22-B1FC1E75E04E}"/>
-              </a:ext>
-            </a:extLst>
-          </p:cNvPr>
-          <p:cNvSpPr>
-            <a:spLocks noGrp="1"/>
-          </p:cNvSpPr>
-          <p:nvPr>
-            <p:ph type="title"/>
-          </p:nvPr>
-        </p:nvSpPr>
-        <p:spPr/>
-        <p:txBody>
-          <a:bodyPr/>
-          <a:lstStyle/>
-          <a:p>
-            <a:r>
-              <a:rPr lang="en-US" dirty="0"/>
-              <a:t>Earth Occlusion of LOS</a:t>
-            </a:r>
-          </a:p>
-        </p:txBody>
-      </p:sp>
-      <p:sp>
-        <p:nvSpPr>
-          <p:cNvPr id="3" name="Content Placeholder 2">
-            <a:extLst>
-              <a:ext uri="{FF2B5EF4-FFF2-40B4-BE49-F238E27FC236}">
-                <a16:creationId xmlns:a16="http://schemas.microsoft.com/office/drawing/2014/main" id="{AD609CE9-6468-D8EE-A7B7-4ADA8A032E0F}"/>
-              </a:ext>
-            </a:extLst>
-          </p:cNvPr>
-          <p:cNvSpPr>
-            <a:spLocks noGrp="1"/>
-          </p:cNvSpPr>
-          <p:nvPr>
-            <p:ph idx="1"/>
-          </p:nvPr>
-        </p:nvSpPr>
-        <p:spPr/>
-        <p:txBody>
-          <a:bodyPr>
-            <a:normAutofit/>
-          </a:bodyPr>
-          <a:lstStyle/>
-          <a:p>
-            <a:r>
-              <a:rPr lang="en-US" sz="1800" dirty="0"/>
-              <a:t>How do I calculate whether or not 2 bodies (points) have LOS or are occluded by the earth using </a:t>
-            </a:r>
-            <a:r>
-              <a:rPr lang="en-US" sz="1800" dirty="0" err="1"/>
-              <a:t>lin</a:t>
-            </a:r>
-            <a:r>
-              <a:rPr lang="en-US" sz="1800" dirty="0"/>
-              <a:t> </a:t>
-            </a:r>
-            <a:r>
-              <a:rPr lang="en-US" sz="1800" dirty="0" err="1"/>
-              <a:t>alg</a:t>
-            </a:r>
-            <a:r>
-              <a:rPr lang="en-US" sz="1800" dirty="0"/>
-              <a:t>?</a:t>
-            </a:r>
-          </a:p>
-          <a:p>
-            <a:r>
-              <a:rPr lang="en-US" sz="1800" dirty="0"/>
-              <a:t>Pointing Vector is d =  B-A  </a:t>
-            </a:r>
-          </a:p>
-          <a:p>
-            <a:r>
-              <a:rPr lang="en-US" sz="1800" dirty="0"/>
-              <a:t>Treat vector pointing A to B is D(t) = ||A + td||</a:t>
-            </a:r>
-          </a:p>
-          <a:p>
-            <a:r>
-              <a:rPr lang="en-US" sz="1800" dirty="0"/>
-              <a:t>Minimizing the square has simpler math properties, would have to use chain rule without square</a:t>
-            </a:r>
-          </a:p>
-          <a:p>
-            <a:r>
-              <a:rPr lang="en-US" sz="1800" dirty="0"/>
-              <a:t>D^2(t)= A dot A + 2t (A dot d) + t^2 (d dot d)  Squaring norm is same as dotting norm with self</a:t>
-            </a:r>
-          </a:p>
-          <a:p>
-            <a:r>
-              <a:rPr lang="en-US" sz="1800" dirty="0"/>
-              <a:t>d/dt D^2’(t) = 2t (d dot d) + 2 (A dot d)</a:t>
-            </a:r>
-          </a:p>
-          <a:p>
-            <a:r>
-              <a:rPr lang="en-US" sz="1800" dirty="0"/>
-              <a:t>0 = 2t (d dot d) + 2 (A dot d)</a:t>
-            </a:r>
-          </a:p>
-          <a:p>
-            <a:r>
-              <a:rPr lang="en-US" sz="1800" dirty="0"/>
-              <a:t>-(A dot d)= t(d dot d)    Can do division because dot products are scalar output</a:t>
-            </a:r>
-          </a:p>
-          <a:p>
-            <a:r>
-              <a:rPr lang="en-US" sz="1800" dirty="0"/>
-              <a:t>t = - (A dot d) / ||d||^2       d dot d is a norm squared</a:t>
-            </a:r>
-          </a:p>
-          <a:p>
-            <a:r>
-              <a:rPr lang="en-US" sz="1800" dirty="0"/>
-              <a:t>Can then calculate that point and if its norm is &lt; radius of earth then no LOS</a:t>
-            </a:r>
-          </a:p>
-          <a:p>
-            <a:endParaRPr lang="en-US" sz="1800" dirty="0"/>
-          </a:p>
-          <a:p>
-            <a:endParaRPr lang="en-US" sz="1800" dirty="0"/>
-          </a:p>
-          <a:p>
-            <a:endParaRPr lang="en-US" sz="1800" dirty="0"/>
-          </a:p>
-          <a:p>
-            <a:endParaRPr lang="en-US" sz="1800" dirty="0"/>
-          </a:p>
-          <a:p>
-            <a:endParaRPr lang="en-US" sz="1800" dirty="0"/>
-          </a:p>
-          <a:p>
-            <a:endParaRPr lang="en-US" sz="1800" dirty="0"/>
-          </a:p>
-        </p:txBody>
-      </p:sp>
-    </p:spTree>
-    <p:extLst>
-      <p:ext uri="{BB962C8B-B14F-4D97-AF65-F5344CB8AC3E}">
-        <p14:creationId xmlns:p14="http://schemas.microsoft.com/office/powerpoint/2010/main" val="4060347343"/>
       </p:ext>
     </p:extLst>
   </p:cSld>
@@ -5484,7 +5473,7 @@
           <p:cNvPr id="2" name="Title 1">
             <a:extLst>
               <a:ext uri="{FF2B5EF4-FFF2-40B4-BE49-F238E27FC236}">
-                <a16:creationId xmlns:a16="http://schemas.microsoft.com/office/drawing/2014/main" id="{2BD7E637-0A0C-B2FC-AE0E-35E5AF1998A5}"/>
+                <a16:creationId xmlns:a16="http://schemas.microsoft.com/office/drawing/2014/main" id="{F893E47E-0152-DBA2-F5C6-81C9CDF39D31}"/>
               </a:ext>
             </a:extLst>
           </p:cNvPr>
@@ -5497,21 +5486,18 @@
         </p:nvSpPr>
         <p:spPr>
           <a:xfrm>
-            <a:off x="4352499" y="2705716"/>
-            <a:ext cx="4882941" cy="1325563"/>
+            <a:off x="838200" y="2535119"/>
+            <a:ext cx="10515600" cy="1325563"/>
           </a:xfrm>
         </p:spPr>
         <p:txBody>
           <a:bodyPr/>
           <a:lstStyle/>
           <a:p>
-            <a:r>
-              <a:rPr lang="en-US" dirty="0" err="1"/>
-              <a:t>Misc</a:t>
-            </a:r>
-            <a:r>
-              <a:rPr lang="en-US" dirty="0"/>
-              <a:t> Loose Ends</a:t>
+            <a:pPr algn="ctr"/>
+            <a:r>
+              <a:rPr lang="en-US" dirty="0"/>
+              <a:t>Problems Overcome</a:t>
             </a:r>
           </a:p>
         </p:txBody>
@@ -5519,7 +5505,7 @@
     </p:spTree>
     <p:extLst>
       <p:ext uri="{BB962C8B-B14F-4D97-AF65-F5344CB8AC3E}">
-        <p14:creationId xmlns:p14="http://schemas.microsoft.com/office/powerpoint/2010/main" val="1216898861"/>
+        <p14:creationId xmlns:p14="http://schemas.microsoft.com/office/powerpoint/2010/main" val="2641203556"/>
       </p:ext>
     </p:extLst>
   </p:cSld>
@@ -5551,7 +5537,7 @@
           <p:cNvPr id="2" name="Title 1">
             <a:extLst>
               <a:ext uri="{FF2B5EF4-FFF2-40B4-BE49-F238E27FC236}">
-                <a16:creationId xmlns:a16="http://schemas.microsoft.com/office/drawing/2014/main" id="{269FB068-6AD7-6770-B2A7-107A9F4366FC}"/>
+                <a16:creationId xmlns:a16="http://schemas.microsoft.com/office/drawing/2014/main" id="{B8475666-74FD-6490-7B22-B1FC1E75E04E}"/>
               </a:ext>
             </a:extLst>
           </p:cNvPr>
@@ -5569,7 +5555,7 @@
           <a:p>
             <a:r>
               <a:rPr lang="en-US" dirty="0"/>
-              <a:t>Coding</a:t>
+              <a:t>Earth Occlusion of LOS</a:t>
             </a:r>
           </a:p>
         </p:txBody>
@@ -5579,7 +5565,7 @@
           <p:cNvPr id="3" name="Content Placeholder 2">
             <a:extLst>
               <a:ext uri="{FF2B5EF4-FFF2-40B4-BE49-F238E27FC236}">
-                <a16:creationId xmlns:a16="http://schemas.microsoft.com/office/drawing/2014/main" id="{857A8299-9CED-A1FE-0C2C-CB75D4FCE0BB}"/>
+                <a16:creationId xmlns:a16="http://schemas.microsoft.com/office/drawing/2014/main" id="{AD609CE9-6468-D8EE-A7B7-4ADA8A032E0F}"/>
               </a:ext>
             </a:extLst>
           </p:cNvPr>
@@ -5592,32 +5578,110 @@
         </p:nvSpPr>
         <p:spPr/>
         <p:txBody>
-          <a:bodyPr/>
-          <a:lstStyle/>
-          <a:p>
-            <a:pPr marL="0" indent="0">
-              <a:buNone/>
-            </a:pPr>
-            <a:r>
-              <a:rPr lang="en-US" dirty="0"/>
-              <a:t>Const Expr</a:t>
-            </a:r>
-          </a:p>
-          <a:p>
-            <a:pPr marL="0" indent="0">
-              <a:buNone/>
-            </a:pPr>
-            <a:endParaRPr lang="en-US" dirty="0"/>
-          </a:p>
-          <a:p>
-            <a:endParaRPr lang="en-US" dirty="0"/>
+          <a:bodyPr>
+            <a:normAutofit/>
+          </a:bodyPr>
+          <a:lstStyle/>
+          <a:p>
+            <a:r>
+              <a:rPr lang="en-US" sz="1800" dirty="0"/>
+              <a:t>How do I calculate whether or not 2 bodies (points) have LOS or are occluded by the earth using </a:t>
+            </a:r>
+            <a:r>
+              <a:rPr lang="en-US" sz="1800" dirty="0" err="1"/>
+              <a:t>lin</a:t>
+            </a:r>
+            <a:r>
+              <a:rPr lang="en-US" sz="1800" dirty="0"/>
+              <a:t> </a:t>
+            </a:r>
+            <a:r>
+              <a:rPr lang="en-US" sz="1800" dirty="0" err="1"/>
+              <a:t>alg</a:t>
+            </a:r>
+            <a:r>
+              <a:rPr lang="en-US" sz="1800" dirty="0"/>
+              <a:t>?</a:t>
+            </a:r>
+          </a:p>
+          <a:p>
+            <a:r>
+              <a:rPr lang="en-US" sz="1800" dirty="0"/>
+              <a:t>Pointing Vector is d =  B-A  </a:t>
+            </a:r>
+          </a:p>
+          <a:p>
+            <a:r>
+              <a:rPr lang="en-US" sz="1800" dirty="0"/>
+              <a:t>Treat vector pointing A to B is D(t) = ||A + td||</a:t>
+            </a:r>
+          </a:p>
+          <a:p>
+            <a:r>
+              <a:rPr lang="en-US" sz="1800" dirty="0"/>
+              <a:t>Minimizing the square has simpler math properties, would have to use chain rule without square</a:t>
+            </a:r>
+          </a:p>
+          <a:p>
+            <a:r>
+              <a:rPr lang="en-US" sz="1800" dirty="0"/>
+              <a:t>D^2(t)= A dot A + 2t (A dot d) + t^2 (d dot d)  Squaring norm is same as dotting norm with self</a:t>
+            </a:r>
+          </a:p>
+          <a:p>
+            <a:r>
+              <a:rPr lang="en-US" sz="1800" dirty="0"/>
+              <a:t>d/dt D^2’(t) = 2t (d dot d) + 2 (A dot d)</a:t>
+            </a:r>
+          </a:p>
+          <a:p>
+            <a:r>
+              <a:rPr lang="en-US" sz="1800" dirty="0"/>
+              <a:t>0 = 2t (d dot d) + 2 (A dot d)</a:t>
+            </a:r>
+          </a:p>
+          <a:p>
+            <a:r>
+              <a:rPr lang="en-US" sz="1800" dirty="0"/>
+              <a:t>-(A dot d)= t(d dot d)    Can do division because dot products are scalar output</a:t>
+            </a:r>
+          </a:p>
+          <a:p>
+            <a:r>
+              <a:rPr lang="en-US" sz="1800" dirty="0"/>
+              <a:t>t = - (A dot d) / ||d||^2       d dot d is a norm squared</a:t>
+            </a:r>
+          </a:p>
+          <a:p>
+            <a:r>
+              <a:rPr lang="en-US" sz="1800" dirty="0"/>
+              <a:t>Can then calculate that point and if its norm is &lt; radius of earth then no LOS</a:t>
+            </a:r>
+          </a:p>
+          <a:p>
+            <a:endParaRPr lang="en-US" sz="1800" dirty="0"/>
+          </a:p>
+          <a:p>
+            <a:endParaRPr lang="en-US" sz="1800" dirty="0"/>
+          </a:p>
+          <a:p>
+            <a:endParaRPr lang="en-US" sz="1800" dirty="0"/>
+          </a:p>
+          <a:p>
+            <a:endParaRPr lang="en-US" sz="1800" dirty="0"/>
+          </a:p>
+          <a:p>
+            <a:endParaRPr lang="en-US" sz="1800" dirty="0"/>
+          </a:p>
+          <a:p>
+            <a:endParaRPr lang="en-US" sz="1800" dirty="0"/>
           </a:p>
         </p:txBody>
       </p:sp>
     </p:spTree>
     <p:extLst>
       <p:ext uri="{BB962C8B-B14F-4D97-AF65-F5344CB8AC3E}">
-        <p14:creationId xmlns:p14="http://schemas.microsoft.com/office/powerpoint/2010/main" val="4128986287"/>
+        <p14:creationId xmlns:p14="http://schemas.microsoft.com/office/powerpoint/2010/main" val="4060347343"/>
       </p:ext>
     </p:extLst>
   </p:cSld>
@@ -5649,6 +5713,240 @@
           <p:cNvPr id="2" name="Title 1">
             <a:extLst>
               <a:ext uri="{FF2B5EF4-FFF2-40B4-BE49-F238E27FC236}">
+                <a16:creationId xmlns:a16="http://schemas.microsoft.com/office/drawing/2014/main" id="{2BD7E637-0A0C-B2FC-AE0E-35E5AF1998A5}"/>
+              </a:ext>
+            </a:extLst>
+          </p:cNvPr>
+          <p:cNvSpPr>
+            <a:spLocks noGrp="1"/>
+          </p:cNvSpPr>
+          <p:nvPr>
+            <p:ph type="title"/>
+          </p:nvPr>
+        </p:nvSpPr>
+        <p:spPr>
+          <a:xfrm>
+            <a:off x="4352499" y="2705716"/>
+            <a:ext cx="4882941" cy="1325563"/>
+          </a:xfrm>
+        </p:spPr>
+        <p:txBody>
+          <a:bodyPr/>
+          <a:lstStyle/>
+          <a:p>
+            <a:r>
+              <a:rPr lang="en-US" dirty="0" err="1"/>
+              <a:t>Misc</a:t>
+            </a:r>
+            <a:r>
+              <a:rPr lang="en-US" dirty="0"/>
+              <a:t> Loose Ends</a:t>
+            </a:r>
+          </a:p>
+        </p:txBody>
+      </p:sp>
+    </p:spTree>
+    <p:extLst>
+      <p:ext uri="{BB962C8B-B14F-4D97-AF65-F5344CB8AC3E}">
+        <p14:creationId xmlns:p14="http://schemas.microsoft.com/office/powerpoint/2010/main" val="1216898861"/>
+      </p:ext>
+    </p:extLst>
+  </p:cSld>
+  <p:clrMapOvr>
+    <a:masterClrMapping/>
+  </p:clrMapOvr>
+</p:sld>
+</file>
+
+<file path=ppt/slides/slide29.xml><?xml version="1.0" encoding="utf-8"?>
+<p:sld xmlns:a="http://schemas.openxmlformats.org/drawingml/2006/main" xmlns:r="http://schemas.openxmlformats.org/officeDocument/2006/relationships" xmlns:p="http://schemas.openxmlformats.org/presentationml/2006/main">
+  <p:cSld>
+    <p:spTree>
+      <p:nvGrpSpPr>
+        <p:cNvPr id="1" name=""/>
+        <p:cNvGrpSpPr/>
+        <p:nvPr/>
+      </p:nvGrpSpPr>
+      <p:grpSpPr>
+        <a:xfrm>
+          <a:off x="0" y="0"/>
+          <a:ext cx="0" cy="0"/>
+          <a:chOff x="0" y="0"/>
+          <a:chExt cx="0" cy="0"/>
+        </a:xfrm>
+      </p:grpSpPr>
+      <p:sp>
+        <p:nvSpPr>
+          <p:cNvPr id="2" name="Title 1">
+            <a:extLst>
+              <a:ext uri="{FF2B5EF4-FFF2-40B4-BE49-F238E27FC236}">
+                <a16:creationId xmlns:a16="http://schemas.microsoft.com/office/drawing/2014/main" id="{269FB068-6AD7-6770-B2A7-107A9F4366FC}"/>
+              </a:ext>
+            </a:extLst>
+          </p:cNvPr>
+          <p:cNvSpPr>
+            <a:spLocks noGrp="1"/>
+          </p:cNvSpPr>
+          <p:nvPr>
+            <p:ph type="title"/>
+          </p:nvPr>
+        </p:nvSpPr>
+        <p:spPr/>
+        <p:txBody>
+          <a:bodyPr/>
+          <a:lstStyle/>
+          <a:p>
+            <a:r>
+              <a:rPr lang="en-US" dirty="0"/>
+              <a:t>Coding</a:t>
+            </a:r>
+          </a:p>
+        </p:txBody>
+      </p:sp>
+      <p:sp>
+        <p:nvSpPr>
+          <p:cNvPr id="3" name="Content Placeholder 2">
+            <a:extLst>
+              <a:ext uri="{FF2B5EF4-FFF2-40B4-BE49-F238E27FC236}">
+                <a16:creationId xmlns:a16="http://schemas.microsoft.com/office/drawing/2014/main" id="{857A8299-9CED-A1FE-0C2C-CB75D4FCE0BB}"/>
+              </a:ext>
+            </a:extLst>
+          </p:cNvPr>
+          <p:cNvSpPr>
+            <a:spLocks noGrp="1"/>
+          </p:cNvSpPr>
+          <p:nvPr>
+            <p:ph idx="1"/>
+          </p:nvPr>
+        </p:nvSpPr>
+        <p:spPr/>
+        <p:txBody>
+          <a:bodyPr/>
+          <a:lstStyle/>
+          <a:p>
+            <a:pPr marL="0" indent="0">
+              <a:buNone/>
+            </a:pPr>
+            <a:r>
+              <a:rPr lang="en-US" dirty="0"/>
+              <a:t>Const Expr</a:t>
+            </a:r>
+          </a:p>
+          <a:p>
+            <a:pPr marL="0" indent="0">
+              <a:buNone/>
+            </a:pPr>
+            <a:endParaRPr lang="en-US" dirty="0"/>
+          </a:p>
+          <a:p>
+            <a:endParaRPr lang="en-US" dirty="0"/>
+          </a:p>
+        </p:txBody>
+      </p:sp>
+    </p:spTree>
+    <p:extLst>
+      <p:ext uri="{BB962C8B-B14F-4D97-AF65-F5344CB8AC3E}">
+        <p14:creationId xmlns:p14="http://schemas.microsoft.com/office/powerpoint/2010/main" val="4128986287"/>
+      </p:ext>
+    </p:extLst>
+  </p:cSld>
+  <p:clrMapOvr>
+    <a:masterClrMapping/>
+  </p:clrMapOvr>
+</p:sld>
+</file>
+
+<file path=ppt/slides/slide3.xml><?xml version="1.0" encoding="utf-8"?>
+<p:sld xmlns:a="http://schemas.openxmlformats.org/drawingml/2006/main" xmlns:r="http://schemas.openxmlformats.org/officeDocument/2006/relationships" xmlns:p="http://schemas.openxmlformats.org/presentationml/2006/main">
+  <p:cSld>
+    <p:spTree>
+      <p:nvGrpSpPr>
+        <p:cNvPr id="1" name="">
+          <a:extLst>
+            <a:ext uri="{FF2B5EF4-FFF2-40B4-BE49-F238E27FC236}">
+              <a16:creationId xmlns:a16="http://schemas.microsoft.com/office/drawing/2014/main" id="{6DF60001-E379-8EB7-24E7-CCB82C2A0026}"/>
+            </a:ext>
+          </a:extLst>
+        </p:cNvPr>
+        <p:cNvGrpSpPr/>
+        <p:nvPr/>
+      </p:nvGrpSpPr>
+      <p:grpSpPr>
+        <a:xfrm>
+          <a:off x="0" y="0"/>
+          <a:ext cx="0" cy="0"/>
+          <a:chOff x="0" y="0"/>
+          <a:chExt cx="0" cy="0"/>
+        </a:xfrm>
+      </p:grpSpPr>
+      <p:sp>
+        <p:nvSpPr>
+          <p:cNvPr id="2" name="Title 1">
+            <a:extLst>
+              <a:ext uri="{FF2B5EF4-FFF2-40B4-BE49-F238E27FC236}">
+                <a16:creationId xmlns:a16="http://schemas.microsoft.com/office/drawing/2014/main" id="{157065B4-9020-3A3E-303E-9405EE359C91}"/>
+              </a:ext>
+            </a:extLst>
+          </p:cNvPr>
+          <p:cNvSpPr>
+            <a:spLocks noGrp="1"/>
+          </p:cNvSpPr>
+          <p:nvPr>
+            <p:ph type="title"/>
+          </p:nvPr>
+        </p:nvSpPr>
+        <p:spPr>
+          <a:xfrm>
+            <a:off x="1834487" y="2712540"/>
+            <a:ext cx="10515600" cy="1325563"/>
+          </a:xfrm>
+        </p:spPr>
+        <p:txBody>
+          <a:bodyPr/>
+          <a:lstStyle/>
+          <a:p>
+            <a:r>
+              <a:rPr lang="en-US" dirty="0"/>
+              <a:t>Simulation Architecture</a:t>
+            </a:r>
+          </a:p>
+        </p:txBody>
+      </p:sp>
+    </p:spTree>
+    <p:extLst>
+      <p:ext uri="{BB962C8B-B14F-4D97-AF65-F5344CB8AC3E}">
+        <p14:creationId xmlns:p14="http://schemas.microsoft.com/office/powerpoint/2010/main" val="2935349719"/>
+      </p:ext>
+    </p:extLst>
+  </p:cSld>
+  <p:clrMapOvr>
+    <a:masterClrMapping/>
+  </p:clrMapOvr>
+</p:sld>
+</file>
+
+<file path=ppt/slides/slide30.xml><?xml version="1.0" encoding="utf-8"?>
+<p:sld xmlns:a="http://schemas.openxmlformats.org/drawingml/2006/main" xmlns:r="http://schemas.openxmlformats.org/officeDocument/2006/relationships" xmlns:p="http://schemas.openxmlformats.org/presentationml/2006/main">
+  <p:cSld>
+    <p:spTree>
+      <p:nvGrpSpPr>
+        <p:cNvPr id="1" name=""/>
+        <p:cNvGrpSpPr/>
+        <p:nvPr/>
+      </p:nvGrpSpPr>
+      <p:grpSpPr>
+        <a:xfrm>
+          <a:off x="0" y="0"/>
+          <a:ext cx="0" cy="0"/>
+          <a:chOff x="0" y="0"/>
+          <a:chExt cx="0" cy="0"/>
+        </a:xfrm>
+      </p:grpSpPr>
+      <p:sp>
+        <p:nvSpPr>
+          <p:cNvPr id="2" name="Title 1">
+            <a:extLst>
+              <a:ext uri="{FF2B5EF4-FFF2-40B4-BE49-F238E27FC236}">
                 <a16:creationId xmlns:a16="http://schemas.microsoft.com/office/drawing/2014/main" id="{18DE167B-A416-AF8F-041B-A98D78C25FB2}"/>
               </a:ext>
             </a:extLst>
@@ -5685,7 +5983,7 @@
 </p:sld>
 </file>
 
-<file path=ppt/slides/slide29.xml><?xml version="1.0" encoding="utf-8"?>
+<file path=ppt/slides/slide31.xml><?xml version="1.0" encoding="utf-8"?>
 <p:sld xmlns:a="http://schemas.openxmlformats.org/drawingml/2006/main" xmlns:r="http://schemas.openxmlformats.org/officeDocument/2006/relationships" xmlns:p="http://schemas.openxmlformats.org/presentationml/2006/main">
   <p:cSld>
     <p:spTree>
@@ -5773,75 +6071,6 @@
 </p:sld>
 </file>
 
-<file path=ppt/slides/slide3.xml><?xml version="1.0" encoding="utf-8"?>
-<p:sld xmlns:a="http://schemas.openxmlformats.org/drawingml/2006/main" xmlns:r="http://schemas.openxmlformats.org/officeDocument/2006/relationships" xmlns:p="http://schemas.openxmlformats.org/presentationml/2006/main">
-  <p:cSld>
-    <p:spTree>
-      <p:nvGrpSpPr>
-        <p:cNvPr id="1" name="">
-          <a:extLst>
-            <a:ext uri="{FF2B5EF4-FFF2-40B4-BE49-F238E27FC236}">
-              <a16:creationId xmlns:a16="http://schemas.microsoft.com/office/drawing/2014/main" id="{6DF60001-E379-8EB7-24E7-CCB82C2A0026}"/>
-            </a:ext>
-          </a:extLst>
-        </p:cNvPr>
-        <p:cNvGrpSpPr/>
-        <p:nvPr/>
-      </p:nvGrpSpPr>
-      <p:grpSpPr>
-        <a:xfrm>
-          <a:off x="0" y="0"/>
-          <a:ext cx="0" cy="0"/>
-          <a:chOff x="0" y="0"/>
-          <a:chExt cx="0" cy="0"/>
-        </a:xfrm>
-      </p:grpSpPr>
-      <p:sp>
-        <p:nvSpPr>
-          <p:cNvPr id="2" name="Title 1">
-            <a:extLst>
-              <a:ext uri="{FF2B5EF4-FFF2-40B4-BE49-F238E27FC236}">
-                <a16:creationId xmlns:a16="http://schemas.microsoft.com/office/drawing/2014/main" id="{157065B4-9020-3A3E-303E-9405EE359C91}"/>
-              </a:ext>
-            </a:extLst>
-          </p:cNvPr>
-          <p:cNvSpPr>
-            <a:spLocks noGrp="1"/>
-          </p:cNvSpPr>
-          <p:nvPr>
-            <p:ph type="title"/>
-          </p:nvPr>
-        </p:nvSpPr>
-        <p:spPr>
-          <a:xfrm>
-            <a:off x="1834487" y="2712540"/>
-            <a:ext cx="10515600" cy="1325563"/>
-          </a:xfrm>
-        </p:spPr>
-        <p:txBody>
-          <a:bodyPr/>
-          <a:lstStyle/>
-          <a:p>
-            <a:r>
-              <a:rPr lang="en-US" dirty="0"/>
-              <a:t>Simulation Architecture</a:t>
-            </a:r>
-          </a:p>
-        </p:txBody>
-      </p:sp>
-    </p:spTree>
-    <p:extLst>
-      <p:ext uri="{BB962C8B-B14F-4D97-AF65-F5344CB8AC3E}">
-        <p14:creationId xmlns:p14="http://schemas.microsoft.com/office/powerpoint/2010/main" val="2935349719"/>
-      </p:ext>
-    </p:extLst>
-  </p:cSld>
-  <p:clrMapOvr>
-    <a:masterClrMapping/>
-  </p:clrMapOvr>
-</p:sld>
-</file>
-
 <file path=ppt/slides/slide4.xml><?xml version="1.0" encoding="utf-8"?>
 <p:sld xmlns:a="http://schemas.openxmlformats.org/drawingml/2006/main" xmlns:r="http://schemas.openxmlformats.org/officeDocument/2006/relationships" xmlns:p="http://schemas.openxmlformats.org/presentationml/2006/main">
   <p:cSld>
@@ -6095,13 +6324,8 @@
             </a:r>
             <a:r>
               <a:rPr lang="en-US" dirty="0"/>
-              <a:t>,  call system that takes in current kinematic state and control  and outputs the new </a:t>
-            </a:r>
-            <a:r>
-              <a:rPr lang="en-US"/>
-              <a:t>state with just math</a:t>
-            </a:r>
-            <a:endParaRPr lang="en-US" dirty="0"/>
+              <a:t>,  call system that takes in current kinematic state and control  and outputs the new state with just math</a:t>
+            </a:r>
           </a:p>
           <a:p>
             <a:endParaRPr lang="en-US" dirty="0"/>
@@ -6156,6 +6380,320 @@
   <p:cSld>
     <p:spTree>
       <p:nvGrpSpPr>
+        <p:cNvPr id="1" name=""/>
+        <p:cNvGrpSpPr/>
+        <p:nvPr/>
+      </p:nvGrpSpPr>
+      <p:grpSpPr>
+        <a:xfrm>
+          <a:off x="0" y="0"/>
+          <a:ext cx="0" cy="0"/>
+          <a:chOff x="0" y="0"/>
+          <a:chExt cx="0" cy="0"/>
+        </a:xfrm>
+      </p:grpSpPr>
+      <p:sp>
+        <p:nvSpPr>
+          <p:cNvPr id="2" name="Title 1">
+            <a:extLst>
+              <a:ext uri="{FF2B5EF4-FFF2-40B4-BE49-F238E27FC236}">
+                <a16:creationId xmlns:a16="http://schemas.microsoft.com/office/drawing/2014/main" id="{B2C25C08-D46B-8138-F854-C2438DECAA08}"/>
+              </a:ext>
+            </a:extLst>
+          </p:cNvPr>
+          <p:cNvSpPr>
+            <a:spLocks noGrp="1"/>
+          </p:cNvSpPr>
+          <p:nvPr>
+            <p:ph type="title"/>
+          </p:nvPr>
+        </p:nvSpPr>
+        <p:spPr/>
+        <p:txBody>
+          <a:bodyPr/>
+          <a:lstStyle/>
+          <a:p>
+            <a:r>
+              <a:rPr lang="en-US" dirty="0"/>
+              <a:t>How to organize entity/component/systems</a:t>
+            </a:r>
+          </a:p>
+        </p:txBody>
+      </p:sp>
+      <p:sp>
+        <p:nvSpPr>
+          <p:cNvPr id="3" name="Content Placeholder 2">
+            <a:extLst>
+              <a:ext uri="{FF2B5EF4-FFF2-40B4-BE49-F238E27FC236}">
+                <a16:creationId xmlns:a16="http://schemas.microsoft.com/office/drawing/2014/main" id="{D94C250C-222A-E5E7-DD61-BB50BE20F8E7}"/>
+              </a:ext>
+            </a:extLst>
+          </p:cNvPr>
+          <p:cNvSpPr>
+            <a:spLocks noGrp="1"/>
+          </p:cNvSpPr>
+          <p:nvPr>
+            <p:ph idx="1"/>
+          </p:nvPr>
+        </p:nvSpPr>
+        <p:spPr>
+          <a:xfrm>
+            <a:off x="385046" y="1690688"/>
+            <a:ext cx="8297708" cy="4187192"/>
+          </a:xfrm>
+        </p:spPr>
+        <p:txBody>
+          <a:bodyPr>
+            <a:normAutofit lnSpcReduction="10000"/>
+          </a:bodyPr>
+          <a:lstStyle/>
+          <a:p>
+            <a:r>
+              <a:rPr lang="en-US" dirty="0"/>
+              <a:t>Have to decide on a hierarchy of calls as I have objects with differing sets of data that are updated using systems which vary based on models used. The concern is that I end up with blurring the lines a lot and the code gets very messy without clear </a:t>
+            </a:r>
+            <a:r>
+              <a:rPr lang="en-US" dirty="0" err="1"/>
+              <a:t>ly</a:t>
+            </a:r>
+            <a:r>
+              <a:rPr lang="en-US" dirty="0"/>
+              <a:t> laid out boundaries of what owns what.</a:t>
+            </a:r>
+          </a:p>
+          <a:p>
+            <a:r>
+              <a:rPr lang="en-US" dirty="0"/>
+              <a:t>I am trying to avoid making things entity specific or not general enough as a missile could eventually have a radar, or a radar on the move or something which would result in weirdness if the models are derived from entity and not attached components</a:t>
+            </a:r>
+          </a:p>
+        </p:txBody>
+      </p:sp>
+      <p:pic>
+        <p:nvPicPr>
+          <p:cNvPr id="5" name="Picture 4">
+            <a:extLst>
+              <a:ext uri="{FF2B5EF4-FFF2-40B4-BE49-F238E27FC236}">
+                <a16:creationId xmlns:a16="http://schemas.microsoft.com/office/drawing/2014/main" id="{DB01CAA7-E986-8685-6273-B6099C7A7E48}"/>
+              </a:ext>
+            </a:extLst>
+          </p:cNvPr>
+          <p:cNvPicPr>
+            <a:picLocks noChangeAspect="1"/>
+          </p:cNvPicPr>
+          <p:nvPr/>
+        </p:nvPicPr>
+        <p:blipFill>
+          <a:blip r:embed="rId2"/>
+          <a:stretch>
+            <a:fillRect/>
+          </a:stretch>
+        </p:blipFill>
+        <p:spPr>
+          <a:xfrm>
+            <a:off x="8682754" y="1609643"/>
+            <a:ext cx="3144874" cy="4179550"/>
+          </a:xfrm>
+          <a:prstGeom prst="rect">
+            <a:avLst/>
+          </a:prstGeom>
+        </p:spPr>
+      </p:pic>
+    </p:spTree>
+    <p:extLst>
+      <p:ext uri="{BB962C8B-B14F-4D97-AF65-F5344CB8AC3E}">
+        <p14:creationId xmlns:p14="http://schemas.microsoft.com/office/powerpoint/2010/main" val="1674698795"/>
+      </p:ext>
+    </p:extLst>
+  </p:cSld>
+  <p:clrMapOvr>
+    <a:masterClrMapping/>
+  </p:clrMapOvr>
+</p:sld>
+</file>
+
+<file path=ppt/slides/slide7.xml><?xml version="1.0" encoding="utf-8"?>
+<p:sld xmlns:a="http://schemas.openxmlformats.org/drawingml/2006/main" xmlns:r="http://schemas.openxmlformats.org/officeDocument/2006/relationships" xmlns:p="http://schemas.openxmlformats.org/presentationml/2006/main">
+  <p:cSld>
+    <p:spTree>
+      <p:nvGrpSpPr>
+        <p:cNvPr id="1" name=""/>
+        <p:cNvGrpSpPr/>
+        <p:nvPr/>
+      </p:nvGrpSpPr>
+      <p:grpSpPr>
+        <a:xfrm>
+          <a:off x="0" y="0"/>
+          <a:ext cx="0" cy="0"/>
+          <a:chOff x="0" y="0"/>
+          <a:chExt cx="0" cy="0"/>
+        </a:xfrm>
+      </p:grpSpPr>
+      <p:sp>
+        <p:nvSpPr>
+          <p:cNvPr id="2" name="Title 1">
+            <a:extLst>
+              <a:ext uri="{FF2B5EF4-FFF2-40B4-BE49-F238E27FC236}">
+                <a16:creationId xmlns:a16="http://schemas.microsoft.com/office/drawing/2014/main" id="{8ACA08C1-3158-975D-F9F6-24CED5953318}"/>
+              </a:ext>
+            </a:extLst>
+          </p:cNvPr>
+          <p:cNvSpPr>
+            <a:spLocks noGrp="1"/>
+          </p:cNvSpPr>
+          <p:nvPr>
+            <p:ph type="title"/>
+          </p:nvPr>
+        </p:nvSpPr>
+        <p:spPr/>
+        <p:txBody>
+          <a:bodyPr/>
+          <a:lstStyle/>
+          <a:p>
+            <a:r>
+              <a:rPr lang="en-US" dirty="0"/>
+              <a:t>Simulation Architecture Debate Outcome</a:t>
+            </a:r>
+          </a:p>
+        </p:txBody>
+      </p:sp>
+      <p:sp>
+        <p:nvSpPr>
+          <p:cNvPr id="3" name="Content Placeholder 2">
+            <a:extLst>
+              <a:ext uri="{FF2B5EF4-FFF2-40B4-BE49-F238E27FC236}">
+                <a16:creationId xmlns:a16="http://schemas.microsoft.com/office/drawing/2014/main" id="{139C2602-2F68-2D6D-FBD7-8AE223D1861D}"/>
+              </a:ext>
+            </a:extLst>
+          </p:cNvPr>
+          <p:cNvSpPr>
+            <a:spLocks noGrp="1"/>
+          </p:cNvSpPr>
+          <p:nvPr>
+            <p:ph idx="1"/>
+          </p:nvPr>
+        </p:nvSpPr>
+        <p:spPr/>
+        <p:txBody>
+          <a:bodyPr>
+            <a:normAutofit fontScale="77500" lnSpcReduction="20000"/>
+          </a:bodyPr>
+          <a:lstStyle/>
+          <a:p>
+            <a:r>
+              <a:rPr lang="en-US" dirty="0"/>
+              <a:t>Code files are split into simulation, utility, and subsystem folders</a:t>
+            </a:r>
+          </a:p>
+          <a:p>
+            <a:r>
+              <a:rPr lang="en-US" dirty="0" err="1"/>
+              <a:t>Subsytem</a:t>
+            </a:r>
+            <a:r>
+              <a:rPr lang="en-US" dirty="0"/>
+              <a:t> folders (sensors, guidance, </a:t>
+            </a:r>
+            <a:r>
+              <a:rPr lang="en-US" dirty="0" err="1"/>
+              <a:t>etc</a:t>
+            </a:r>
+            <a:r>
+              <a:rPr lang="en-US" dirty="0"/>
+              <a:t>) house the states which hold the data, the system (one function .update()) which orchestrates the appropriate update based on each entity, and the models it uses to update the state. </a:t>
+            </a:r>
+          </a:p>
+          <a:p>
+            <a:r>
+              <a:rPr lang="en-US" dirty="0"/>
+              <a:t>This simplifies top sim loop to be a set of </a:t>
+            </a:r>
+            <a:r>
+              <a:rPr lang="en-US" dirty="0" err="1"/>
+              <a:t>system.update</a:t>
+            </a:r>
+            <a:r>
+              <a:rPr lang="en-US" dirty="0"/>
+              <a:t>(state, dt, </a:t>
+            </a:r>
+            <a:r>
+              <a:rPr lang="en-US" dirty="0" err="1"/>
+              <a:t>etc</a:t>
+            </a:r>
+            <a:r>
+              <a:rPr lang="en-US" dirty="0"/>
+              <a:t>), the states are all logged and progressed in motion at the end.</a:t>
+            </a:r>
+          </a:p>
+          <a:p>
+            <a:r>
+              <a:rPr lang="en-US" dirty="0"/>
+              <a:t>Entities will be initialized with the states of the components it has, therefore existence of a </a:t>
+            </a:r>
+            <a:r>
+              <a:rPr lang="en-US" dirty="0" err="1"/>
+              <a:t>entity.motion_state</a:t>
+            </a:r>
+            <a:r>
+              <a:rPr lang="en-US" dirty="0"/>
+              <a:t> will be seen by </a:t>
+            </a:r>
+            <a:r>
+              <a:rPr lang="en-US" dirty="0" err="1"/>
+              <a:t>motion_system</a:t>
+            </a:r>
+            <a:r>
+              <a:rPr lang="en-US" dirty="0"/>
+              <a:t> and will use </a:t>
+            </a:r>
+            <a:r>
+              <a:rPr lang="en-US" dirty="0" err="1"/>
+              <a:t>entity.motion_model</a:t>
+            </a:r>
+            <a:r>
+              <a:rPr lang="en-US" dirty="0"/>
+              <a:t> (whose existence is implied by the state existing, will have to be protected manually in initialization of the entity) to update it</a:t>
+            </a:r>
+          </a:p>
+          <a:p>
+            <a:r>
+              <a:rPr lang="en-US" dirty="0"/>
+              <a:t>Sub systems should be largely independent although some bleed over will have to be dealt with like guidance using estimation of </a:t>
+            </a:r>
+            <a:r>
+              <a:rPr lang="en-US" dirty="0" err="1"/>
+              <a:t>gps</a:t>
+            </a:r>
+            <a:r>
+              <a:rPr lang="en-US" dirty="0"/>
+              <a:t> and radar location belief about itself and the target. Other cases I am sure will pop up. At leas the models should all be functions that are insular and not called outside of </a:t>
+            </a:r>
+            <a:r>
+              <a:rPr lang="en-US"/>
+              <a:t>their system.</a:t>
+            </a:r>
+            <a:endParaRPr lang="en-US" dirty="0"/>
+          </a:p>
+        </p:txBody>
+      </p:sp>
+    </p:spTree>
+    <p:extLst>
+      <p:ext uri="{BB962C8B-B14F-4D97-AF65-F5344CB8AC3E}">
+        <p14:creationId xmlns:p14="http://schemas.microsoft.com/office/powerpoint/2010/main" val="1222222787"/>
+      </p:ext>
+    </p:extLst>
+  </p:cSld>
+  <p:clrMapOvr>
+    <a:masterClrMapping/>
+  </p:clrMapOvr>
+</p:sld>
+</file>
+
+<file path=ppt/slides/slide8.xml><?xml version="1.0" encoding="utf-8"?>
+<p:sld xmlns:a="http://schemas.openxmlformats.org/drawingml/2006/main" xmlns:r="http://schemas.openxmlformats.org/officeDocument/2006/relationships" xmlns:p="http://schemas.openxmlformats.org/presentationml/2006/main">
+  <p:cSld>
+    <p:spTree>
+      <p:nvGrpSpPr>
         <p:cNvPr id="1" name="">
           <a:extLst>
             <a:ext uri="{FF2B5EF4-FFF2-40B4-BE49-F238E27FC236}">
@@ -6220,7 +6758,7 @@
 </p:sld>
 </file>
 
-<file path=ppt/slides/slide7.xml><?xml version="1.0" encoding="utf-8"?>
+<file path=ppt/slides/slide9.xml><?xml version="1.0" encoding="utf-8"?>
 <p:sld xmlns:a="http://schemas.openxmlformats.org/drawingml/2006/main" xmlns:r="http://schemas.openxmlformats.org/officeDocument/2006/relationships" xmlns:p="http://schemas.openxmlformats.org/presentationml/2006/main">
   <p:cSld>
     <p:spTree>
@@ -6317,179 +6855,6 @@
     <p:extLst>
       <p:ext uri="{BB962C8B-B14F-4D97-AF65-F5344CB8AC3E}">
         <p14:creationId xmlns:p14="http://schemas.microsoft.com/office/powerpoint/2010/main" val="4165467339"/>
-      </p:ext>
-    </p:extLst>
-  </p:cSld>
-  <p:clrMapOvr>
-    <a:masterClrMapping/>
-  </p:clrMapOvr>
-</p:sld>
-</file>
-
-<file path=ppt/slides/slide8.xml><?xml version="1.0" encoding="utf-8"?>
-<p:sld xmlns:a="http://schemas.openxmlformats.org/drawingml/2006/main" xmlns:r="http://schemas.openxmlformats.org/officeDocument/2006/relationships" xmlns:p="http://schemas.openxmlformats.org/presentationml/2006/main">
-  <p:cSld>
-    <p:spTree>
-      <p:nvGrpSpPr>
-        <p:cNvPr id="1" name="">
-          <a:extLst>
-            <a:ext uri="{FF2B5EF4-FFF2-40B4-BE49-F238E27FC236}">
-              <a16:creationId xmlns:a16="http://schemas.microsoft.com/office/drawing/2014/main" id="{DA4D5631-0A62-AB59-D727-76A1E8FD3F2F}"/>
-            </a:ext>
-          </a:extLst>
-        </p:cNvPr>
-        <p:cNvGrpSpPr/>
-        <p:nvPr/>
-      </p:nvGrpSpPr>
-      <p:grpSpPr>
-        <a:xfrm>
-          <a:off x="0" y="0"/>
-          <a:ext cx="0" cy="0"/>
-          <a:chOff x="0" y="0"/>
-          <a:chExt cx="0" cy="0"/>
-        </a:xfrm>
-      </p:grpSpPr>
-      <p:sp>
-        <p:nvSpPr>
-          <p:cNvPr id="2" name="Title 1">
-            <a:extLst>
-              <a:ext uri="{FF2B5EF4-FFF2-40B4-BE49-F238E27FC236}">
-                <a16:creationId xmlns:a16="http://schemas.microsoft.com/office/drawing/2014/main" id="{461F6BEA-5B2C-497A-78C4-B6E376BDA52B}"/>
-              </a:ext>
-            </a:extLst>
-          </p:cNvPr>
-          <p:cNvSpPr>
-            <a:spLocks noGrp="1"/>
-          </p:cNvSpPr>
-          <p:nvPr>
-            <p:ph type="title"/>
-          </p:nvPr>
-        </p:nvSpPr>
-        <p:spPr/>
-        <p:txBody>
-          <a:bodyPr/>
-          <a:lstStyle/>
-          <a:p>
-            <a:r>
-              <a:rPr lang="en-US" dirty="0"/>
-              <a:t>Developer Notes</a:t>
-            </a:r>
-          </a:p>
-        </p:txBody>
-      </p:sp>
-      <p:sp>
-        <p:nvSpPr>
-          <p:cNvPr id="3" name="Content Placeholder 2">
-            <a:extLst>
-              <a:ext uri="{FF2B5EF4-FFF2-40B4-BE49-F238E27FC236}">
-                <a16:creationId xmlns:a16="http://schemas.microsoft.com/office/drawing/2014/main" id="{6BD1868D-38D3-020B-42CE-2B1B0BDDBE23}"/>
-              </a:ext>
-            </a:extLst>
-          </p:cNvPr>
-          <p:cNvSpPr>
-            <a:spLocks noGrp="1"/>
-          </p:cNvSpPr>
-          <p:nvPr>
-            <p:ph idx="1"/>
-          </p:nvPr>
-        </p:nvSpPr>
-        <p:spPr/>
-        <p:txBody>
-          <a:bodyPr/>
-          <a:lstStyle/>
-          <a:p>
-            <a:r>
-              <a:rPr lang="en-US" dirty="0"/>
-              <a:t>ECI versus ECEF</a:t>
-            </a:r>
-          </a:p>
-          <a:p>
-            <a:r>
-              <a:rPr lang="en-US" dirty="0"/>
-              <a:t>ENU versus NED</a:t>
-            </a:r>
-          </a:p>
-          <a:p>
-            <a:r>
-              <a:rPr lang="en-US" dirty="0"/>
-              <a:t>Since only 3 DOF assumption is pointing and velocity vector are same, important for prop nav and radar</a:t>
-            </a:r>
-          </a:p>
-          <a:p>
-            <a:r>
-              <a:rPr lang="en-US" dirty="0"/>
-              <a:t>Kinematic State</a:t>
-            </a:r>
-          </a:p>
-        </p:txBody>
-      </p:sp>
-    </p:spTree>
-    <p:extLst>
-      <p:ext uri="{BB962C8B-B14F-4D97-AF65-F5344CB8AC3E}">
-        <p14:creationId xmlns:p14="http://schemas.microsoft.com/office/powerpoint/2010/main" val="74780814"/>
-      </p:ext>
-    </p:extLst>
-  </p:cSld>
-  <p:clrMapOvr>
-    <a:masterClrMapping/>
-  </p:clrMapOvr>
-</p:sld>
-</file>
-
-<file path=ppt/slides/slide9.xml><?xml version="1.0" encoding="utf-8"?>
-<p:sld xmlns:a="http://schemas.openxmlformats.org/drawingml/2006/main" xmlns:r="http://schemas.openxmlformats.org/officeDocument/2006/relationships" xmlns:p="http://schemas.openxmlformats.org/presentationml/2006/main">
-  <p:cSld>
-    <p:spTree>
-      <p:nvGrpSpPr>
-        <p:cNvPr id="1" name=""/>
-        <p:cNvGrpSpPr/>
-        <p:nvPr/>
-      </p:nvGrpSpPr>
-      <p:grpSpPr>
-        <a:xfrm>
-          <a:off x="0" y="0"/>
-          <a:ext cx="0" cy="0"/>
-          <a:chOff x="0" y="0"/>
-          <a:chExt cx="0" cy="0"/>
-        </a:xfrm>
-      </p:grpSpPr>
-      <p:sp>
-        <p:nvSpPr>
-          <p:cNvPr id="2" name="Title 1">
-            <a:extLst>
-              <a:ext uri="{FF2B5EF4-FFF2-40B4-BE49-F238E27FC236}">
-                <a16:creationId xmlns:a16="http://schemas.microsoft.com/office/drawing/2014/main" id="{123AF59F-86A0-A19D-E1F2-A72865B6DB78}"/>
-              </a:ext>
-            </a:extLst>
-          </p:cNvPr>
-          <p:cNvSpPr>
-            <a:spLocks noGrp="1"/>
-          </p:cNvSpPr>
-          <p:nvPr>
-            <p:ph type="title"/>
-          </p:nvPr>
-        </p:nvSpPr>
-        <p:spPr>
-          <a:xfrm>
-            <a:off x="2776183" y="2766218"/>
-            <a:ext cx="10515600" cy="1325563"/>
-          </a:xfrm>
-        </p:spPr>
-        <p:txBody>
-          <a:bodyPr/>
-          <a:lstStyle/>
-          <a:p>
-            <a:r>
-              <a:rPr lang="en-US" dirty="0"/>
-              <a:t>Missile Guidance With LOS</a:t>
-            </a:r>
-          </a:p>
-        </p:txBody>
-      </p:sp>
-    </p:spTree>
-    <p:extLst>
-      <p:ext uri="{BB962C8B-B14F-4D97-AF65-F5344CB8AC3E}">
-        <p14:creationId xmlns:p14="http://schemas.microsoft.com/office/powerpoint/2010/main" val="497690451"/>
       </p:ext>
     </p:extLst>
   </p:cSld>

</xml_diff>

<commit_message>
subsystems split up and motion system pretty much done, good baseline, gonna build out first stage system for all subsystems then create entities to match them for first new rerun run
</commit_message>
<xml_diff>
--- a/docs/Apogee_Progession.pptx
+++ b/docs/Apogee_Progession.pptx
@@ -11,31 +11,32 @@
     <p:sldId id="286" r:id="rId5"/>
     <p:sldId id="287" r:id="rId6"/>
     <p:sldId id="288" r:id="rId7"/>
-    <p:sldId id="289" r:id="rId8"/>
-    <p:sldId id="285" r:id="rId9"/>
-    <p:sldId id="274" r:id="rId10"/>
-    <p:sldId id="275" r:id="rId11"/>
-    <p:sldId id="259" r:id="rId12"/>
-    <p:sldId id="265" r:id="rId13"/>
-    <p:sldId id="266" r:id="rId14"/>
-    <p:sldId id="260" r:id="rId15"/>
-    <p:sldId id="267" r:id="rId16"/>
-    <p:sldId id="268" r:id="rId17"/>
-    <p:sldId id="261" r:id="rId18"/>
-    <p:sldId id="271" r:id="rId19"/>
-    <p:sldId id="272" r:id="rId20"/>
-    <p:sldId id="262" r:id="rId21"/>
-    <p:sldId id="269" r:id="rId22"/>
-    <p:sldId id="270" r:id="rId23"/>
-    <p:sldId id="276" r:id="rId24"/>
-    <p:sldId id="277" r:id="rId25"/>
-    <p:sldId id="278" r:id="rId26"/>
-    <p:sldId id="284" r:id="rId27"/>
-    <p:sldId id="283" r:id="rId28"/>
-    <p:sldId id="282" r:id="rId29"/>
-    <p:sldId id="281" r:id="rId30"/>
-    <p:sldId id="279" r:id="rId31"/>
-    <p:sldId id="280" r:id="rId32"/>
+    <p:sldId id="290" r:id="rId8"/>
+    <p:sldId id="289" r:id="rId9"/>
+    <p:sldId id="285" r:id="rId10"/>
+    <p:sldId id="274" r:id="rId11"/>
+    <p:sldId id="275" r:id="rId12"/>
+    <p:sldId id="259" r:id="rId13"/>
+    <p:sldId id="265" r:id="rId14"/>
+    <p:sldId id="266" r:id="rId15"/>
+    <p:sldId id="260" r:id="rId16"/>
+    <p:sldId id="267" r:id="rId17"/>
+    <p:sldId id="268" r:id="rId18"/>
+    <p:sldId id="261" r:id="rId19"/>
+    <p:sldId id="271" r:id="rId20"/>
+    <p:sldId id="272" r:id="rId21"/>
+    <p:sldId id="262" r:id="rId22"/>
+    <p:sldId id="269" r:id="rId23"/>
+    <p:sldId id="270" r:id="rId24"/>
+    <p:sldId id="276" r:id="rId25"/>
+    <p:sldId id="277" r:id="rId26"/>
+    <p:sldId id="278" r:id="rId27"/>
+    <p:sldId id="284" r:id="rId28"/>
+    <p:sldId id="283" r:id="rId29"/>
+    <p:sldId id="282" r:id="rId30"/>
+    <p:sldId id="281" r:id="rId31"/>
+    <p:sldId id="279" r:id="rId32"/>
+    <p:sldId id="280" r:id="rId33"/>
   </p:sldIdLst>
   <p:sldSz cx="12192000" cy="6858000"/>
   <p:notesSz cx="6858000" cy="9144000"/>
@@ -145,7 +146,7 @@
 <file path=ppt/revisionInfo.xml><?xml version="1.0" encoding="utf-8"?>
 <p1510:revInfo xmlns:a="http://schemas.openxmlformats.org/drawingml/2006/main" xmlns:r="http://schemas.openxmlformats.org/officeDocument/2006/relationships" xmlns:p1510="http://schemas.microsoft.com/office/powerpoint/2015/10/main">
   <p1510:revLst>
-    <p1510:client id="{9F88DE7B-4153-4DD5-8CD8-49B431BF79F3}" v="9" dt="2026-10-14T03:59:15.516"/>
+    <p1510:client id="{9F88DE7B-4153-4DD5-8CD8-49B431BF79F3}" v="10" dt="2026-10-16T14:53:56.780"/>
   </p1510:revLst>
 </p1510:revInfo>
 </file>
@@ -155,7 +156,7 @@
   <pc:docChgLst>
     <pc:chgData name="Jeremy Jestel" userId="f12305450eb37733" providerId="LiveId" clId="{5A341855-0C93-42C0-8589-13149EEF218B}"/>
     <pc:docChg chg="undo custSel addSld delSld modSld">
-      <pc:chgData name="Jeremy Jestel" userId="f12305450eb37733" providerId="LiveId" clId="{5A341855-0C93-42C0-8589-13149EEF218B}" dt="2026-10-15T04:01:05.072" v="7212" actId="20577"/>
+      <pc:chgData name="Jeremy Jestel" userId="f12305450eb37733" providerId="LiveId" clId="{5A341855-0C93-42C0-8589-13149EEF218B}" dt="2026-10-16T16:19:58.072" v="7937" actId="20577"/>
       <pc:docMkLst>
         <pc:docMk/>
       </pc:docMkLst>
@@ -175,13 +176,13 @@
         </pc:spChg>
       </pc:sldChg>
       <pc:sldChg chg="modSp new mod">
-        <pc:chgData name="Jeremy Jestel" userId="f12305450eb37733" providerId="LiveId" clId="{5A341855-0C93-42C0-8589-13149EEF218B}" dt="2026-10-05T23:17:54.258" v="292" actId="20577"/>
+        <pc:chgData name="Jeremy Jestel" userId="f12305450eb37733" providerId="LiveId" clId="{5A341855-0C93-42C0-8589-13149EEF218B}" dt="2026-10-16T16:19:58.072" v="7937" actId="20577"/>
         <pc:sldMkLst>
           <pc:docMk/>
           <pc:sldMk cId="4049945487" sldId="257"/>
         </pc:sldMkLst>
         <pc:spChg chg="mod">
-          <ac:chgData name="Jeremy Jestel" userId="f12305450eb37733" providerId="LiveId" clId="{5A341855-0C93-42C0-8589-13149EEF218B}" dt="2026-10-05T23:16:54.604" v="32" actId="20577"/>
+          <ac:chgData name="Jeremy Jestel" userId="f12305450eb37733" providerId="LiveId" clId="{5A341855-0C93-42C0-8589-13149EEF218B}" dt="2026-10-16T16:19:37.234" v="7868" actId="20577"/>
           <ac:spMkLst>
             <pc:docMk/>
             <pc:sldMk cId="4049945487" sldId="257"/>
@@ -189,7 +190,7 @@
           </ac:spMkLst>
         </pc:spChg>
         <pc:spChg chg="mod">
-          <ac:chgData name="Jeremy Jestel" userId="f12305450eb37733" providerId="LiveId" clId="{5A341855-0C93-42C0-8589-13149EEF218B}" dt="2026-10-05T23:17:54.258" v="292" actId="20577"/>
+          <ac:chgData name="Jeremy Jestel" userId="f12305450eb37733" providerId="LiveId" clId="{5A341855-0C93-42C0-8589-13149EEF218B}" dt="2026-10-16T16:19:58.072" v="7937" actId="20577"/>
           <ac:spMkLst>
             <pc:docMk/>
             <pc:sldMk cId="4049945487" sldId="257"/>
@@ -368,13 +369,13 @@
         </pc:spChg>
       </pc:sldChg>
       <pc:sldChg chg="modSp add mod">
-        <pc:chgData name="Jeremy Jestel" userId="f12305450eb37733" providerId="LiveId" clId="{5A341855-0C93-42C0-8589-13149EEF218B}" dt="2026-10-12T19:49:43.228" v="1220" actId="20577"/>
+        <pc:chgData name="Jeremy Jestel" userId="f12305450eb37733" providerId="LiveId" clId="{5A341855-0C93-42C0-8589-13149EEF218B}" dt="2026-10-16T14:18:06.163" v="7364" actId="20577"/>
         <pc:sldMkLst>
           <pc:docMk/>
           <pc:sldMk cId="74780814" sldId="275"/>
         </pc:sldMkLst>
         <pc:spChg chg="mod">
-          <ac:chgData name="Jeremy Jestel" userId="f12305450eb37733" providerId="LiveId" clId="{5A341855-0C93-42C0-8589-13149EEF218B}" dt="2026-10-12T19:49:43.228" v="1220" actId="20577"/>
+          <ac:chgData name="Jeremy Jestel" userId="f12305450eb37733" providerId="LiveId" clId="{5A341855-0C93-42C0-8589-13149EEF218B}" dt="2026-10-16T14:18:06.163" v="7364" actId="20577"/>
           <ac:spMkLst>
             <pc:docMk/>
             <pc:sldMk cId="74780814" sldId="275"/>
@@ -541,7 +542,7 @@
         </pc:sldMkLst>
       </pc:sldChg>
       <pc:sldChg chg="modSp new mod">
-        <pc:chgData name="Jeremy Jestel" userId="f12305450eb37733" providerId="LiveId" clId="{5A341855-0C93-42C0-8589-13149EEF218B}" dt="2026-10-14T03:59:53.062" v="3661" actId="20577"/>
+        <pc:chgData name="Jeremy Jestel" userId="f12305450eb37733" providerId="LiveId" clId="{5A341855-0C93-42C0-8589-13149EEF218B}" dt="2026-10-16T14:20:04.809" v="7472" actId="20577"/>
         <pc:sldMkLst>
           <pc:docMk/>
           <pc:sldMk cId="3139715625" sldId="286"/>
@@ -555,7 +556,7 @@
           </ac:spMkLst>
         </pc:spChg>
         <pc:spChg chg="mod">
-          <ac:chgData name="Jeremy Jestel" userId="f12305450eb37733" providerId="LiveId" clId="{5A341855-0C93-42C0-8589-13149EEF218B}" dt="2026-10-14T03:59:53.062" v="3661" actId="20577"/>
+          <ac:chgData name="Jeremy Jestel" userId="f12305450eb37733" providerId="LiveId" clId="{5A341855-0C93-42C0-8589-13149EEF218B}" dt="2026-10-16T14:20:04.809" v="7472" actId="20577"/>
           <ac:spMkLst>
             <pc:docMk/>
             <pc:sldMk cId="3139715625" sldId="286"/>
@@ -564,7 +565,7 @@
         </pc:spChg>
       </pc:sldChg>
       <pc:sldChg chg="addSp modSp new mod">
-        <pc:chgData name="Jeremy Jestel" userId="f12305450eb37733" providerId="LiveId" clId="{5A341855-0C93-42C0-8589-13149EEF218B}" dt="2026-10-14T04:11:00.091" v="4483" actId="20577"/>
+        <pc:chgData name="Jeremy Jestel" userId="f12305450eb37733" providerId="LiveId" clId="{5A341855-0C93-42C0-8589-13149EEF218B}" dt="2026-10-16T13:53:27.379" v="7218" actId="1076"/>
         <pc:sldMkLst>
           <pc:docMk/>
           <pc:sldMk cId="2987790816" sldId="287"/>
@@ -578,7 +579,7 @@
           </ac:spMkLst>
         </pc:spChg>
         <pc:spChg chg="mod">
-          <ac:chgData name="Jeremy Jestel" userId="f12305450eb37733" providerId="LiveId" clId="{5A341855-0C93-42C0-8589-13149EEF218B}" dt="2026-10-14T04:11:00.091" v="4483" actId="20577"/>
+          <ac:chgData name="Jeremy Jestel" userId="f12305450eb37733" providerId="LiveId" clId="{5A341855-0C93-42C0-8589-13149EEF218B}" dt="2026-10-16T13:53:19.139" v="7214" actId="27636"/>
           <ac:spMkLst>
             <pc:docMk/>
             <pc:sldMk cId="2987790816" sldId="287"/>
@@ -586,7 +587,7 @@
           </ac:spMkLst>
         </pc:spChg>
         <pc:picChg chg="add mod">
-          <ac:chgData name="Jeremy Jestel" userId="f12305450eb37733" providerId="LiveId" clId="{5A341855-0C93-42C0-8589-13149EEF218B}" dt="2026-10-14T04:08:11.028" v="3945" actId="1076"/>
+          <ac:chgData name="Jeremy Jestel" userId="f12305450eb37733" providerId="LiveId" clId="{5A341855-0C93-42C0-8589-13149EEF218B}" dt="2026-10-16T13:53:27.379" v="7218" actId="1076"/>
           <ac:picMkLst>
             <pc:docMk/>
             <pc:sldMk cId="2987790816" sldId="287"/>
@@ -648,6 +649,29 @@
           </ac:spMkLst>
         </pc:spChg>
       </pc:sldChg>
+      <pc:sldChg chg="modSp new mod">
+        <pc:chgData name="Jeremy Jestel" userId="f12305450eb37733" providerId="LiveId" clId="{5A341855-0C93-42C0-8589-13149EEF218B}" dt="2026-10-16T15:03:58.741" v="7837" actId="20577"/>
+        <pc:sldMkLst>
+          <pc:docMk/>
+          <pc:sldMk cId="2505765051" sldId="290"/>
+        </pc:sldMkLst>
+        <pc:spChg chg="mod">
+          <ac:chgData name="Jeremy Jestel" userId="f12305450eb37733" providerId="LiveId" clId="{5A341855-0C93-42C0-8589-13149EEF218B}" dt="2026-10-16T14:52:44.071" v="7490" actId="20577"/>
+          <ac:spMkLst>
+            <pc:docMk/>
+            <pc:sldMk cId="2505765051" sldId="290"/>
+            <ac:spMk id="2" creationId="{E5B83AF1-B5B4-69B2-F372-470449CCC3BD}"/>
+          </ac:spMkLst>
+        </pc:spChg>
+        <pc:spChg chg="mod">
+          <ac:chgData name="Jeremy Jestel" userId="f12305450eb37733" providerId="LiveId" clId="{5A341855-0C93-42C0-8589-13149EEF218B}" dt="2026-10-16T15:03:58.741" v="7837" actId="20577"/>
+          <ac:spMkLst>
+            <pc:docMk/>
+            <pc:sldMk cId="2505765051" sldId="290"/>
+            <ac:spMk id="3" creationId="{AC9983DB-6704-D6FF-4B6C-D1E573CFF3A1}"/>
+          </ac:spMkLst>
+        </pc:spChg>
+      </pc:sldChg>
     </pc:docChg>
   </pc:docChgLst>
 </pc:chgInfo>
@@ -800,7 +824,7 @@
           <a:p>
             <a:fld id="{CEB632EC-697C-46E2-86FC-E2DD52DD9F70}" type="datetimeFigureOut">
               <a:rPr lang="en-US" smtClean="0"/>
-              <a:t>10/14/2026</a:t>
+              <a:t>10/16/2026</a:t>
             </a:fld>
             <a:endParaRPr lang="en-US"/>
           </a:p>
@@ -998,7 +1022,7 @@
           <a:p>
             <a:fld id="{CEB632EC-697C-46E2-86FC-E2DD52DD9F70}" type="datetimeFigureOut">
               <a:rPr lang="en-US" smtClean="0"/>
-              <a:t>10/14/2026</a:t>
+              <a:t>10/16/2026</a:t>
             </a:fld>
             <a:endParaRPr lang="en-US"/>
           </a:p>
@@ -1206,7 +1230,7 @@
           <a:p>
             <a:fld id="{CEB632EC-697C-46E2-86FC-E2DD52DD9F70}" type="datetimeFigureOut">
               <a:rPr lang="en-US" smtClean="0"/>
-              <a:t>10/14/2026</a:t>
+              <a:t>10/16/2026</a:t>
             </a:fld>
             <a:endParaRPr lang="en-US"/>
           </a:p>
@@ -1404,7 +1428,7 @@
           <a:p>
             <a:fld id="{CEB632EC-697C-46E2-86FC-E2DD52DD9F70}" type="datetimeFigureOut">
               <a:rPr lang="en-US" smtClean="0"/>
-              <a:t>10/14/2026</a:t>
+              <a:t>10/16/2026</a:t>
             </a:fld>
             <a:endParaRPr lang="en-US"/>
           </a:p>
@@ -1679,7 +1703,7 @@
           <a:p>
             <a:fld id="{CEB632EC-697C-46E2-86FC-E2DD52DD9F70}" type="datetimeFigureOut">
               <a:rPr lang="en-US" smtClean="0"/>
-              <a:t>10/14/2026</a:t>
+              <a:t>10/16/2026</a:t>
             </a:fld>
             <a:endParaRPr lang="en-US"/>
           </a:p>
@@ -1944,7 +1968,7 @@
           <a:p>
             <a:fld id="{CEB632EC-697C-46E2-86FC-E2DD52DD9F70}" type="datetimeFigureOut">
               <a:rPr lang="en-US" smtClean="0"/>
-              <a:t>10/14/2026</a:t>
+              <a:t>10/16/2026</a:t>
             </a:fld>
             <a:endParaRPr lang="en-US"/>
           </a:p>
@@ -2356,7 +2380,7 @@
           <a:p>
             <a:fld id="{CEB632EC-697C-46E2-86FC-E2DD52DD9F70}" type="datetimeFigureOut">
               <a:rPr lang="en-US" smtClean="0"/>
-              <a:t>10/14/2026</a:t>
+              <a:t>10/16/2026</a:t>
             </a:fld>
             <a:endParaRPr lang="en-US"/>
           </a:p>
@@ -2497,7 +2521,7 @@
           <a:p>
             <a:fld id="{CEB632EC-697C-46E2-86FC-E2DD52DD9F70}" type="datetimeFigureOut">
               <a:rPr lang="en-US" smtClean="0"/>
-              <a:t>10/14/2026</a:t>
+              <a:t>10/16/2026</a:t>
             </a:fld>
             <a:endParaRPr lang="en-US"/>
           </a:p>
@@ -2610,7 +2634,7 @@
           <a:p>
             <a:fld id="{CEB632EC-697C-46E2-86FC-E2DD52DD9F70}" type="datetimeFigureOut">
               <a:rPr lang="en-US" smtClean="0"/>
-              <a:t>10/14/2026</a:t>
+              <a:t>10/16/2026</a:t>
             </a:fld>
             <a:endParaRPr lang="en-US"/>
           </a:p>
@@ -2921,7 +2945,7 @@
           <a:p>
             <a:fld id="{CEB632EC-697C-46E2-86FC-E2DD52DD9F70}" type="datetimeFigureOut">
               <a:rPr lang="en-US" smtClean="0"/>
-              <a:t>10/14/2026</a:t>
+              <a:t>10/16/2026</a:t>
             </a:fld>
             <a:endParaRPr lang="en-US"/>
           </a:p>
@@ -3209,7 +3233,7 @@
           <a:p>
             <a:fld id="{CEB632EC-697C-46E2-86FC-E2DD52DD9F70}" type="datetimeFigureOut">
               <a:rPr lang="en-US" smtClean="0"/>
-              <a:t>10/14/2026</a:t>
+              <a:t>10/16/2026</a:t>
             </a:fld>
             <a:endParaRPr lang="en-US"/>
           </a:p>
@@ -3450,7 +3474,7 @@
           <a:p>
             <a:fld id="{CEB632EC-697C-46E2-86FC-E2DD52DD9F70}" type="datetimeFigureOut">
               <a:rPr lang="en-US" smtClean="0"/>
-              <a:t>10/14/2026</a:t>
+              <a:t>10/16/2026</a:t>
             </a:fld>
             <a:endParaRPr lang="en-US"/>
           </a:p>
@@ -3941,6 +3965,112 @@
         <p:cNvPr id="1" name="">
           <a:extLst>
             <a:ext uri="{FF2B5EF4-FFF2-40B4-BE49-F238E27FC236}">
+              <a16:creationId xmlns:a16="http://schemas.microsoft.com/office/drawing/2014/main" id="{194624A1-D311-60F3-6660-B529F37D540A}"/>
+            </a:ext>
+          </a:extLst>
+        </p:cNvPr>
+        <p:cNvGrpSpPr/>
+        <p:nvPr/>
+      </p:nvGrpSpPr>
+      <p:grpSpPr>
+        <a:xfrm>
+          <a:off x="0" y="0"/>
+          <a:ext cx="0" cy="0"/>
+          <a:chOff x="0" y="0"/>
+          <a:chExt cx="0" cy="0"/>
+        </a:xfrm>
+      </p:grpSpPr>
+      <p:sp>
+        <p:nvSpPr>
+          <p:cNvPr id="2" name="Title 1">
+            <a:extLst>
+              <a:ext uri="{FF2B5EF4-FFF2-40B4-BE49-F238E27FC236}">
+                <a16:creationId xmlns:a16="http://schemas.microsoft.com/office/drawing/2014/main" id="{D1DDBB3A-771B-0C3C-E78E-A7CA942B08E6}"/>
+              </a:ext>
+            </a:extLst>
+          </p:cNvPr>
+          <p:cNvSpPr>
+            <a:spLocks noGrp="1"/>
+          </p:cNvSpPr>
+          <p:nvPr>
+            <p:ph type="title"/>
+          </p:nvPr>
+        </p:nvSpPr>
+        <p:spPr/>
+        <p:txBody>
+          <a:bodyPr/>
+          <a:lstStyle/>
+          <a:p>
+            <a:r>
+              <a:rPr lang="en-US" dirty="0"/>
+              <a:t>Feature Description</a:t>
+            </a:r>
+          </a:p>
+        </p:txBody>
+      </p:sp>
+      <p:sp>
+        <p:nvSpPr>
+          <p:cNvPr id="3" name="Content Placeholder 2">
+            <a:extLst>
+              <a:ext uri="{FF2B5EF4-FFF2-40B4-BE49-F238E27FC236}">
+                <a16:creationId xmlns:a16="http://schemas.microsoft.com/office/drawing/2014/main" id="{E2FB64A5-C3DA-7481-BCA2-1E2072EC340C}"/>
+              </a:ext>
+            </a:extLst>
+          </p:cNvPr>
+          <p:cNvSpPr>
+            <a:spLocks noGrp="1"/>
+          </p:cNvSpPr>
+          <p:nvPr>
+            <p:ph idx="1"/>
+          </p:nvPr>
+        </p:nvSpPr>
+        <p:spPr/>
+        <p:txBody>
+          <a:bodyPr/>
+          <a:lstStyle/>
+          <a:p>
+            <a:r>
+              <a:rPr lang="en-US" dirty="0"/>
+              <a:t>Different systems care about different coordinates</a:t>
+            </a:r>
+          </a:p>
+          <a:p>
+            <a:r>
+              <a:rPr lang="en-US" dirty="0"/>
+              <a:t>Choosing the right makes calculations more useful for </a:t>
+            </a:r>
+            <a:r>
+              <a:rPr lang="en-US" dirty="0" err="1"/>
+              <a:t>specifica</a:t>
+            </a:r>
+            <a:r>
+              <a:rPr lang="en-US" dirty="0"/>
+              <a:t> cases</a:t>
+            </a:r>
+          </a:p>
+        </p:txBody>
+      </p:sp>
+    </p:spTree>
+    <p:extLst>
+      <p:ext uri="{BB962C8B-B14F-4D97-AF65-F5344CB8AC3E}">
+        <p14:creationId xmlns:p14="http://schemas.microsoft.com/office/powerpoint/2010/main" val="4165467339"/>
+      </p:ext>
+    </p:extLst>
+  </p:cSld>
+  <p:clrMapOvr>
+    <a:masterClrMapping/>
+  </p:clrMapOvr>
+</p:sld>
+</file>
+
+<file path=ppt/slides/slide11.xml><?xml version="1.0" encoding="utf-8"?>
+<p:sld xmlns:a="http://schemas.openxmlformats.org/drawingml/2006/main" xmlns:r="http://schemas.openxmlformats.org/officeDocument/2006/relationships" xmlns:p="http://schemas.openxmlformats.org/presentationml/2006/main">
+  <p:cSld>
+    <p:spTree>
+      <p:nvGrpSpPr>
+        <p:cNvPr id="1" name="">
+          <a:extLst>
+            <a:ext uri="{FF2B5EF4-FFF2-40B4-BE49-F238E27FC236}">
               <a16:creationId xmlns:a16="http://schemas.microsoft.com/office/drawing/2014/main" id="{DA4D5631-0A62-AB59-D727-76A1E8FD3F2F}"/>
             </a:ext>
           </a:extLst>
@@ -4013,7 +4143,7 @@
           <a:p>
             <a:r>
               <a:rPr lang="en-US" dirty="0"/>
-              <a:t>ENU versus NED</a:t>
+              <a:t>ENU versus NED: I chose NED as standard as I have some experience in it but will switch if seems like specific systems prefer ENU, low preference.</a:t>
             </a:r>
           </a:p>
           <a:p>
@@ -4043,7 +4173,7 @@
 </p:sld>
 </file>
 
-<file path=ppt/slides/slide11.xml><?xml version="1.0" encoding="utf-8"?>
+<file path=ppt/slides/slide12.xml><?xml version="1.0" encoding="utf-8"?>
 <p:sld xmlns:a="http://schemas.openxmlformats.org/drawingml/2006/main" xmlns:r="http://schemas.openxmlformats.org/officeDocument/2006/relationships" xmlns:p="http://schemas.openxmlformats.org/presentationml/2006/main">
   <p:cSld>
     <p:spTree>
@@ -4106,7 +4236,7 @@
 </p:sld>
 </file>
 
-<file path=ppt/slides/slide12.xml><?xml version="1.0" encoding="utf-8"?>
+<file path=ppt/slides/slide13.xml><?xml version="1.0" encoding="utf-8"?>
 <p:sld xmlns:a="http://schemas.openxmlformats.org/drawingml/2006/main" xmlns:r="http://schemas.openxmlformats.org/officeDocument/2006/relationships" xmlns:p="http://schemas.openxmlformats.org/presentationml/2006/main">
   <p:cSld>
     <p:spTree>
@@ -4195,7 +4325,7 @@
 </p:sld>
 </file>
 
-<file path=ppt/slides/slide13.xml><?xml version="1.0" encoding="utf-8"?>
+<file path=ppt/slides/slide14.xml><?xml version="1.0" encoding="utf-8"?>
 <p:sld xmlns:a="http://schemas.openxmlformats.org/drawingml/2006/main" xmlns:r="http://schemas.openxmlformats.org/officeDocument/2006/relationships" xmlns:p="http://schemas.openxmlformats.org/presentationml/2006/main">
   <p:cSld>
     <p:spTree>
@@ -4326,7 +4456,7 @@
 </p:sld>
 </file>
 
-<file path=ppt/slides/slide14.xml><?xml version="1.0" encoding="utf-8"?>
+<file path=ppt/slides/slide15.xml><?xml version="1.0" encoding="utf-8"?>
 <p:sld xmlns:a="http://schemas.openxmlformats.org/drawingml/2006/main" xmlns:r="http://schemas.openxmlformats.org/officeDocument/2006/relationships" xmlns:p="http://schemas.openxmlformats.org/presentationml/2006/main">
   <p:cSld>
     <p:spTree>
@@ -4395,7 +4525,7 @@
 </p:sld>
 </file>
 
-<file path=ppt/slides/slide15.xml><?xml version="1.0" encoding="utf-8"?>
+<file path=ppt/slides/slide16.xml><?xml version="1.0" encoding="utf-8"?>
 <p:sld xmlns:a="http://schemas.openxmlformats.org/drawingml/2006/main" xmlns:r="http://schemas.openxmlformats.org/officeDocument/2006/relationships" xmlns:p="http://schemas.openxmlformats.org/presentationml/2006/main">
   <p:cSld>
     <p:spTree>
@@ -4484,7 +4614,7 @@
 </p:sld>
 </file>
 
-<file path=ppt/slides/slide16.xml><?xml version="1.0" encoding="utf-8"?>
+<file path=ppt/slides/slide17.xml><?xml version="1.0" encoding="utf-8"?>
 <p:sld xmlns:a="http://schemas.openxmlformats.org/drawingml/2006/main" xmlns:r="http://schemas.openxmlformats.org/officeDocument/2006/relationships" xmlns:p="http://schemas.openxmlformats.org/presentationml/2006/main">
   <p:cSld>
     <p:spTree>
@@ -4573,7 +4703,7 @@
 </p:sld>
 </file>
 
-<file path=ppt/slides/slide17.xml><?xml version="1.0" encoding="utf-8"?>
+<file path=ppt/slides/slide18.xml><?xml version="1.0" encoding="utf-8"?>
 <p:sld xmlns:a="http://schemas.openxmlformats.org/drawingml/2006/main" xmlns:r="http://schemas.openxmlformats.org/officeDocument/2006/relationships" xmlns:p="http://schemas.openxmlformats.org/presentationml/2006/main">
   <p:cSld>
     <p:spTree>
@@ -4642,7 +4772,7 @@
 </p:sld>
 </file>
 
-<file path=ppt/slides/slide18.xml><?xml version="1.0" encoding="utf-8"?>
+<file path=ppt/slides/slide19.xml><?xml version="1.0" encoding="utf-8"?>
 <p:sld xmlns:a="http://schemas.openxmlformats.org/drawingml/2006/main" xmlns:r="http://schemas.openxmlformats.org/officeDocument/2006/relationships" xmlns:p="http://schemas.openxmlformats.org/presentationml/2006/main">
   <p:cSld>
     <p:spTree>
@@ -4722,95 +4852,6 @@
     <p:extLst>
       <p:ext uri="{BB962C8B-B14F-4D97-AF65-F5344CB8AC3E}">
         <p14:creationId xmlns:p14="http://schemas.microsoft.com/office/powerpoint/2010/main" val="2670624338"/>
-      </p:ext>
-    </p:extLst>
-  </p:cSld>
-  <p:clrMapOvr>
-    <a:masterClrMapping/>
-  </p:clrMapOvr>
-</p:sld>
-</file>
-
-<file path=ppt/slides/slide19.xml><?xml version="1.0" encoding="utf-8"?>
-<p:sld xmlns:a="http://schemas.openxmlformats.org/drawingml/2006/main" xmlns:r="http://schemas.openxmlformats.org/officeDocument/2006/relationships" xmlns:p="http://schemas.openxmlformats.org/presentationml/2006/main">
-  <p:cSld>
-    <p:spTree>
-      <p:nvGrpSpPr>
-        <p:cNvPr id="1" name="">
-          <a:extLst>
-            <a:ext uri="{FF2B5EF4-FFF2-40B4-BE49-F238E27FC236}">
-              <a16:creationId xmlns:a16="http://schemas.microsoft.com/office/drawing/2014/main" id="{A15E2039-6B97-D1CB-449F-B19D4765336E}"/>
-            </a:ext>
-          </a:extLst>
-        </p:cNvPr>
-        <p:cNvGrpSpPr/>
-        <p:nvPr/>
-      </p:nvGrpSpPr>
-      <p:grpSpPr>
-        <a:xfrm>
-          <a:off x="0" y="0"/>
-          <a:ext cx="0" cy="0"/>
-          <a:chOff x="0" y="0"/>
-          <a:chExt cx="0" cy="0"/>
-        </a:xfrm>
-      </p:grpSpPr>
-      <p:sp>
-        <p:nvSpPr>
-          <p:cNvPr id="2" name="Title 1">
-            <a:extLst>
-              <a:ext uri="{FF2B5EF4-FFF2-40B4-BE49-F238E27FC236}">
-                <a16:creationId xmlns:a16="http://schemas.microsoft.com/office/drawing/2014/main" id="{686E6F56-54CD-9918-9973-470BFDAC17C0}"/>
-              </a:ext>
-            </a:extLst>
-          </p:cNvPr>
-          <p:cNvSpPr>
-            <a:spLocks noGrp="1"/>
-          </p:cNvSpPr>
-          <p:nvPr>
-            <p:ph type="title"/>
-          </p:nvPr>
-        </p:nvSpPr>
-        <p:spPr/>
-        <p:txBody>
-          <a:bodyPr/>
-          <a:lstStyle/>
-          <a:p>
-            <a:r>
-              <a:rPr lang="en-US" dirty="0"/>
-              <a:t>Developer Notes</a:t>
-            </a:r>
-          </a:p>
-        </p:txBody>
-      </p:sp>
-      <p:sp>
-        <p:nvSpPr>
-          <p:cNvPr id="3" name="Content Placeholder 2">
-            <a:extLst>
-              <a:ext uri="{FF2B5EF4-FFF2-40B4-BE49-F238E27FC236}">
-                <a16:creationId xmlns:a16="http://schemas.microsoft.com/office/drawing/2014/main" id="{7D809A1B-4C7B-3A20-E1D9-7F8E230B0E1E}"/>
-              </a:ext>
-            </a:extLst>
-          </p:cNvPr>
-          <p:cNvSpPr>
-            <a:spLocks noGrp="1"/>
-          </p:cNvSpPr>
-          <p:nvPr>
-            <p:ph idx="1"/>
-          </p:nvPr>
-        </p:nvSpPr>
-        <p:spPr/>
-        <p:txBody>
-          <a:bodyPr/>
-          <a:lstStyle/>
-          <a:p>
-            <a:endParaRPr lang="en-US" dirty="0"/>
-          </a:p>
-        </p:txBody>
-      </p:sp>
-    </p:spTree>
-    <p:extLst>
-      <p:ext uri="{BB962C8B-B14F-4D97-AF65-F5344CB8AC3E}">
-        <p14:creationId xmlns:p14="http://schemas.microsoft.com/office/powerpoint/2010/main" val="1431625114"/>
       </p:ext>
     </p:extLst>
   </p:cSld>
@@ -4860,7 +4901,7 @@
           <a:p>
             <a:r>
               <a:rPr lang="en-US" dirty="0"/>
-              <a:t>Idea</a:t>
+              <a:t>Assumptions</a:t>
             </a:r>
           </a:p>
         </p:txBody>
@@ -4888,14 +4929,15 @@
           <a:p>
             <a:r>
               <a:rPr lang="en-US" dirty="0"/>
-              <a:t>Thought is to have two slides for each capability new feature, one explaining what it is and its significance</a:t>
-            </a:r>
-          </a:p>
-          <a:p>
-            <a:r>
-              <a:rPr lang="en-US" dirty="0"/>
-              <a:t>Another explaining difficulties in developing it, resources used and developer reflections</a:t>
-            </a:r>
+              <a:t>Ground radar is stationary on earth, only affected by </a:t>
+            </a:r>
+            <a:r>
+              <a:rPr lang="en-US"/>
+              <a:t>earth rotation</a:t>
+            </a:r>
+          </a:p>
+          <a:p>
+            <a:endParaRPr lang="en-US" dirty="0"/>
           </a:p>
         </p:txBody>
       </p:sp>
@@ -4913,6 +4955,95 @@
 </file>
 
 <file path=ppt/slides/slide20.xml><?xml version="1.0" encoding="utf-8"?>
+<p:sld xmlns:a="http://schemas.openxmlformats.org/drawingml/2006/main" xmlns:r="http://schemas.openxmlformats.org/officeDocument/2006/relationships" xmlns:p="http://schemas.openxmlformats.org/presentationml/2006/main">
+  <p:cSld>
+    <p:spTree>
+      <p:nvGrpSpPr>
+        <p:cNvPr id="1" name="">
+          <a:extLst>
+            <a:ext uri="{FF2B5EF4-FFF2-40B4-BE49-F238E27FC236}">
+              <a16:creationId xmlns:a16="http://schemas.microsoft.com/office/drawing/2014/main" id="{A15E2039-6B97-D1CB-449F-B19D4765336E}"/>
+            </a:ext>
+          </a:extLst>
+        </p:cNvPr>
+        <p:cNvGrpSpPr/>
+        <p:nvPr/>
+      </p:nvGrpSpPr>
+      <p:grpSpPr>
+        <a:xfrm>
+          <a:off x="0" y="0"/>
+          <a:ext cx="0" cy="0"/>
+          <a:chOff x="0" y="0"/>
+          <a:chExt cx="0" cy="0"/>
+        </a:xfrm>
+      </p:grpSpPr>
+      <p:sp>
+        <p:nvSpPr>
+          <p:cNvPr id="2" name="Title 1">
+            <a:extLst>
+              <a:ext uri="{FF2B5EF4-FFF2-40B4-BE49-F238E27FC236}">
+                <a16:creationId xmlns:a16="http://schemas.microsoft.com/office/drawing/2014/main" id="{686E6F56-54CD-9918-9973-470BFDAC17C0}"/>
+              </a:ext>
+            </a:extLst>
+          </p:cNvPr>
+          <p:cNvSpPr>
+            <a:spLocks noGrp="1"/>
+          </p:cNvSpPr>
+          <p:nvPr>
+            <p:ph type="title"/>
+          </p:nvPr>
+        </p:nvSpPr>
+        <p:spPr/>
+        <p:txBody>
+          <a:bodyPr/>
+          <a:lstStyle/>
+          <a:p>
+            <a:r>
+              <a:rPr lang="en-US" dirty="0"/>
+              <a:t>Developer Notes</a:t>
+            </a:r>
+          </a:p>
+        </p:txBody>
+      </p:sp>
+      <p:sp>
+        <p:nvSpPr>
+          <p:cNvPr id="3" name="Content Placeholder 2">
+            <a:extLst>
+              <a:ext uri="{FF2B5EF4-FFF2-40B4-BE49-F238E27FC236}">
+                <a16:creationId xmlns:a16="http://schemas.microsoft.com/office/drawing/2014/main" id="{7D809A1B-4C7B-3A20-E1D9-7F8E230B0E1E}"/>
+              </a:ext>
+            </a:extLst>
+          </p:cNvPr>
+          <p:cNvSpPr>
+            <a:spLocks noGrp="1"/>
+          </p:cNvSpPr>
+          <p:nvPr>
+            <p:ph idx="1"/>
+          </p:nvPr>
+        </p:nvSpPr>
+        <p:spPr/>
+        <p:txBody>
+          <a:bodyPr/>
+          <a:lstStyle/>
+          <a:p>
+            <a:endParaRPr lang="en-US" dirty="0"/>
+          </a:p>
+        </p:txBody>
+      </p:sp>
+    </p:spTree>
+    <p:extLst>
+      <p:ext uri="{BB962C8B-B14F-4D97-AF65-F5344CB8AC3E}">
+        <p14:creationId xmlns:p14="http://schemas.microsoft.com/office/powerpoint/2010/main" val="1431625114"/>
+      </p:ext>
+    </p:extLst>
+  </p:cSld>
+  <p:clrMapOvr>
+    <a:masterClrMapping/>
+  </p:clrMapOvr>
+</p:sld>
+</file>
+
+<file path=ppt/slides/slide21.xml><?xml version="1.0" encoding="utf-8"?>
 <p:sld xmlns:a="http://schemas.openxmlformats.org/drawingml/2006/main" xmlns:r="http://schemas.openxmlformats.org/officeDocument/2006/relationships" xmlns:p="http://schemas.openxmlformats.org/presentationml/2006/main">
   <p:cSld>
     <p:spTree>
@@ -4981,7 +5112,7 @@
 </p:sld>
 </file>
 
-<file path=ppt/slides/slide21.xml><?xml version="1.0" encoding="utf-8"?>
+<file path=ppt/slides/slide22.xml><?xml version="1.0" encoding="utf-8"?>
 <p:sld xmlns:a="http://schemas.openxmlformats.org/drawingml/2006/main" xmlns:r="http://schemas.openxmlformats.org/officeDocument/2006/relationships" xmlns:p="http://schemas.openxmlformats.org/presentationml/2006/main">
   <p:cSld>
     <p:spTree>
@@ -5070,7 +5201,7 @@
 </p:sld>
 </file>
 
-<file path=ppt/slides/slide22.xml><?xml version="1.0" encoding="utf-8"?>
+<file path=ppt/slides/slide23.xml><?xml version="1.0" encoding="utf-8"?>
 <p:sld xmlns:a="http://schemas.openxmlformats.org/drawingml/2006/main" xmlns:r="http://schemas.openxmlformats.org/officeDocument/2006/relationships" xmlns:p="http://schemas.openxmlformats.org/presentationml/2006/main">
   <p:cSld>
     <p:spTree>
@@ -5159,7 +5290,7 @@
 </p:sld>
 </file>
 
-<file path=ppt/slides/slide23.xml><?xml version="1.0" encoding="utf-8"?>
+<file path=ppt/slides/slide24.xml><?xml version="1.0" encoding="utf-8"?>
 <p:sld xmlns:a="http://schemas.openxmlformats.org/drawingml/2006/main" xmlns:r="http://schemas.openxmlformats.org/officeDocument/2006/relationships" xmlns:p="http://schemas.openxmlformats.org/presentationml/2006/main">
   <p:cSld>
     <p:spTree>
@@ -5228,7 +5359,7 @@
 </p:sld>
 </file>
 
-<file path=ppt/slides/slide24.xml><?xml version="1.0" encoding="utf-8"?>
+<file path=ppt/slides/slide25.xml><?xml version="1.0" encoding="utf-8"?>
 <p:sld xmlns:a="http://schemas.openxmlformats.org/drawingml/2006/main" xmlns:r="http://schemas.openxmlformats.org/officeDocument/2006/relationships" xmlns:p="http://schemas.openxmlformats.org/presentationml/2006/main">
   <p:cSld>
     <p:spTree>
@@ -5317,7 +5448,7 @@
 </p:sld>
 </file>
 
-<file path=ppt/slides/slide25.xml><?xml version="1.0" encoding="utf-8"?>
+<file path=ppt/slides/slide26.xml><?xml version="1.0" encoding="utf-8"?>
 <p:sld xmlns:a="http://schemas.openxmlformats.org/drawingml/2006/main" xmlns:r="http://schemas.openxmlformats.org/officeDocument/2006/relationships" xmlns:p="http://schemas.openxmlformats.org/presentationml/2006/main">
   <p:cSld>
     <p:spTree>
@@ -5442,70 +5573,6 @@
     <p:extLst>
       <p:ext uri="{BB962C8B-B14F-4D97-AF65-F5344CB8AC3E}">
         <p14:creationId xmlns:p14="http://schemas.microsoft.com/office/powerpoint/2010/main" val="2306170173"/>
-      </p:ext>
-    </p:extLst>
-  </p:cSld>
-  <p:clrMapOvr>
-    <a:masterClrMapping/>
-  </p:clrMapOvr>
-</p:sld>
-</file>
-
-<file path=ppt/slides/slide26.xml><?xml version="1.0" encoding="utf-8"?>
-<p:sld xmlns:a="http://schemas.openxmlformats.org/drawingml/2006/main" xmlns:r="http://schemas.openxmlformats.org/officeDocument/2006/relationships" xmlns:p="http://schemas.openxmlformats.org/presentationml/2006/main">
-  <p:cSld>
-    <p:spTree>
-      <p:nvGrpSpPr>
-        <p:cNvPr id="1" name=""/>
-        <p:cNvGrpSpPr/>
-        <p:nvPr/>
-      </p:nvGrpSpPr>
-      <p:grpSpPr>
-        <a:xfrm>
-          <a:off x="0" y="0"/>
-          <a:ext cx="0" cy="0"/>
-          <a:chOff x="0" y="0"/>
-          <a:chExt cx="0" cy="0"/>
-        </a:xfrm>
-      </p:grpSpPr>
-      <p:sp>
-        <p:nvSpPr>
-          <p:cNvPr id="2" name="Title 1">
-            <a:extLst>
-              <a:ext uri="{FF2B5EF4-FFF2-40B4-BE49-F238E27FC236}">
-                <a16:creationId xmlns:a16="http://schemas.microsoft.com/office/drawing/2014/main" id="{F893E47E-0152-DBA2-F5C6-81C9CDF39D31}"/>
-              </a:ext>
-            </a:extLst>
-          </p:cNvPr>
-          <p:cNvSpPr>
-            <a:spLocks noGrp="1"/>
-          </p:cNvSpPr>
-          <p:nvPr>
-            <p:ph type="title"/>
-          </p:nvPr>
-        </p:nvSpPr>
-        <p:spPr>
-          <a:xfrm>
-            <a:off x="838200" y="2535119"/>
-            <a:ext cx="10515600" cy="1325563"/>
-          </a:xfrm>
-        </p:spPr>
-        <p:txBody>
-          <a:bodyPr/>
-          <a:lstStyle/>
-          <a:p>
-            <a:pPr algn="ctr"/>
-            <a:r>
-              <a:rPr lang="en-US" dirty="0"/>
-              <a:t>Problems Overcome</a:t>
-            </a:r>
-          </a:p>
-        </p:txBody>
-      </p:sp>
-    </p:spTree>
-    <p:extLst>
-      <p:ext uri="{BB962C8B-B14F-4D97-AF65-F5344CB8AC3E}">
-        <p14:creationId xmlns:p14="http://schemas.microsoft.com/office/powerpoint/2010/main" val="2641203556"/>
       </p:ext>
     </p:extLst>
   </p:cSld>
@@ -5537,7 +5604,7 @@
           <p:cNvPr id="2" name="Title 1">
             <a:extLst>
               <a:ext uri="{FF2B5EF4-FFF2-40B4-BE49-F238E27FC236}">
-                <a16:creationId xmlns:a16="http://schemas.microsoft.com/office/drawing/2014/main" id="{B8475666-74FD-6490-7B22-B1FC1E75E04E}"/>
+                <a16:creationId xmlns:a16="http://schemas.microsoft.com/office/drawing/2014/main" id="{F893E47E-0152-DBA2-F5C6-81C9CDF39D31}"/>
               </a:ext>
             </a:extLst>
           </p:cNvPr>
@@ -5548,140 +5615,28 @@
             <p:ph type="title"/>
           </p:nvPr>
         </p:nvSpPr>
-        <p:spPr/>
-        <p:txBody>
-          <a:bodyPr/>
-          <a:lstStyle/>
-          <a:p>
-            <a:r>
-              <a:rPr lang="en-US" dirty="0"/>
-              <a:t>Earth Occlusion of LOS</a:t>
-            </a:r>
-          </a:p>
-        </p:txBody>
-      </p:sp>
-      <p:sp>
-        <p:nvSpPr>
-          <p:cNvPr id="3" name="Content Placeholder 2">
-            <a:extLst>
-              <a:ext uri="{FF2B5EF4-FFF2-40B4-BE49-F238E27FC236}">
-                <a16:creationId xmlns:a16="http://schemas.microsoft.com/office/drawing/2014/main" id="{AD609CE9-6468-D8EE-A7B7-4ADA8A032E0F}"/>
-              </a:ext>
-            </a:extLst>
-          </p:cNvPr>
-          <p:cNvSpPr>
-            <a:spLocks noGrp="1"/>
-          </p:cNvSpPr>
-          <p:nvPr>
-            <p:ph idx="1"/>
-          </p:nvPr>
-        </p:nvSpPr>
-        <p:spPr/>
-        <p:txBody>
-          <a:bodyPr>
-            <a:normAutofit/>
-          </a:bodyPr>
-          <a:lstStyle/>
-          <a:p>
-            <a:r>
-              <a:rPr lang="en-US" sz="1800" dirty="0"/>
-              <a:t>How do I calculate whether or not 2 bodies (points) have LOS or are occluded by the earth using </a:t>
-            </a:r>
-            <a:r>
-              <a:rPr lang="en-US" sz="1800" dirty="0" err="1"/>
-              <a:t>lin</a:t>
-            </a:r>
-            <a:r>
-              <a:rPr lang="en-US" sz="1800" dirty="0"/>
-              <a:t> </a:t>
-            </a:r>
-            <a:r>
-              <a:rPr lang="en-US" sz="1800" dirty="0" err="1"/>
-              <a:t>alg</a:t>
-            </a:r>
-            <a:r>
-              <a:rPr lang="en-US" sz="1800" dirty="0"/>
-              <a:t>?</a:t>
-            </a:r>
-          </a:p>
-          <a:p>
-            <a:r>
-              <a:rPr lang="en-US" sz="1800" dirty="0"/>
-              <a:t>Pointing Vector is d =  B-A  </a:t>
-            </a:r>
-          </a:p>
-          <a:p>
-            <a:r>
-              <a:rPr lang="en-US" sz="1800" dirty="0"/>
-              <a:t>Treat vector pointing A to B is D(t) = ||A + td||</a:t>
-            </a:r>
-          </a:p>
-          <a:p>
-            <a:r>
-              <a:rPr lang="en-US" sz="1800" dirty="0"/>
-              <a:t>Minimizing the square has simpler math properties, would have to use chain rule without square</a:t>
-            </a:r>
-          </a:p>
-          <a:p>
-            <a:r>
-              <a:rPr lang="en-US" sz="1800" dirty="0"/>
-              <a:t>D^2(t)= A dot A + 2t (A dot d) + t^2 (d dot d)  Squaring norm is same as dotting norm with self</a:t>
-            </a:r>
-          </a:p>
-          <a:p>
-            <a:r>
-              <a:rPr lang="en-US" sz="1800" dirty="0"/>
-              <a:t>d/dt D^2’(t) = 2t (d dot d) + 2 (A dot d)</a:t>
-            </a:r>
-          </a:p>
-          <a:p>
-            <a:r>
-              <a:rPr lang="en-US" sz="1800" dirty="0"/>
-              <a:t>0 = 2t (d dot d) + 2 (A dot d)</a:t>
-            </a:r>
-          </a:p>
-          <a:p>
-            <a:r>
-              <a:rPr lang="en-US" sz="1800" dirty="0"/>
-              <a:t>-(A dot d)= t(d dot d)    Can do division because dot products are scalar output</a:t>
-            </a:r>
-          </a:p>
-          <a:p>
-            <a:r>
-              <a:rPr lang="en-US" sz="1800" dirty="0"/>
-              <a:t>t = - (A dot d) / ||d||^2       d dot d is a norm squared</a:t>
-            </a:r>
-          </a:p>
-          <a:p>
-            <a:r>
-              <a:rPr lang="en-US" sz="1800" dirty="0"/>
-              <a:t>Can then calculate that point and if its norm is &lt; radius of earth then no LOS</a:t>
-            </a:r>
-          </a:p>
-          <a:p>
-            <a:endParaRPr lang="en-US" sz="1800" dirty="0"/>
-          </a:p>
-          <a:p>
-            <a:endParaRPr lang="en-US" sz="1800" dirty="0"/>
-          </a:p>
-          <a:p>
-            <a:endParaRPr lang="en-US" sz="1800" dirty="0"/>
-          </a:p>
-          <a:p>
-            <a:endParaRPr lang="en-US" sz="1800" dirty="0"/>
-          </a:p>
-          <a:p>
-            <a:endParaRPr lang="en-US" sz="1800" dirty="0"/>
-          </a:p>
-          <a:p>
-            <a:endParaRPr lang="en-US" sz="1800" dirty="0"/>
+        <p:spPr>
+          <a:xfrm>
+            <a:off x="838200" y="2535119"/>
+            <a:ext cx="10515600" cy="1325563"/>
+          </a:xfrm>
+        </p:spPr>
+        <p:txBody>
+          <a:bodyPr/>
+          <a:lstStyle/>
+          <a:p>
+            <a:pPr algn="ctr"/>
+            <a:r>
+              <a:rPr lang="en-US" dirty="0"/>
+              <a:t>Problems Overcome</a:t>
+            </a:r>
           </a:p>
         </p:txBody>
       </p:sp>
     </p:spTree>
     <p:extLst>
       <p:ext uri="{BB962C8B-B14F-4D97-AF65-F5344CB8AC3E}">
-        <p14:creationId xmlns:p14="http://schemas.microsoft.com/office/powerpoint/2010/main" val="4060347343"/>
+        <p14:creationId xmlns:p14="http://schemas.microsoft.com/office/powerpoint/2010/main" val="2641203556"/>
       </p:ext>
     </p:extLst>
   </p:cSld>
@@ -5713,7 +5668,7 @@
           <p:cNvPr id="2" name="Title 1">
             <a:extLst>
               <a:ext uri="{FF2B5EF4-FFF2-40B4-BE49-F238E27FC236}">
-                <a16:creationId xmlns:a16="http://schemas.microsoft.com/office/drawing/2014/main" id="{2BD7E637-0A0C-B2FC-AE0E-35E5AF1998A5}"/>
+                <a16:creationId xmlns:a16="http://schemas.microsoft.com/office/drawing/2014/main" id="{B8475666-74FD-6490-7B22-B1FC1E75E04E}"/>
               </a:ext>
             </a:extLst>
           </p:cNvPr>
@@ -5724,31 +5679,140 @@
             <p:ph type="title"/>
           </p:nvPr>
         </p:nvSpPr>
-        <p:spPr>
-          <a:xfrm>
-            <a:off x="4352499" y="2705716"/>
-            <a:ext cx="4882941" cy="1325563"/>
-          </a:xfrm>
-        </p:spPr>
-        <p:txBody>
-          <a:bodyPr/>
-          <a:lstStyle/>
-          <a:p>
-            <a:r>
-              <a:rPr lang="en-US" dirty="0" err="1"/>
-              <a:t>Misc</a:t>
-            </a:r>
-            <a:r>
-              <a:rPr lang="en-US" dirty="0"/>
-              <a:t> Loose Ends</a:t>
-            </a:r>
+        <p:spPr/>
+        <p:txBody>
+          <a:bodyPr/>
+          <a:lstStyle/>
+          <a:p>
+            <a:r>
+              <a:rPr lang="en-US" dirty="0"/>
+              <a:t>Earth Occlusion of LOS</a:t>
+            </a:r>
+          </a:p>
+        </p:txBody>
+      </p:sp>
+      <p:sp>
+        <p:nvSpPr>
+          <p:cNvPr id="3" name="Content Placeholder 2">
+            <a:extLst>
+              <a:ext uri="{FF2B5EF4-FFF2-40B4-BE49-F238E27FC236}">
+                <a16:creationId xmlns:a16="http://schemas.microsoft.com/office/drawing/2014/main" id="{AD609CE9-6468-D8EE-A7B7-4ADA8A032E0F}"/>
+              </a:ext>
+            </a:extLst>
+          </p:cNvPr>
+          <p:cNvSpPr>
+            <a:spLocks noGrp="1"/>
+          </p:cNvSpPr>
+          <p:nvPr>
+            <p:ph idx="1"/>
+          </p:nvPr>
+        </p:nvSpPr>
+        <p:spPr/>
+        <p:txBody>
+          <a:bodyPr>
+            <a:normAutofit/>
+          </a:bodyPr>
+          <a:lstStyle/>
+          <a:p>
+            <a:r>
+              <a:rPr lang="en-US" sz="1800" dirty="0"/>
+              <a:t>How do I calculate whether or not 2 bodies (points) have LOS or are occluded by the earth using </a:t>
+            </a:r>
+            <a:r>
+              <a:rPr lang="en-US" sz="1800" dirty="0" err="1"/>
+              <a:t>lin</a:t>
+            </a:r>
+            <a:r>
+              <a:rPr lang="en-US" sz="1800" dirty="0"/>
+              <a:t> </a:t>
+            </a:r>
+            <a:r>
+              <a:rPr lang="en-US" sz="1800" dirty="0" err="1"/>
+              <a:t>alg</a:t>
+            </a:r>
+            <a:r>
+              <a:rPr lang="en-US" sz="1800" dirty="0"/>
+              <a:t>?</a:t>
+            </a:r>
+          </a:p>
+          <a:p>
+            <a:r>
+              <a:rPr lang="en-US" sz="1800" dirty="0"/>
+              <a:t>Pointing Vector is d =  B-A  </a:t>
+            </a:r>
+          </a:p>
+          <a:p>
+            <a:r>
+              <a:rPr lang="en-US" sz="1800" dirty="0"/>
+              <a:t>Treat vector pointing A to B is D(t) = ||A + td||</a:t>
+            </a:r>
+          </a:p>
+          <a:p>
+            <a:r>
+              <a:rPr lang="en-US" sz="1800" dirty="0"/>
+              <a:t>Minimizing the square has simpler math properties, would have to use chain rule without square</a:t>
+            </a:r>
+          </a:p>
+          <a:p>
+            <a:r>
+              <a:rPr lang="en-US" sz="1800" dirty="0"/>
+              <a:t>D^2(t)= A dot A + 2t (A dot d) + t^2 (d dot d)  Squaring norm is same as dotting norm with self</a:t>
+            </a:r>
+          </a:p>
+          <a:p>
+            <a:r>
+              <a:rPr lang="en-US" sz="1800" dirty="0"/>
+              <a:t>d/dt D^2’(t) = 2t (d dot d) + 2 (A dot d)</a:t>
+            </a:r>
+          </a:p>
+          <a:p>
+            <a:r>
+              <a:rPr lang="en-US" sz="1800" dirty="0"/>
+              <a:t>0 = 2t (d dot d) + 2 (A dot d)</a:t>
+            </a:r>
+          </a:p>
+          <a:p>
+            <a:r>
+              <a:rPr lang="en-US" sz="1800" dirty="0"/>
+              <a:t>-(A dot d)= t(d dot d)    Can do division because dot products are scalar output</a:t>
+            </a:r>
+          </a:p>
+          <a:p>
+            <a:r>
+              <a:rPr lang="en-US" sz="1800" dirty="0"/>
+              <a:t>t = - (A dot d) / ||d||^2       d dot d is a norm squared</a:t>
+            </a:r>
+          </a:p>
+          <a:p>
+            <a:r>
+              <a:rPr lang="en-US" sz="1800" dirty="0"/>
+              <a:t>Can then calculate that point and if its norm is &lt; radius of earth then no LOS</a:t>
+            </a:r>
+          </a:p>
+          <a:p>
+            <a:endParaRPr lang="en-US" sz="1800" dirty="0"/>
+          </a:p>
+          <a:p>
+            <a:endParaRPr lang="en-US" sz="1800" dirty="0"/>
+          </a:p>
+          <a:p>
+            <a:endParaRPr lang="en-US" sz="1800" dirty="0"/>
+          </a:p>
+          <a:p>
+            <a:endParaRPr lang="en-US" sz="1800" dirty="0"/>
+          </a:p>
+          <a:p>
+            <a:endParaRPr lang="en-US" sz="1800" dirty="0"/>
+          </a:p>
+          <a:p>
+            <a:endParaRPr lang="en-US" sz="1800" dirty="0"/>
           </a:p>
         </p:txBody>
       </p:sp>
     </p:spTree>
     <p:extLst>
       <p:ext uri="{BB962C8B-B14F-4D97-AF65-F5344CB8AC3E}">
-        <p14:creationId xmlns:p14="http://schemas.microsoft.com/office/powerpoint/2010/main" val="1216898861"/>
+        <p14:creationId xmlns:p14="http://schemas.microsoft.com/office/powerpoint/2010/main" val="4060347343"/>
       </p:ext>
     </p:extLst>
   </p:cSld>
@@ -5780,7 +5844,7 @@
           <p:cNvPr id="2" name="Title 1">
             <a:extLst>
               <a:ext uri="{FF2B5EF4-FFF2-40B4-BE49-F238E27FC236}">
-                <a16:creationId xmlns:a16="http://schemas.microsoft.com/office/drawing/2014/main" id="{269FB068-6AD7-6770-B2A7-107A9F4366FC}"/>
+                <a16:creationId xmlns:a16="http://schemas.microsoft.com/office/drawing/2014/main" id="{2BD7E637-0A0C-B2FC-AE0E-35E5AF1998A5}"/>
               </a:ext>
             </a:extLst>
           </p:cNvPr>
@@ -5791,62 +5855,31 @@
             <p:ph type="title"/>
           </p:nvPr>
         </p:nvSpPr>
-        <p:spPr/>
-        <p:txBody>
-          <a:bodyPr/>
-          <a:lstStyle/>
-          <a:p>
-            <a:r>
-              <a:rPr lang="en-US" dirty="0"/>
-              <a:t>Coding</a:t>
-            </a:r>
-          </a:p>
-        </p:txBody>
-      </p:sp>
-      <p:sp>
-        <p:nvSpPr>
-          <p:cNvPr id="3" name="Content Placeholder 2">
-            <a:extLst>
-              <a:ext uri="{FF2B5EF4-FFF2-40B4-BE49-F238E27FC236}">
-                <a16:creationId xmlns:a16="http://schemas.microsoft.com/office/drawing/2014/main" id="{857A8299-9CED-A1FE-0C2C-CB75D4FCE0BB}"/>
-              </a:ext>
-            </a:extLst>
-          </p:cNvPr>
-          <p:cNvSpPr>
-            <a:spLocks noGrp="1"/>
-          </p:cNvSpPr>
-          <p:nvPr>
-            <p:ph idx="1"/>
-          </p:nvPr>
-        </p:nvSpPr>
-        <p:spPr/>
-        <p:txBody>
-          <a:bodyPr/>
-          <a:lstStyle/>
-          <a:p>
-            <a:pPr marL="0" indent="0">
-              <a:buNone/>
-            </a:pPr>
-            <a:r>
-              <a:rPr lang="en-US" dirty="0"/>
-              <a:t>Const Expr</a:t>
-            </a:r>
-          </a:p>
-          <a:p>
-            <a:pPr marL="0" indent="0">
-              <a:buNone/>
-            </a:pPr>
-            <a:endParaRPr lang="en-US" dirty="0"/>
-          </a:p>
-          <a:p>
-            <a:endParaRPr lang="en-US" dirty="0"/>
+        <p:spPr>
+          <a:xfrm>
+            <a:off x="4352499" y="2705716"/>
+            <a:ext cx="4882941" cy="1325563"/>
+          </a:xfrm>
+        </p:spPr>
+        <p:txBody>
+          <a:bodyPr/>
+          <a:lstStyle/>
+          <a:p>
+            <a:r>
+              <a:rPr lang="en-US" dirty="0" err="1"/>
+              <a:t>Misc</a:t>
+            </a:r>
+            <a:r>
+              <a:rPr lang="en-US" dirty="0"/>
+              <a:t> Loose Ends</a:t>
+            </a:r>
           </a:p>
         </p:txBody>
       </p:sp>
     </p:spTree>
     <p:extLst>
       <p:ext uri="{BB962C8B-B14F-4D97-AF65-F5344CB8AC3E}">
-        <p14:creationId xmlns:p14="http://schemas.microsoft.com/office/powerpoint/2010/main" val="4128986287"/>
+        <p14:creationId xmlns:p14="http://schemas.microsoft.com/office/powerpoint/2010/main" val="1216898861"/>
       </p:ext>
     </p:extLst>
   </p:cSld>
@@ -5947,6 +5980,104 @@
           <p:cNvPr id="2" name="Title 1">
             <a:extLst>
               <a:ext uri="{FF2B5EF4-FFF2-40B4-BE49-F238E27FC236}">
+                <a16:creationId xmlns:a16="http://schemas.microsoft.com/office/drawing/2014/main" id="{269FB068-6AD7-6770-B2A7-107A9F4366FC}"/>
+              </a:ext>
+            </a:extLst>
+          </p:cNvPr>
+          <p:cNvSpPr>
+            <a:spLocks noGrp="1"/>
+          </p:cNvSpPr>
+          <p:nvPr>
+            <p:ph type="title"/>
+          </p:nvPr>
+        </p:nvSpPr>
+        <p:spPr/>
+        <p:txBody>
+          <a:bodyPr/>
+          <a:lstStyle/>
+          <a:p>
+            <a:r>
+              <a:rPr lang="en-US" dirty="0"/>
+              <a:t>Coding</a:t>
+            </a:r>
+          </a:p>
+        </p:txBody>
+      </p:sp>
+      <p:sp>
+        <p:nvSpPr>
+          <p:cNvPr id="3" name="Content Placeholder 2">
+            <a:extLst>
+              <a:ext uri="{FF2B5EF4-FFF2-40B4-BE49-F238E27FC236}">
+                <a16:creationId xmlns:a16="http://schemas.microsoft.com/office/drawing/2014/main" id="{857A8299-9CED-A1FE-0C2C-CB75D4FCE0BB}"/>
+              </a:ext>
+            </a:extLst>
+          </p:cNvPr>
+          <p:cNvSpPr>
+            <a:spLocks noGrp="1"/>
+          </p:cNvSpPr>
+          <p:nvPr>
+            <p:ph idx="1"/>
+          </p:nvPr>
+        </p:nvSpPr>
+        <p:spPr/>
+        <p:txBody>
+          <a:bodyPr/>
+          <a:lstStyle/>
+          <a:p>
+            <a:pPr marL="0" indent="0">
+              <a:buNone/>
+            </a:pPr>
+            <a:r>
+              <a:rPr lang="en-US" dirty="0"/>
+              <a:t>Const Expr</a:t>
+            </a:r>
+          </a:p>
+          <a:p>
+            <a:pPr marL="0" indent="0">
+              <a:buNone/>
+            </a:pPr>
+            <a:endParaRPr lang="en-US" dirty="0"/>
+          </a:p>
+          <a:p>
+            <a:endParaRPr lang="en-US" dirty="0"/>
+          </a:p>
+        </p:txBody>
+      </p:sp>
+    </p:spTree>
+    <p:extLst>
+      <p:ext uri="{BB962C8B-B14F-4D97-AF65-F5344CB8AC3E}">
+        <p14:creationId xmlns:p14="http://schemas.microsoft.com/office/powerpoint/2010/main" val="4128986287"/>
+      </p:ext>
+    </p:extLst>
+  </p:cSld>
+  <p:clrMapOvr>
+    <a:masterClrMapping/>
+  </p:clrMapOvr>
+</p:sld>
+</file>
+
+<file path=ppt/slides/slide31.xml><?xml version="1.0" encoding="utf-8"?>
+<p:sld xmlns:a="http://schemas.openxmlformats.org/drawingml/2006/main" xmlns:r="http://schemas.openxmlformats.org/officeDocument/2006/relationships" xmlns:p="http://schemas.openxmlformats.org/presentationml/2006/main">
+  <p:cSld>
+    <p:spTree>
+      <p:nvGrpSpPr>
+        <p:cNvPr id="1" name=""/>
+        <p:cNvGrpSpPr/>
+        <p:nvPr/>
+      </p:nvGrpSpPr>
+      <p:grpSpPr>
+        <a:xfrm>
+          <a:off x="0" y="0"/>
+          <a:ext cx="0" cy="0"/>
+          <a:chOff x="0" y="0"/>
+          <a:chExt cx="0" cy="0"/>
+        </a:xfrm>
+      </p:grpSpPr>
+      <p:sp>
+        <p:nvSpPr>
+          <p:cNvPr id="2" name="Title 1">
+            <a:extLst>
+              <a:ext uri="{FF2B5EF4-FFF2-40B4-BE49-F238E27FC236}">
                 <a16:creationId xmlns:a16="http://schemas.microsoft.com/office/drawing/2014/main" id="{18DE167B-A416-AF8F-041B-A98D78C25FB2}"/>
               </a:ext>
             </a:extLst>
@@ -5983,7 +6114,7 @@
 </p:sld>
 </file>
 
-<file path=ppt/slides/slide31.xml><?xml version="1.0" encoding="utf-8"?>
+<file path=ppt/slides/slide32.xml><?xml version="1.0" encoding="utf-8"?>
 <p:sld xmlns:a="http://schemas.openxmlformats.org/drawingml/2006/main" xmlns:r="http://schemas.openxmlformats.org/officeDocument/2006/relationships" xmlns:p="http://schemas.openxmlformats.org/presentationml/2006/main">
   <p:cSld>
     <p:spTree>
@@ -6199,7 +6330,7 @@
             </a:r>
             <a:r>
               <a:rPr lang="en-US" sz="1400" dirty="0"/>
-              <a:t>() (Motion)</a:t>
+              <a:t>() (Motion) ( intentionally logging before motion update to avoid mismatch of time step with systems values</a:t>
             </a:r>
           </a:p>
           <a:p>
@@ -6297,9 +6428,16 @@
             <p:ph idx="1"/>
           </p:nvPr>
         </p:nvSpPr>
-        <p:spPr/>
-        <p:txBody>
-          <a:bodyPr/>
+        <p:spPr>
+          <a:xfrm>
+            <a:off x="838200" y="1825625"/>
+            <a:ext cx="8892654" cy="4351338"/>
+          </a:xfrm>
+        </p:spPr>
+        <p:txBody>
+          <a:bodyPr>
+            <a:normAutofit lnSpcReduction="10000"/>
+          </a:bodyPr>
           <a:lstStyle/>
           <a:p>
             <a:r>
@@ -6354,8 +6492,8 @@
         </p:blipFill>
         <p:spPr>
           <a:xfrm>
-            <a:off x="9600694" y="3198966"/>
-            <a:ext cx="2257442" cy="3162323"/>
+            <a:off x="9348716" y="2277743"/>
+            <a:ext cx="2687347" cy="3764553"/>
           </a:xfrm>
           <a:prstGeom prst="rect">
             <a:avLst/>
@@ -6534,6 +6672,119 @@
           <p:cNvPr id="2" name="Title 1">
             <a:extLst>
               <a:ext uri="{FF2B5EF4-FFF2-40B4-BE49-F238E27FC236}">
+                <a16:creationId xmlns:a16="http://schemas.microsoft.com/office/drawing/2014/main" id="{E5B83AF1-B5B4-69B2-F372-470449CCC3BD}"/>
+              </a:ext>
+            </a:extLst>
+          </p:cNvPr>
+          <p:cNvSpPr>
+            <a:spLocks noGrp="1"/>
+          </p:cNvSpPr>
+          <p:nvPr>
+            <p:ph type="title"/>
+          </p:nvPr>
+        </p:nvSpPr>
+        <p:spPr/>
+        <p:txBody>
+          <a:bodyPr/>
+          <a:lstStyle/>
+          <a:p>
+            <a:r>
+              <a:rPr lang="en-US" dirty="0"/>
+              <a:t>Entity definition</a:t>
+            </a:r>
+          </a:p>
+        </p:txBody>
+      </p:sp>
+      <p:sp>
+        <p:nvSpPr>
+          <p:cNvPr id="3" name="Content Placeholder 2">
+            <a:extLst>
+              <a:ext uri="{FF2B5EF4-FFF2-40B4-BE49-F238E27FC236}">
+                <a16:creationId xmlns:a16="http://schemas.microsoft.com/office/drawing/2014/main" id="{AC9983DB-6704-D6FF-4B6C-D1E573CFF3A1}"/>
+              </a:ext>
+            </a:extLst>
+          </p:cNvPr>
+          <p:cNvSpPr>
+            <a:spLocks noGrp="1"/>
+          </p:cNvSpPr>
+          <p:nvPr>
+            <p:ph idx="1"/>
+          </p:nvPr>
+        </p:nvSpPr>
+        <p:spPr/>
+        <p:txBody>
+          <a:bodyPr>
+            <a:normAutofit fontScale="92500" lnSpcReduction="10000"/>
+          </a:bodyPr>
+          <a:lstStyle/>
+          <a:p>
+            <a:r>
+              <a:rPr lang="en-US" dirty="0"/>
+              <a:t>I am having to decide how I want entity to be structured and more so how I can make the models used and states active and components existing clear and consistently modular just by defining with each instance of an entity, in my motion system if I do switch case for a motion model it makes them mutually exclusive, if I do if statements then I need to define each possible state option and model in the entity. </a:t>
+            </a:r>
+          </a:p>
+          <a:p>
+            <a:endParaRPr lang="en-US" dirty="0"/>
+          </a:p>
+          <a:p>
+            <a:r>
+              <a:rPr lang="en-US" dirty="0"/>
+              <a:t>Seems to make sense to have different </a:t>
+            </a:r>
+            <a:r>
+              <a:rPr lang="en-US" dirty="0" err="1"/>
+              <a:t>subssytems</a:t>
+            </a:r>
+            <a:r>
+              <a:rPr lang="en-US" dirty="0"/>
+              <a:t> have different methods of selecting model, state </a:t>
+            </a:r>
+            <a:r>
+              <a:rPr lang="en-US" dirty="0" err="1"/>
+              <a:t>etc</a:t>
+            </a:r>
+            <a:r>
+              <a:rPr lang="en-US" dirty="0"/>
+              <a:t>, for example the guidance will be fine as switch case because will only ever have one guidance model. Motion on the other hand </a:t>
+            </a:r>
+          </a:p>
+        </p:txBody>
+      </p:sp>
+    </p:spTree>
+    <p:extLst>
+      <p:ext uri="{BB962C8B-B14F-4D97-AF65-F5344CB8AC3E}">
+        <p14:creationId xmlns:p14="http://schemas.microsoft.com/office/powerpoint/2010/main" val="2505765051"/>
+      </p:ext>
+    </p:extLst>
+  </p:cSld>
+  <p:clrMapOvr>
+    <a:masterClrMapping/>
+  </p:clrMapOvr>
+</p:sld>
+</file>
+
+<file path=ppt/slides/slide8.xml><?xml version="1.0" encoding="utf-8"?>
+<p:sld xmlns:a="http://schemas.openxmlformats.org/drawingml/2006/main" xmlns:r="http://schemas.openxmlformats.org/officeDocument/2006/relationships" xmlns:p="http://schemas.openxmlformats.org/presentationml/2006/main">
+  <p:cSld>
+    <p:spTree>
+      <p:nvGrpSpPr>
+        <p:cNvPr id="1" name=""/>
+        <p:cNvGrpSpPr/>
+        <p:nvPr/>
+      </p:nvGrpSpPr>
+      <p:grpSpPr>
+        <a:xfrm>
+          <a:off x="0" y="0"/>
+          <a:ext cx="0" cy="0"/>
+          <a:chOff x="0" y="0"/>
+          <a:chExt cx="0" cy="0"/>
+        </a:xfrm>
+      </p:grpSpPr>
+      <p:sp>
+        <p:nvSpPr>
+          <p:cNvPr id="2" name="Title 1">
+            <a:extLst>
+              <a:ext uri="{FF2B5EF4-FFF2-40B4-BE49-F238E27FC236}">
                 <a16:creationId xmlns:a16="http://schemas.microsoft.com/office/drawing/2014/main" id="{8ACA08C1-3158-975D-F9F6-24CED5953318}"/>
               </a:ext>
             </a:extLst>
@@ -6689,7 +6940,7 @@
 </p:sld>
 </file>
 
-<file path=ppt/slides/slide8.xml><?xml version="1.0" encoding="utf-8"?>
+<file path=ppt/slides/slide9.xml><?xml version="1.0" encoding="utf-8"?>
 <p:sld xmlns:a="http://schemas.openxmlformats.org/drawingml/2006/main" xmlns:r="http://schemas.openxmlformats.org/officeDocument/2006/relationships" xmlns:p="http://schemas.openxmlformats.org/presentationml/2006/main">
   <p:cSld>
     <p:spTree>
@@ -6749,112 +7000,6 @@
     <p:extLst>
       <p:ext uri="{BB962C8B-B14F-4D97-AF65-F5344CB8AC3E}">
         <p14:creationId xmlns:p14="http://schemas.microsoft.com/office/powerpoint/2010/main" val="3880961570"/>
-      </p:ext>
-    </p:extLst>
-  </p:cSld>
-  <p:clrMapOvr>
-    <a:masterClrMapping/>
-  </p:clrMapOvr>
-</p:sld>
-</file>
-
-<file path=ppt/slides/slide9.xml><?xml version="1.0" encoding="utf-8"?>
-<p:sld xmlns:a="http://schemas.openxmlformats.org/drawingml/2006/main" xmlns:r="http://schemas.openxmlformats.org/officeDocument/2006/relationships" xmlns:p="http://schemas.openxmlformats.org/presentationml/2006/main">
-  <p:cSld>
-    <p:spTree>
-      <p:nvGrpSpPr>
-        <p:cNvPr id="1" name="">
-          <a:extLst>
-            <a:ext uri="{FF2B5EF4-FFF2-40B4-BE49-F238E27FC236}">
-              <a16:creationId xmlns:a16="http://schemas.microsoft.com/office/drawing/2014/main" id="{194624A1-D311-60F3-6660-B529F37D540A}"/>
-            </a:ext>
-          </a:extLst>
-        </p:cNvPr>
-        <p:cNvGrpSpPr/>
-        <p:nvPr/>
-      </p:nvGrpSpPr>
-      <p:grpSpPr>
-        <a:xfrm>
-          <a:off x="0" y="0"/>
-          <a:ext cx="0" cy="0"/>
-          <a:chOff x="0" y="0"/>
-          <a:chExt cx="0" cy="0"/>
-        </a:xfrm>
-      </p:grpSpPr>
-      <p:sp>
-        <p:nvSpPr>
-          <p:cNvPr id="2" name="Title 1">
-            <a:extLst>
-              <a:ext uri="{FF2B5EF4-FFF2-40B4-BE49-F238E27FC236}">
-                <a16:creationId xmlns:a16="http://schemas.microsoft.com/office/drawing/2014/main" id="{D1DDBB3A-771B-0C3C-E78E-A7CA942B08E6}"/>
-              </a:ext>
-            </a:extLst>
-          </p:cNvPr>
-          <p:cNvSpPr>
-            <a:spLocks noGrp="1"/>
-          </p:cNvSpPr>
-          <p:nvPr>
-            <p:ph type="title"/>
-          </p:nvPr>
-        </p:nvSpPr>
-        <p:spPr/>
-        <p:txBody>
-          <a:bodyPr/>
-          <a:lstStyle/>
-          <a:p>
-            <a:r>
-              <a:rPr lang="en-US" dirty="0"/>
-              <a:t>Feature Description</a:t>
-            </a:r>
-          </a:p>
-        </p:txBody>
-      </p:sp>
-      <p:sp>
-        <p:nvSpPr>
-          <p:cNvPr id="3" name="Content Placeholder 2">
-            <a:extLst>
-              <a:ext uri="{FF2B5EF4-FFF2-40B4-BE49-F238E27FC236}">
-                <a16:creationId xmlns:a16="http://schemas.microsoft.com/office/drawing/2014/main" id="{E2FB64A5-C3DA-7481-BCA2-1E2072EC340C}"/>
-              </a:ext>
-            </a:extLst>
-          </p:cNvPr>
-          <p:cNvSpPr>
-            <a:spLocks noGrp="1"/>
-          </p:cNvSpPr>
-          <p:nvPr>
-            <p:ph idx="1"/>
-          </p:nvPr>
-        </p:nvSpPr>
-        <p:spPr/>
-        <p:txBody>
-          <a:bodyPr/>
-          <a:lstStyle/>
-          <a:p>
-            <a:r>
-              <a:rPr lang="en-US" dirty="0"/>
-              <a:t>Different systems care about different coordinates</a:t>
-            </a:r>
-          </a:p>
-          <a:p>
-            <a:r>
-              <a:rPr lang="en-US" dirty="0"/>
-              <a:t>Choosing the right makes calculations more useful for </a:t>
-            </a:r>
-            <a:r>
-              <a:rPr lang="en-US" dirty="0" err="1"/>
-              <a:t>specifica</a:t>
-            </a:r>
-            <a:r>
-              <a:rPr lang="en-US" dirty="0"/>
-              <a:t> cases</a:t>
-            </a:r>
-          </a:p>
-        </p:txBody>
-      </p:sp>
-    </p:spTree>
-    <p:extLst>
-      <p:ext uri="{BB962C8B-B14F-4D97-AF65-F5344CB8AC3E}">
-        <p14:creationId xmlns:p14="http://schemas.microsoft.com/office/powerpoint/2010/main" val="4165467339"/>
       </p:ext>
     </p:extLst>
   </p:cSld>

</xml_diff>

<commit_message>
working on radar system, going to get into radar signal processing  functions next. after that comes entity updates, and hopefully run again.
</commit_message>
<xml_diff>
--- a/docs/Apogee_Progession.pptx
+++ b/docs/Apogee_Progession.pptx
@@ -146,7 +146,7 @@
 <file path=ppt/revisionInfo.xml><?xml version="1.0" encoding="utf-8"?>
 <p1510:revInfo xmlns:a="http://schemas.openxmlformats.org/drawingml/2006/main" xmlns:r="http://schemas.openxmlformats.org/officeDocument/2006/relationships" xmlns:p1510="http://schemas.microsoft.com/office/powerpoint/2015/10/main">
   <p1510:revLst>
-    <p1510:client id="{9F88DE7B-4153-4DD5-8CD8-49B431BF79F3}" v="10" dt="2026-10-16T14:53:56.780"/>
+    <p1510:client id="{9F88DE7B-4153-4DD5-8CD8-49B431BF79F3}" v="11" dt="2026-10-19T03:08:02.189"/>
   </p1510:revLst>
 </p1510:revInfo>
 </file>
@@ -156,7 +156,7 @@
   <pc:docChgLst>
     <pc:chgData name="Jeremy Jestel" userId="f12305450eb37733" providerId="LiveId" clId="{5A341855-0C93-42C0-8589-13149EEF218B}"/>
     <pc:docChg chg="undo custSel addSld delSld modSld">
-      <pc:chgData name="Jeremy Jestel" userId="f12305450eb37733" providerId="LiveId" clId="{5A341855-0C93-42C0-8589-13149EEF218B}" dt="2026-10-16T16:19:58.072" v="7937" actId="20577"/>
+      <pc:chgData name="Jeremy Jestel" userId="f12305450eb37733" providerId="LiveId" clId="{5A341855-0C93-42C0-8589-13149EEF218B}" dt="2026-10-19T03:08:35.188" v="8935" actId="20577"/>
       <pc:docMkLst>
         <pc:docMk/>
       </pc:docMkLst>
@@ -176,7 +176,7 @@
         </pc:spChg>
       </pc:sldChg>
       <pc:sldChg chg="modSp new mod">
-        <pc:chgData name="Jeremy Jestel" userId="f12305450eb37733" providerId="LiveId" clId="{5A341855-0C93-42C0-8589-13149EEF218B}" dt="2026-10-16T16:19:58.072" v="7937" actId="20577"/>
+        <pc:chgData name="Jeremy Jestel" userId="f12305450eb37733" providerId="LiveId" clId="{5A341855-0C93-42C0-8589-13149EEF218B}" dt="2026-10-19T03:07:55.750" v="8817" actId="21"/>
         <pc:sldMkLst>
           <pc:docMk/>
           <pc:sldMk cId="4049945487" sldId="257"/>
@@ -190,7 +190,7 @@
           </ac:spMkLst>
         </pc:spChg>
         <pc:spChg chg="mod">
-          <ac:chgData name="Jeremy Jestel" userId="f12305450eb37733" providerId="LiveId" clId="{5A341855-0C93-42C0-8589-13149EEF218B}" dt="2026-10-16T16:19:58.072" v="7937" actId="20577"/>
+          <ac:chgData name="Jeremy Jestel" userId="f12305450eb37733" providerId="LiveId" clId="{5A341855-0C93-42C0-8589-13149EEF218B}" dt="2026-10-19T03:07:55.750" v="8817" actId="21"/>
           <ac:spMkLst>
             <pc:docMk/>
             <pc:sldMk cId="4049945487" sldId="257"/>
@@ -331,12 +331,20 @@
           <pc:sldMk cId="2670624338" sldId="271"/>
         </pc:sldMkLst>
       </pc:sldChg>
-      <pc:sldChg chg="add">
-        <pc:chgData name="Jeremy Jestel" userId="f12305450eb37733" providerId="LiveId" clId="{5A341855-0C93-42C0-8589-13149EEF218B}" dt="2026-10-12T19:18:45.901" v="430"/>
+      <pc:sldChg chg="modSp add mod">
+        <pc:chgData name="Jeremy Jestel" userId="f12305450eb37733" providerId="LiveId" clId="{5A341855-0C93-42C0-8589-13149EEF218B}" dt="2026-10-19T03:08:35.188" v="8935" actId="20577"/>
         <pc:sldMkLst>
           <pc:docMk/>
           <pc:sldMk cId="1431625114" sldId="272"/>
         </pc:sldMkLst>
+        <pc:spChg chg="mod">
+          <ac:chgData name="Jeremy Jestel" userId="f12305450eb37733" providerId="LiveId" clId="{5A341855-0C93-42C0-8589-13149EEF218B}" dt="2026-10-19T03:08:35.188" v="8935" actId="20577"/>
+          <ac:spMkLst>
+            <pc:docMk/>
+            <pc:sldMk cId="1431625114" sldId="272"/>
+            <ac:spMk id="3" creationId="{7D809A1B-4C7B-3A20-E1D9-7F8E230B0E1E}"/>
+          </ac:spMkLst>
+        </pc:spChg>
       </pc:sldChg>
       <pc:sldChg chg="modSp add mod">
         <pc:chgData name="Jeremy Jestel" userId="f12305450eb37733" providerId="LiveId" clId="{5A341855-0C93-42C0-8589-13149EEF218B}" dt="2026-10-14T03:52:04.388" v="3028" actId="20577"/>
@@ -824,7 +832,7 @@
           <a:p>
             <a:fld id="{CEB632EC-697C-46E2-86FC-E2DD52DD9F70}" type="datetimeFigureOut">
               <a:rPr lang="en-US" smtClean="0"/>
-              <a:t>10/16/2026</a:t>
+              <a:t>10/18/2026</a:t>
             </a:fld>
             <a:endParaRPr lang="en-US"/>
           </a:p>
@@ -1022,7 +1030,7 @@
           <a:p>
             <a:fld id="{CEB632EC-697C-46E2-86FC-E2DD52DD9F70}" type="datetimeFigureOut">
               <a:rPr lang="en-US" smtClean="0"/>
-              <a:t>10/16/2026</a:t>
+              <a:t>10/18/2026</a:t>
             </a:fld>
             <a:endParaRPr lang="en-US"/>
           </a:p>
@@ -1230,7 +1238,7 @@
           <a:p>
             <a:fld id="{CEB632EC-697C-46E2-86FC-E2DD52DD9F70}" type="datetimeFigureOut">
               <a:rPr lang="en-US" smtClean="0"/>
-              <a:t>10/16/2026</a:t>
+              <a:t>10/18/2026</a:t>
             </a:fld>
             <a:endParaRPr lang="en-US"/>
           </a:p>
@@ -1428,7 +1436,7 @@
           <a:p>
             <a:fld id="{CEB632EC-697C-46E2-86FC-E2DD52DD9F70}" type="datetimeFigureOut">
               <a:rPr lang="en-US" smtClean="0"/>
-              <a:t>10/16/2026</a:t>
+              <a:t>10/18/2026</a:t>
             </a:fld>
             <a:endParaRPr lang="en-US"/>
           </a:p>
@@ -1703,7 +1711,7 @@
           <a:p>
             <a:fld id="{CEB632EC-697C-46E2-86FC-E2DD52DD9F70}" type="datetimeFigureOut">
               <a:rPr lang="en-US" smtClean="0"/>
-              <a:t>10/16/2026</a:t>
+              <a:t>10/18/2026</a:t>
             </a:fld>
             <a:endParaRPr lang="en-US"/>
           </a:p>
@@ -1968,7 +1976,7 @@
           <a:p>
             <a:fld id="{CEB632EC-697C-46E2-86FC-E2DD52DD9F70}" type="datetimeFigureOut">
               <a:rPr lang="en-US" smtClean="0"/>
-              <a:t>10/16/2026</a:t>
+              <a:t>10/18/2026</a:t>
             </a:fld>
             <a:endParaRPr lang="en-US"/>
           </a:p>
@@ -2380,7 +2388,7 @@
           <a:p>
             <a:fld id="{CEB632EC-697C-46E2-86FC-E2DD52DD9F70}" type="datetimeFigureOut">
               <a:rPr lang="en-US" smtClean="0"/>
-              <a:t>10/16/2026</a:t>
+              <a:t>10/18/2026</a:t>
             </a:fld>
             <a:endParaRPr lang="en-US"/>
           </a:p>
@@ -2521,7 +2529,7 @@
           <a:p>
             <a:fld id="{CEB632EC-697C-46E2-86FC-E2DD52DD9F70}" type="datetimeFigureOut">
               <a:rPr lang="en-US" smtClean="0"/>
-              <a:t>10/16/2026</a:t>
+              <a:t>10/18/2026</a:t>
             </a:fld>
             <a:endParaRPr lang="en-US"/>
           </a:p>
@@ -2634,7 +2642,7 @@
           <a:p>
             <a:fld id="{CEB632EC-697C-46E2-86FC-E2DD52DD9F70}" type="datetimeFigureOut">
               <a:rPr lang="en-US" smtClean="0"/>
-              <a:t>10/16/2026</a:t>
+              <a:t>10/18/2026</a:t>
             </a:fld>
             <a:endParaRPr lang="en-US"/>
           </a:p>
@@ -2945,7 +2953,7 @@
           <a:p>
             <a:fld id="{CEB632EC-697C-46E2-86FC-E2DD52DD9F70}" type="datetimeFigureOut">
               <a:rPr lang="en-US" smtClean="0"/>
-              <a:t>10/16/2026</a:t>
+              <a:t>10/18/2026</a:t>
             </a:fld>
             <a:endParaRPr lang="en-US"/>
           </a:p>
@@ -3233,7 +3241,7 @@
           <a:p>
             <a:fld id="{CEB632EC-697C-46E2-86FC-E2DD52DD9F70}" type="datetimeFigureOut">
               <a:rPr lang="en-US" smtClean="0"/>
-              <a:t>10/16/2026</a:t>
+              <a:t>10/18/2026</a:t>
             </a:fld>
             <a:endParaRPr lang="en-US"/>
           </a:p>
@@ -3474,7 +3482,7 @@
           <a:p>
             <a:fld id="{CEB632EC-697C-46E2-86FC-E2DD52DD9F70}" type="datetimeFigureOut">
               <a:rPr lang="en-US" smtClean="0"/>
-              <a:t>10/16/2026</a:t>
+              <a:t>10/18/2026</a:t>
             </a:fld>
             <a:endParaRPr lang="en-US"/>
           </a:p>
@@ -4929,15 +4937,20 @@
           <a:p>
             <a:r>
               <a:rPr lang="en-US" dirty="0"/>
-              <a:t>Ground radar is stationary on earth, only affected by </a:t>
-            </a:r>
-            <a:r>
-              <a:rPr lang="en-US"/>
-              <a:t>earth rotation</a:t>
-            </a:r>
-          </a:p>
-          <a:p>
-            <a:endParaRPr lang="en-US" dirty="0"/>
+              <a:t>Ground radar is stationary on earth, only affected by earth rotation</a:t>
+            </a:r>
+          </a:p>
+          <a:p>
+            <a:r>
+              <a:rPr lang="en-US" dirty="0"/>
+              <a:t>Locations in ECI, Velocity vector is pointing vector</a:t>
+            </a:r>
+          </a:p>
+          <a:p>
+            <a:r>
+              <a:rPr lang="en-US" dirty="0"/>
+              <a:t>Entities know where same team assets are</a:t>
+            </a:r>
           </a:p>
         </p:txBody>
       </p:sp>
@@ -5023,8 +5036,35 @@
         </p:nvSpPr>
         <p:spPr/>
         <p:txBody>
-          <a:bodyPr/>
-          <a:lstStyle/>
+          <a:bodyPr>
+            <a:normAutofit lnSpcReduction="10000"/>
+          </a:bodyPr>
+          <a:lstStyle/>
+          <a:p>
+            <a:r>
+              <a:rPr lang="en-US" dirty="0"/>
+              <a:t>Because I am using a timestep much larger than a radar </a:t>
+            </a:r>
+            <a:r>
+              <a:rPr lang="en-US" dirty="0" err="1"/>
+              <a:t>prf</a:t>
+            </a:r>
+            <a:r>
+              <a:rPr lang="en-US" dirty="0"/>
+              <a:t> I am not pretending to do a full radar schedule and beam pattern, my goal is to say based on the beamwidth, position of targets, and pointing angle of the beam will this target be visible, and generate a range doppler map live for if a radar CPI occurred at that timestep. When this target is confidently tracked then the interceptor will be queued.</a:t>
+            </a:r>
+          </a:p>
+          <a:p>
+            <a:r>
+              <a:rPr lang="en-US" dirty="0"/>
+              <a:t>Assuming for now the radars have halfsphere coverage area, assuming the scan schedule would be covering enough for reasonably large sampling gap to cover all positions. I chose to check this using the dot product of the </a:t>
+            </a:r>
+            <a:r>
+              <a:rPr lang="en-US"/>
+              <a:t>position vectors</a:t>
+            </a:r>
+            <a:endParaRPr lang="en-US" dirty="0"/>
+          </a:p>
           <a:p>
             <a:endParaRPr lang="en-US" dirty="0"/>
           </a:p>

</xml_diff>

<commit_message>
starting radar work with rnage doppler
</commit_message>
<xml_diff>
--- a/docs/Apogee_Progession.pptx
+++ b/docs/Apogee_Progession.pptx
@@ -4,6 +4,9 @@
   <p:sldMasterIdLst>
     <p:sldMasterId id="2147483648" r:id="rId1"/>
   </p:sldMasterIdLst>
+  <p:notesMasterIdLst>
+    <p:notesMasterId r:id="rId36"/>
+  </p:notesMasterIdLst>
   <p:sldIdLst>
     <p:sldId id="256" r:id="rId2"/>
     <p:sldId id="257" r:id="rId3"/>
@@ -37,6 +40,8 @@
     <p:sldId id="281" r:id="rId31"/>
     <p:sldId id="279" r:id="rId32"/>
     <p:sldId id="280" r:id="rId33"/>
+    <p:sldId id="291" r:id="rId34"/>
+    <p:sldId id="292" r:id="rId35"/>
   </p:sldIdLst>
   <p:sldSz cx="12192000" cy="6858000"/>
   <p:notesSz cx="6858000" cy="9144000"/>
@@ -146,7 +151,7 @@
 <file path=ppt/revisionInfo.xml><?xml version="1.0" encoding="utf-8"?>
 <p1510:revInfo xmlns:a="http://schemas.openxmlformats.org/drawingml/2006/main" xmlns:r="http://schemas.openxmlformats.org/officeDocument/2006/relationships" xmlns:p1510="http://schemas.microsoft.com/office/powerpoint/2015/10/main">
   <p1510:revLst>
-    <p1510:client id="{9F88DE7B-4153-4DD5-8CD8-49B431BF79F3}" v="11" dt="2026-10-19T03:08:02.189"/>
+    <p1510:client id="{9F88DE7B-4153-4DD5-8CD8-49B431BF79F3}" v="12" dt="2026-10-25T03:18:57.903"/>
   </p1510:revLst>
 </p1510:revInfo>
 </file>
@@ -156,7 +161,7 @@
   <pc:docChgLst>
     <pc:chgData name="Jeremy Jestel" userId="f12305450eb37733" providerId="LiveId" clId="{5A341855-0C93-42C0-8589-13149EEF218B}"/>
     <pc:docChg chg="undo custSel addSld delSld modSld">
-      <pc:chgData name="Jeremy Jestel" userId="f12305450eb37733" providerId="LiveId" clId="{5A341855-0C93-42C0-8589-13149EEF218B}" dt="2026-10-19T03:08:35.188" v="8935" actId="20577"/>
+      <pc:chgData name="Jeremy Jestel" userId="f12305450eb37733" providerId="LiveId" clId="{5A341855-0C93-42C0-8589-13149EEF218B}" dt="2026-10-25T03:50:27.021" v="9018" actId="1076"/>
       <pc:docMkLst>
         <pc:docMk/>
       </pc:docMkLst>
@@ -443,26 +448,58 @@
           </ac:spMkLst>
         </pc:spChg>
       </pc:sldChg>
-      <pc:sldChg chg="addSp modSp new mod">
-        <pc:chgData name="Jeremy Jestel" userId="f12305450eb37733" providerId="LiveId" clId="{5A341855-0C93-42C0-8589-13149EEF218B}" dt="2026-10-12T19:52:59.034" v="1416" actId="20577"/>
+      <pc:sldChg chg="addSp delSp modSp new mod">
+        <pc:chgData name="Jeremy Jestel" userId="f12305450eb37733" providerId="LiveId" clId="{5A341855-0C93-42C0-8589-13149EEF218B}" dt="2026-10-25T03:18:05.921" v="9011" actId="14100"/>
         <pc:sldMkLst>
           <pc:docMk/>
           <pc:sldMk cId="1893937781" sldId="280"/>
         </pc:sldMkLst>
         <pc:spChg chg="mod">
-          <ac:chgData name="Jeremy Jestel" userId="f12305450eb37733" providerId="LiveId" clId="{5A341855-0C93-42C0-8589-13149EEF218B}" dt="2026-10-12T19:52:59.034" v="1416" actId="20577"/>
+          <ac:chgData name="Jeremy Jestel" userId="f12305450eb37733" providerId="LiveId" clId="{5A341855-0C93-42C0-8589-13149EEF218B}" dt="2026-10-25T03:16:22.177" v="8987" actId="20577"/>
           <ac:spMkLst>
             <pc:docMk/>
             <pc:sldMk cId="1893937781" sldId="280"/>
             <ac:spMk id="2" creationId="{3F084D8E-B8C0-2CDC-6875-96B063DF1BB4}"/>
           </ac:spMkLst>
         </pc:spChg>
-        <pc:picChg chg="add mod">
-          <ac:chgData name="Jeremy Jestel" userId="f12305450eb37733" providerId="LiveId" clId="{5A341855-0C93-42C0-8589-13149EEF218B}" dt="2026-10-12T19:52:48.065" v="1404" actId="1076"/>
+        <pc:picChg chg="add del mod">
+          <ac:chgData name="Jeremy Jestel" userId="f12305450eb37733" providerId="LiveId" clId="{5A341855-0C93-42C0-8589-13149EEF218B}" dt="2026-10-25T03:15:28.618" v="8940" actId="478"/>
           <ac:picMkLst>
             <pc:docMk/>
             <pc:sldMk cId="1893937781" sldId="280"/>
             <ac:picMk id="4" creationId="{0C3EA623-F2F9-00F3-3743-E0E0B9423D2E}"/>
+          </ac:picMkLst>
+        </pc:picChg>
+        <pc:picChg chg="add del mod">
+          <ac:chgData name="Jeremy Jestel" userId="f12305450eb37733" providerId="LiveId" clId="{5A341855-0C93-42C0-8589-13149EEF218B}" dt="2026-10-25T03:17:59.556" v="9008" actId="478"/>
+          <ac:picMkLst>
+            <pc:docMk/>
+            <pc:sldMk cId="1893937781" sldId="280"/>
+            <ac:picMk id="5" creationId="{97331A8E-2BF8-2104-18F0-37E6DCB1F3C8}"/>
+          </ac:picMkLst>
+        </pc:picChg>
+        <pc:picChg chg="add del mod">
+          <ac:chgData name="Jeremy Jestel" userId="f12305450eb37733" providerId="LiveId" clId="{5A341855-0C93-42C0-8589-13149EEF218B}" dt="2026-10-25T03:17:44.256" v="9004" actId="478"/>
+          <ac:picMkLst>
+            <pc:docMk/>
+            <pc:sldMk cId="1893937781" sldId="280"/>
+            <ac:picMk id="7" creationId="{66E08B0E-29C9-4983-CB65-4AB8145885C2}"/>
+          </ac:picMkLst>
+        </pc:picChg>
+        <pc:picChg chg="add mod">
+          <ac:chgData name="Jeremy Jestel" userId="f12305450eb37733" providerId="LiveId" clId="{5A341855-0C93-42C0-8589-13149EEF218B}" dt="2026-10-25T03:17:49.936" v="9007" actId="14100"/>
+          <ac:picMkLst>
+            <pc:docMk/>
+            <pc:sldMk cId="1893937781" sldId="280"/>
+            <ac:picMk id="9" creationId="{0C6F3249-7F90-CEFF-DBDE-CA777688CE53}"/>
+          </ac:picMkLst>
+        </pc:picChg>
+        <pc:picChg chg="add mod">
+          <ac:chgData name="Jeremy Jestel" userId="f12305450eb37733" providerId="LiveId" clId="{5A341855-0C93-42C0-8589-13149EEF218B}" dt="2026-10-25T03:18:05.921" v="9011" actId="14100"/>
+          <ac:picMkLst>
+            <pc:docMk/>
+            <pc:sldMk cId="1893937781" sldId="280"/>
+            <ac:picMk id="11" creationId="{253A1191-70B2-9489-0C0C-27778377D678}"/>
           </ac:picMkLst>
         </pc:picChg>
       </pc:sldChg>
@@ -680,9 +717,636 @@
           </ac:spMkLst>
         </pc:spChg>
       </pc:sldChg>
+      <pc:sldChg chg="addSp delSp modSp new mod">
+        <pc:chgData name="Jeremy Jestel" userId="f12305450eb37733" providerId="LiveId" clId="{5A341855-0C93-42C0-8589-13149EEF218B}" dt="2026-10-25T03:17:31.269" v="9003" actId="1076"/>
+        <pc:sldMkLst>
+          <pc:docMk/>
+          <pc:sldMk cId="1877038678" sldId="291"/>
+        </pc:sldMkLst>
+        <pc:spChg chg="mod">
+          <ac:chgData name="Jeremy Jestel" userId="f12305450eb37733" providerId="LiveId" clId="{5A341855-0C93-42C0-8589-13149EEF218B}" dt="2026-10-25T03:16:13.910" v="8972" actId="20577"/>
+          <ac:spMkLst>
+            <pc:docMk/>
+            <pc:sldMk cId="1877038678" sldId="291"/>
+            <ac:spMk id="2" creationId="{333C5CDE-5BD3-A296-A418-C7E25E5817A3}"/>
+          </ac:spMkLst>
+        </pc:spChg>
+        <pc:picChg chg="add del mod">
+          <ac:chgData name="Jeremy Jestel" userId="f12305450eb37733" providerId="LiveId" clId="{5A341855-0C93-42C0-8589-13149EEF218B}" dt="2026-10-25T03:17:17.615" v="8999" actId="478"/>
+          <ac:picMkLst>
+            <pc:docMk/>
+            <pc:sldMk cId="1877038678" sldId="291"/>
+            <ac:picMk id="4" creationId="{50DF47E8-069B-707F-1791-DCA4144607D9}"/>
+          </ac:picMkLst>
+        </pc:picChg>
+        <pc:picChg chg="add del mod">
+          <ac:chgData name="Jeremy Jestel" userId="f12305450eb37733" providerId="LiveId" clId="{5A341855-0C93-42C0-8589-13149EEF218B}" dt="2026-10-25T03:16:54.727" v="8994" actId="21"/>
+          <ac:picMkLst>
+            <pc:docMk/>
+            <pc:sldMk cId="1877038678" sldId="291"/>
+            <ac:picMk id="6" creationId="{4B4A271B-3520-AE4E-BB91-99841F77F7D8}"/>
+          </ac:picMkLst>
+        </pc:picChg>
+        <pc:picChg chg="add mod">
+          <ac:chgData name="Jeremy Jestel" userId="f12305450eb37733" providerId="LiveId" clId="{5A341855-0C93-42C0-8589-13149EEF218B}" dt="2026-10-25T03:17:12.234" v="8998" actId="14100"/>
+          <ac:picMkLst>
+            <pc:docMk/>
+            <pc:sldMk cId="1877038678" sldId="291"/>
+            <ac:picMk id="8" creationId="{22BDC7EA-F222-8AFF-83C9-EAB752C2B0AB}"/>
+          </ac:picMkLst>
+        </pc:picChg>
+        <pc:picChg chg="add mod">
+          <ac:chgData name="Jeremy Jestel" userId="f12305450eb37733" providerId="LiveId" clId="{5A341855-0C93-42C0-8589-13149EEF218B}" dt="2026-10-25T03:17:31.269" v="9003" actId="1076"/>
+          <ac:picMkLst>
+            <pc:docMk/>
+            <pc:sldMk cId="1877038678" sldId="291"/>
+            <ac:picMk id="10" creationId="{C545E555-F82E-7CB5-E6DD-04C4FCA7772F}"/>
+          </ac:picMkLst>
+        </pc:picChg>
+      </pc:sldChg>
+      <pc:sldChg chg="addSp delSp modSp add mod">
+        <pc:chgData name="Jeremy Jestel" userId="f12305450eb37733" providerId="LiveId" clId="{5A341855-0C93-42C0-8589-13149EEF218B}" dt="2026-10-25T03:50:27.021" v="9018" actId="1076"/>
+        <pc:sldMkLst>
+          <pc:docMk/>
+          <pc:sldMk cId="782185433" sldId="292"/>
+        </pc:sldMkLst>
+        <pc:spChg chg="mod">
+          <ac:chgData name="Jeremy Jestel" userId="f12305450eb37733" providerId="LiveId" clId="{5A341855-0C93-42C0-8589-13149EEF218B}" dt="2026-10-25T03:19:02.043" v="9014" actId="20577"/>
+          <ac:spMkLst>
+            <pc:docMk/>
+            <pc:sldMk cId="782185433" sldId="292"/>
+            <ac:spMk id="2" creationId="{1CF6D8CE-FF4F-4958-EB05-39F5EA5D8BD2}"/>
+          </ac:spMkLst>
+        </pc:spChg>
+        <pc:picChg chg="add mod">
+          <ac:chgData name="Jeremy Jestel" userId="f12305450eb37733" providerId="LiveId" clId="{5A341855-0C93-42C0-8589-13149EEF218B}" dt="2026-10-25T03:50:27.021" v="9018" actId="1076"/>
+          <ac:picMkLst>
+            <pc:docMk/>
+            <pc:sldMk cId="782185433" sldId="292"/>
+            <ac:picMk id="4" creationId="{5F7C9C87-3D06-D5CF-1FCC-BC4EF4BD2AC6}"/>
+          </ac:picMkLst>
+        </pc:picChg>
+        <pc:picChg chg="del">
+          <ac:chgData name="Jeremy Jestel" userId="f12305450eb37733" providerId="LiveId" clId="{5A341855-0C93-42C0-8589-13149EEF218B}" dt="2026-10-25T03:19:04.726" v="9016" actId="478"/>
+          <ac:picMkLst>
+            <pc:docMk/>
+            <pc:sldMk cId="782185433" sldId="292"/>
+            <ac:picMk id="8" creationId="{41F2FFC5-D512-B16E-3312-989161C17C7B}"/>
+          </ac:picMkLst>
+        </pc:picChg>
+        <pc:picChg chg="del">
+          <ac:chgData name="Jeremy Jestel" userId="f12305450eb37733" providerId="LiveId" clId="{5A341855-0C93-42C0-8589-13149EEF218B}" dt="2026-10-25T03:19:03.339" v="9015" actId="478"/>
+          <ac:picMkLst>
+            <pc:docMk/>
+            <pc:sldMk cId="782185433" sldId="292"/>
+            <ac:picMk id="10" creationId="{49791376-C06E-B685-048B-BC1EC3539FA7}"/>
+          </ac:picMkLst>
+        </pc:picChg>
+      </pc:sldChg>
     </pc:docChg>
   </pc:docChgLst>
 </pc:chgInfo>
+</file>
+
+<file path=ppt/notesMasters/notesMaster1.xml><?xml version="1.0" encoding="utf-8"?>
+<p:notesMaster xmlns:a="http://schemas.openxmlformats.org/drawingml/2006/main" xmlns:r="http://schemas.openxmlformats.org/officeDocument/2006/relationships" xmlns:p="http://schemas.openxmlformats.org/presentationml/2006/main">
+  <p:cSld>
+    <p:bg>
+      <p:bgRef idx="1001">
+        <a:schemeClr val="bg1"/>
+      </p:bgRef>
+    </p:bg>
+    <p:spTree>
+      <p:nvGrpSpPr>
+        <p:cNvPr id="1" name=""/>
+        <p:cNvGrpSpPr/>
+        <p:nvPr/>
+      </p:nvGrpSpPr>
+      <p:grpSpPr>
+        <a:xfrm>
+          <a:off x="0" y="0"/>
+          <a:ext cx="0" cy="0"/>
+          <a:chOff x="0" y="0"/>
+          <a:chExt cx="0" cy="0"/>
+        </a:xfrm>
+      </p:grpSpPr>
+      <p:sp>
+        <p:nvSpPr>
+          <p:cNvPr id="2" name="Header Placeholder 1"/>
+          <p:cNvSpPr>
+            <a:spLocks noGrp="1"/>
+          </p:cNvSpPr>
+          <p:nvPr>
+            <p:ph type="hdr" sz="quarter"/>
+          </p:nvPr>
+        </p:nvSpPr>
+        <p:spPr>
+          <a:xfrm>
+            <a:off x="0" y="0"/>
+            <a:ext cx="2971800" cy="458788"/>
+          </a:xfrm>
+          <a:prstGeom prst="rect">
+            <a:avLst/>
+          </a:prstGeom>
+        </p:spPr>
+        <p:txBody>
+          <a:bodyPr vert="horz" lIns="91440" tIns="45720" rIns="91440" bIns="45720" rtlCol="0"/>
+          <a:lstStyle>
+            <a:lvl1pPr algn="l">
+              <a:defRPr sz="1200"/>
+            </a:lvl1pPr>
+          </a:lstStyle>
+          <a:p>
+            <a:endParaRPr lang="en-US"/>
+          </a:p>
+        </p:txBody>
+      </p:sp>
+      <p:sp>
+        <p:nvSpPr>
+          <p:cNvPr id="3" name="Date Placeholder 2"/>
+          <p:cNvSpPr>
+            <a:spLocks noGrp="1"/>
+          </p:cNvSpPr>
+          <p:nvPr>
+            <p:ph type="dt" idx="1"/>
+          </p:nvPr>
+        </p:nvSpPr>
+        <p:spPr>
+          <a:xfrm>
+            <a:off x="3884613" y="0"/>
+            <a:ext cx="2971800" cy="458788"/>
+          </a:xfrm>
+          <a:prstGeom prst="rect">
+            <a:avLst/>
+          </a:prstGeom>
+        </p:spPr>
+        <p:txBody>
+          <a:bodyPr vert="horz" lIns="91440" tIns="45720" rIns="91440" bIns="45720" rtlCol="0"/>
+          <a:lstStyle>
+            <a:lvl1pPr algn="r">
+              <a:defRPr sz="1200"/>
+            </a:lvl1pPr>
+          </a:lstStyle>
+          <a:p>
+            <a:fld id="{DAF9801D-36A9-4A72-9DD9-47BAA8CB77B9}" type="datetimeFigureOut">
+              <a:rPr lang="en-US" smtClean="0"/>
+              <a:t>10/24/2026</a:t>
+            </a:fld>
+            <a:endParaRPr lang="en-US"/>
+          </a:p>
+        </p:txBody>
+      </p:sp>
+      <p:sp>
+        <p:nvSpPr>
+          <p:cNvPr id="4" name="Slide Image Placeholder 3"/>
+          <p:cNvSpPr>
+            <a:spLocks noGrp="1" noRot="1" noChangeAspect="1"/>
+          </p:cNvSpPr>
+          <p:nvPr>
+            <p:ph type="sldImg" idx="2"/>
+          </p:nvPr>
+        </p:nvSpPr>
+        <p:spPr>
+          <a:xfrm>
+            <a:off x="685800" y="1143000"/>
+            <a:ext cx="5486400" cy="3086100"/>
+          </a:xfrm>
+          <a:prstGeom prst="rect">
+            <a:avLst/>
+          </a:prstGeom>
+          <a:noFill/>
+          <a:ln w="12700">
+            <a:solidFill>
+              <a:prstClr val="black"/>
+            </a:solidFill>
+          </a:ln>
+        </p:spPr>
+        <p:txBody>
+          <a:bodyPr vert="horz" lIns="91440" tIns="45720" rIns="91440" bIns="45720" rtlCol="0" anchor="ctr"/>
+          <a:lstStyle/>
+          <a:p>
+            <a:endParaRPr lang="en-US"/>
+          </a:p>
+        </p:txBody>
+      </p:sp>
+      <p:sp>
+        <p:nvSpPr>
+          <p:cNvPr id="5" name="Notes Placeholder 4"/>
+          <p:cNvSpPr>
+            <a:spLocks noGrp="1"/>
+          </p:cNvSpPr>
+          <p:nvPr>
+            <p:ph type="body" sz="quarter" idx="3"/>
+          </p:nvPr>
+        </p:nvSpPr>
+        <p:spPr>
+          <a:xfrm>
+            <a:off x="685800" y="4400550"/>
+            <a:ext cx="5486400" cy="3600450"/>
+          </a:xfrm>
+          <a:prstGeom prst="rect">
+            <a:avLst/>
+          </a:prstGeom>
+        </p:spPr>
+        <p:txBody>
+          <a:bodyPr vert="horz" lIns="91440" tIns="45720" rIns="91440" bIns="45720" rtlCol="0"/>
+          <a:lstStyle/>
+          <a:p>
+            <a:pPr lvl="0"/>
+            <a:r>
+              <a:rPr lang="en-US"/>
+              <a:t>Click to edit Master text styles</a:t>
+            </a:r>
+          </a:p>
+          <a:p>
+            <a:pPr lvl="1"/>
+            <a:r>
+              <a:rPr lang="en-US"/>
+              <a:t>Second level</a:t>
+            </a:r>
+          </a:p>
+          <a:p>
+            <a:pPr lvl="2"/>
+            <a:r>
+              <a:rPr lang="en-US"/>
+              <a:t>Third level</a:t>
+            </a:r>
+          </a:p>
+          <a:p>
+            <a:pPr lvl="3"/>
+            <a:r>
+              <a:rPr lang="en-US"/>
+              <a:t>Fourth level</a:t>
+            </a:r>
+          </a:p>
+          <a:p>
+            <a:pPr lvl="4"/>
+            <a:r>
+              <a:rPr lang="en-US"/>
+              <a:t>Fifth level</a:t>
+            </a:r>
+          </a:p>
+        </p:txBody>
+      </p:sp>
+      <p:sp>
+        <p:nvSpPr>
+          <p:cNvPr id="6" name="Footer Placeholder 5"/>
+          <p:cNvSpPr>
+            <a:spLocks noGrp="1"/>
+          </p:cNvSpPr>
+          <p:nvPr>
+            <p:ph type="ftr" sz="quarter" idx="4"/>
+          </p:nvPr>
+        </p:nvSpPr>
+        <p:spPr>
+          <a:xfrm>
+            <a:off x="0" y="8685213"/>
+            <a:ext cx="2971800" cy="458787"/>
+          </a:xfrm>
+          <a:prstGeom prst="rect">
+            <a:avLst/>
+          </a:prstGeom>
+        </p:spPr>
+        <p:txBody>
+          <a:bodyPr vert="horz" lIns="91440" tIns="45720" rIns="91440" bIns="45720" rtlCol="0" anchor="b"/>
+          <a:lstStyle>
+            <a:lvl1pPr algn="l">
+              <a:defRPr sz="1200"/>
+            </a:lvl1pPr>
+          </a:lstStyle>
+          <a:p>
+            <a:endParaRPr lang="en-US"/>
+          </a:p>
+        </p:txBody>
+      </p:sp>
+      <p:sp>
+        <p:nvSpPr>
+          <p:cNvPr id="7" name="Slide Number Placeholder 6"/>
+          <p:cNvSpPr>
+            <a:spLocks noGrp="1"/>
+          </p:cNvSpPr>
+          <p:nvPr>
+            <p:ph type="sldNum" sz="quarter" idx="5"/>
+          </p:nvPr>
+        </p:nvSpPr>
+        <p:spPr>
+          <a:xfrm>
+            <a:off x="3884613" y="8685213"/>
+            <a:ext cx="2971800" cy="458787"/>
+          </a:xfrm>
+          <a:prstGeom prst="rect">
+            <a:avLst/>
+          </a:prstGeom>
+        </p:spPr>
+        <p:txBody>
+          <a:bodyPr vert="horz" lIns="91440" tIns="45720" rIns="91440" bIns="45720" rtlCol="0" anchor="b"/>
+          <a:lstStyle>
+            <a:lvl1pPr algn="r">
+              <a:defRPr sz="1200"/>
+            </a:lvl1pPr>
+          </a:lstStyle>
+          <a:p>
+            <a:fld id="{721AAA67-97EA-44F9-8951-4DF8B2B2787D}" type="slidenum">
+              <a:rPr lang="en-US" smtClean="0"/>
+              <a:t>‹#›</a:t>
+            </a:fld>
+            <a:endParaRPr lang="en-US"/>
+          </a:p>
+        </p:txBody>
+      </p:sp>
+    </p:spTree>
+    <p:extLst>
+      <p:ext uri="{BB962C8B-B14F-4D97-AF65-F5344CB8AC3E}">
+        <p14:creationId xmlns:p14="http://schemas.microsoft.com/office/powerpoint/2010/main" val="1732737168"/>
+      </p:ext>
+    </p:extLst>
+  </p:cSld>
+  <p:clrMap bg1="lt1" tx1="dk1" bg2="lt2" tx2="dk2" accent1="accent1" accent2="accent2" accent3="accent3" accent4="accent4" accent5="accent5" accent6="accent6" hlink="hlink" folHlink="folHlink"/>
+  <p:notesStyle>
+    <a:lvl1pPr marL="0" algn="l" defTabSz="914400" rtl="0" eaLnBrk="1" latinLnBrk="0" hangingPunct="1">
+      <a:defRPr sz="1200" kern="1200">
+        <a:solidFill>
+          <a:schemeClr val="tx1"/>
+        </a:solidFill>
+        <a:latin typeface="+mn-lt"/>
+        <a:ea typeface="+mn-ea"/>
+        <a:cs typeface="+mn-cs"/>
+      </a:defRPr>
+    </a:lvl1pPr>
+    <a:lvl2pPr marL="457200" algn="l" defTabSz="914400" rtl="0" eaLnBrk="1" latinLnBrk="0" hangingPunct="1">
+      <a:defRPr sz="1200" kern="1200">
+        <a:solidFill>
+          <a:schemeClr val="tx1"/>
+        </a:solidFill>
+        <a:latin typeface="+mn-lt"/>
+        <a:ea typeface="+mn-ea"/>
+        <a:cs typeface="+mn-cs"/>
+      </a:defRPr>
+    </a:lvl2pPr>
+    <a:lvl3pPr marL="914400" algn="l" defTabSz="914400" rtl="0" eaLnBrk="1" latinLnBrk="0" hangingPunct="1">
+      <a:defRPr sz="1200" kern="1200">
+        <a:solidFill>
+          <a:schemeClr val="tx1"/>
+        </a:solidFill>
+        <a:latin typeface="+mn-lt"/>
+        <a:ea typeface="+mn-ea"/>
+        <a:cs typeface="+mn-cs"/>
+      </a:defRPr>
+    </a:lvl3pPr>
+    <a:lvl4pPr marL="1371600" algn="l" defTabSz="914400" rtl="0" eaLnBrk="1" latinLnBrk="0" hangingPunct="1">
+      <a:defRPr sz="1200" kern="1200">
+        <a:solidFill>
+          <a:schemeClr val="tx1"/>
+        </a:solidFill>
+        <a:latin typeface="+mn-lt"/>
+        <a:ea typeface="+mn-ea"/>
+        <a:cs typeface="+mn-cs"/>
+      </a:defRPr>
+    </a:lvl4pPr>
+    <a:lvl5pPr marL="1828800" algn="l" defTabSz="914400" rtl="0" eaLnBrk="1" latinLnBrk="0" hangingPunct="1">
+      <a:defRPr sz="1200" kern="1200">
+        <a:solidFill>
+          <a:schemeClr val="tx1"/>
+        </a:solidFill>
+        <a:latin typeface="+mn-lt"/>
+        <a:ea typeface="+mn-ea"/>
+        <a:cs typeface="+mn-cs"/>
+      </a:defRPr>
+    </a:lvl5pPr>
+    <a:lvl6pPr marL="2286000" algn="l" defTabSz="914400" rtl="0" eaLnBrk="1" latinLnBrk="0" hangingPunct="1">
+      <a:defRPr sz="1200" kern="1200">
+        <a:solidFill>
+          <a:schemeClr val="tx1"/>
+        </a:solidFill>
+        <a:latin typeface="+mn-lt"/>
+        <a:ea typeface="+mn-ea"/>
+        <a:cs typeface="+mn-cs"/>
+      </a:defRPr>
+    </a:lvl6pPr>
+    <a:lvl7pPr marL="2743200" algn="l" defTabSz="914400" rtl="0" eaLnBrk="1" latinLnBrk="0" hangingPunct="1">
+      <a:defRPr sz="1200" kern="1200">
+        <a:solidFill>
+          <a:schemeClr val="tx1"/>
+        </a:solidFill>
+        <a:latin typeface="+mn-lt"/>
+        <a:ea typeface="+mn-ea"/>
+        <a:cs typeface="+mn-cs"/>
+      </a:defRPr>
+    </a:lvl7pPr>
+    <a:lvl8pPr marL="3200400" algn="l" defTabSz="914400" rtl="0" eaLnBrk="1" latinLnBrk="0" hangingPunct="1">
+      <a:defRPr sz="1200" kern="1200">
+        <a:solidFill>
+          <a:schemeClr val="tx1"/>
+        </a:solidFill>
+        <a:latin typeface="+mn-lt"/>
+        <a:ea typeface="+mn-ea"/>
+        <a:cs typeface="+mn-cs"/>
+      </a:defRPr>
+    </a:lvl8pPr>
+    <a:lvl9pPr marL="3657600" algn="l" defTabSz="914400" rtl="0" eaLnBrk="1" latinLnBrk="0" hangingPunct="1">
+      <a:defRPr sz="1200" kern="1200">
+        <a:solidFill>
+          <a:schemeClr val="tx1"/>
+        </a:solidFill>
+        <a:latin typeface="+mn-lt"/>
+        <a:ea typeface="+mn-ea"/>
+        <a:cs typeface="+mn-cs"/>
+      </a:defRPr>
+    </a:lvl9pPr>
+  </p:notesStyle>
+</p:notesMaster>
+</file>
+
+<file path=ppt/notesSlides/notesSlide1.xml><?xml version="1.0" encoding="utf-8"?>
+<p:notes xmlns:a="http://schemas.openxmlformats.org/drawingml/2006/main" xmlns:r="http://schemas.openxmlformats.org/officeDocument/2006/relationships" xmlns:p="http://schemas.openxmlformats.org/presentationml/2006/main">
+  <p:cSld>
+    <p:spTree>
+      <p:nvGrpSpPr>
+        <p:cNvPr id="1" name=""/>
+        <p:cNvGrpSpPr/>
+        <p:nvPr/>
+      </p:nvGrpSpPr>
+      <p:grpSpPr>
+        <a:xfrm>
+          <a:off x="0" y="0"/>
+          <a:ext cx="0" cy="0"/>
+          <a:chOff x="0" y="0"/>
+          <a:chExt cx="0" cy="0"/>
+        </a:xfrm>
+      </p:grpSpPr>
+      <p:sp>
+        <p:nvSpPr>
+          <p:cNvPr id="2" name="Slide Image Placeholder 1"/>
+          <p:cNvSpPr>
+            <a:spLocks noGrp="1" noRot="1" noChangeAspect="1"/>
+          </p:cNvSpPr>
+          <p:nvPr>
+            <p:ph type="sldImg"/>
+          </p:nvPr>
+        </p:nvSpPr>
+        <p:spPr/>
+      </p:sp>
+      <p:sp>
+        <p:nvSpPr>
+          <p:cNvPr id="3" name="Notes Placeholder 2"/>
+          <p:cNvSpPr>
+            <a:spLocks noGrp="1"/>
+          </p:cNvSpPr>
+          <p:nvPr>
+            <p:ph type="body" idx="1"/>
+          </p:nvPr>
+        </p:nvSpPr>
+        <p:spPr/>
+        <p:txBody>
+          <a:bodyPr/>
+          <a:lstStyle/>
+          <a:p>
+            <a:endParaRPr lang="en-US" dirty="0"/>
+          </a:p>
+        </p:txBody>
+      </p:sp>
+      <p:sp>
+        <p:nvSpPr>
+          <p:cNvPr id="4" name="Slide Number Placeholder 3"/>
+          <p:cNvSpPr>
+            <a:spLocks noGrp="1"/>
+          </p:cNvSpPr>
+          <p:nvPr>
+            <p:ph type="sldNum" sz="quarter" idx="5"/>
+          </p:nvPr>
+        </p:nvSpPr>
+        <p:spPr/>
+        <p:txBody>
+          <a:bodyPr/>
+          <a:lstStyle/>
+          <a:p>
+            <a:fld id="{721AAA67-97EA-44F9-8951-4DF8B2B2787D}" type="slidenum">
+              <a:rPr lang="en-US" smtClean="0"/>
+              <a:t>33</a:t>
+            </a:fld>
+            <a:endParaRPr lang="en-US"/>
+          </a:p>
+        </p:txBody>
+      </p:sp>
+    </p:spTree>
+    <p:extLst>
+      <p:ext uri="{BB962C8B-B14F-4D97-AF65-F5344CB8AC3E}">
+        <p14:creationId xmlns:p14="http://schemas.microsoft.com/office/powerpoint/2010/main" val="2944973489"/>
+      </p:ext>
+    </p:extLst>
+  </p:cSld>
+  <p:clrMapOvr>
+    <a:masterClrMapping/>
+  </p:clrMapOvr>
+</p:notes>
+</file>
+
+<file path=ppt/notesSlides/notesSlide2.xml><?xml version="1.0" encoding="utf-8"?>
+<p:notes xmlns:a="http://schemas.openxmlformats.org/drawingml/2006/main" xmlns:r="http://schemas.openxmlformats.org/officeDocument/2006/relationships" xmlns:p="http://schemas.openxmlformats.org/presentationml/2006/main">
+  <p:cSld>
+    <p:spTree>
+      <p:nvGrpSpPr>
+        <p:cNvPr id="1" name="">
+          <a:extLst>
+            <a:ext uri="{FF2B5EF4-FFF2-40B4-BE49-F238E27FC236}">
+              <a16:creationId xmlns:a16="http://schemas.microsoft.com/office/drawing/2014/main" id="{5F6E872C-5AF9-7208-C580-175A87478AE6}"/>
+            </a:ext>
+          </a:extLst>
+        </p:cNvPr>
+        <p:cNvGrpSpPr/>
+        <p:nvPr/>
+      </p:nvGrpSpPr>
+      <p:grpSpPr>
+        <a:xfrm>
+          <a:off x="0" y="0"/>
+          <a:ext cx="0" cy="0"/>
+          <a:chOff x="0" y="0"/>
+          <a:chExt cx="0" cy="0"/>
+        </a:xfrm>
+      </p:grpSpPr>
+      <p:sp>
+        <p:nvSpPr>
+          <p:cNvPr id="2" name="Slide Image Placeholder 1">
+            <a:extLst>
+              <a:ext uri="{FF2B5EF4-FFF2-40B4-BE49-F238E27FC236}">
+                <a16:creationId xmlns:a16="http://schemas.microsoft.com/office/drawing/2014/main" id="{BD9EE8A7-6319-D007-985C-55CE35CCC517}"/>
+              </a:ext>
+            </a:extLst>
+          </p:cNvPr>
+          <p:cNvSpPr>
+            <a:spLocks noGrp="1" noRot="1" noChangeAspect="1"/>
+          </p:cNvSpPr>
+          <p:nvPr>
+            <p:ph type="sldImg"/>
+          </p:nvPr>
+        </p:nvSpPr>
+        <p:spPr/>
+      </p:sp>
+      <p:sp>
+        <p:nvSpPr>
+          <p:cNvPr id="3" name="Notes Placeholder 2">
+            <a:extLst>
+              <a:ext uri="{FF2B5EF4-FFF2-40B4-BE49-F238E27FC236}">
+                <a16:creationId xmlns:a16="http://schemas.microsoft.com/office/drawing/2014/main" id="{E384FA4A-7DB4-6E24-6305-3597CFA06341}"/>
+              </a:ext>
+            </a:extLst>
+          </p:cNvPr>
+          <p:cNvSpPr>
+            <a:spLocks noGrp="1"/>
+          </p:cNvSpPr>
+          <p:nvPr>
+            <p:ph type="body" idx="1"/>
+          </p:nvPr>
+        </p:nvSpPr>
+        <p:spPr/>
+        <p:txBody>
+          <a:bodyPr/>
+          <a:lstStyle/>
+          <a:p>
+            <a:endParaRPr lang="en-US" dirty="0"/>
+          </a:p>
+        </p:txBody>
+      </p:sp>
+      <p:sp>
+        <p:nvSpPr>
+          <p:cNvPr id="4" name="Slide Number Placeholder 3">
+            <a:extLst>
+              <a:ext uri="{FF2B5EF4-FFF2-40B4-BE49-F238E27FC236}">
+                <a16:creationId xmlns:a16="http://schemas.microsoft.com/office/drawing/2014/main" id="{5AA34775-1BCA-D9C4-A9D8-E6810311FC73}"/>
+              </a:ext>
+            </a:extLst>
+          </p:cNvPr>
+          <p:cNvSpPr>
+            <a:spLocks noGrp="1"/>
+          </p:cNvSpPr>
+          <p:nvPr>
+            <p:ph type="sldNum" sz="quarter" idx="5"/>
+          </p:nvPr>
+        </p:nvSpPr>
+        <p:spPr/>
+        <p:txBody>
+          <a:bodyPr/>
+          <a:lstStyle/>
+          <a:p>
+            <a:fld id="{721AAA67-97EA-44F9-8951-4DF8B2B2787D}" type="slidenum">
+              <a:rPr lang="en-US" smtClean="0"/>
+              <a:t>34</a:t>
+            </a:fld>
+            <a:endParaRPr lang="en-US"/>
+          </a:p>
+        </p:txBody>
+      </p:sp>
+    </p:spTree>
+    <p:extLst>
+      <p:ext uri="{BB962C8B-B14F-4D97-AF65-F5344CB8AC3E}">
+        <p14:creationId xmlns:p14="http://schemas.microsoft.com/office/powerpoint/2010/main" val="3090481237"/>
+      </p:ext>
+    </p:extLst>
+  </p:cSld>
+  <p:clrMapOvr>
+    <a:masterClrMapping/>
+  </p:clrMapOvr>
+</p:notes>
 </file>
 
 <file path=ppt/slideLayouts/slideLayout1.xml><?xml version="1.0" encoding="utf-8"?>
@@ -832,7 +1496,7 @@
           <a:p>
             <a:fld id="{CEB632EC-697C-46E2-86FC-E2DD52DD9F70}" type="datetimeFigureOut">
               <a:rPr lang="en-US" smtClean="0"/>
-              <a:t>10/18/2026</a:t>
+              <a:t>10/24/2026</a:t>
             </a:fld>
             <a:endParaRPr lang="en-US"/>
           </a:p>
@@ -1030,7 +1694,7 @@
           <a:p>
             <a:fld id="{CEB632EC-697C-46E2-86FC-E2DD52DD9F70}" type="datetimeFigureOut">
               <a:rPr lang="en-US" smtClean="0"/>
-              <a:t>10/18/2026</a:t>
+              <a:t>10/24/2026</a:t>
             </a:fld>
             <a:endParaRPr lang="en-US"/>
           </a:p>
@@ -1238,7 +1902,7 @@
           <a:p>
             <a:fld id="{CEB632EC-697C-46E2-86FC-E2DD52DD9F70}" type="datetimeFigureOut">
               <a:rPr lang="en-US" smtClean="0"/>
-              <a:t>10/18/2026</a:t>
+              <a:t>10/24/2026</a:t>
             </a:fld>
             <a:endParaRPr lang="en-US"/>
           </a:p>
@@ -1436,7 +2100,7 @@
           <a:p>
             <a:fld id="{CEB632EC-697C-46E2-86FC-E2DD52DD9F70}" type="datetimeFigureOut">
               <a:rPr lang="en-US" smtClean="0"/>
-              <a:t>10/18/2026</a:t>
+              <a:t>10/24/2026</a:t>
             </a:fld>
             <a:endParaRPr lang="en-US"/>
           </a:p>
@@ -1711,7 +2375,7 @@
           <a:p>
             <a:fld id="{CEB632EC-697C-46E2-86FC-E2DD52DD9F70}" type="datetimeFigureOut">
               <a:rPr lang="en-US" smtClean="0"/>
-              <a:t>10/18/2026</a:t>
+              <a:t>10/24/2026</a:t>
             </a:fld>
             <a:endParaRPr lang="en-US"/>
           </a:p>
@@ -1976,7 +2640,7 @@
           <a:p>
             <a:fld id="{CEB632EC-697C-46E2-86FC-E2DD52DD9F70}" type="datetimeFigureOut">
               <a:rPr lang="en-US" smtClean="0"/>
-              <a:t>10/18/2026</a:t>
+              <a:t>10/24/2026</a:t>
             </a:fld>
             <a:endParaRPr lang="en-US"/>
           </a:p>
@@ -2388,7 +3052,7 @@
           <a:p>
             <a:fld id="{CEB632EC-697C-46E2-86FC-E2DD52DD9F70}" type="datetimeFigureOut">
               <a:rPr lang="en-US" smtClean="0"/>
-              <a:t>10/18/2026</a:t>
+              <a:t>10/24/2026</a:t>
             </a:fld>
             <a:endParaRPr lang="en-US"/>
           </a:p>
@@ -2529,7 +3193,7 @@
           <a:p>
             <a:fld id="{CEB632EC-697C-46E2-86FC-E2DD52DD9F70}" type="datetimeFigureOut">
               <a:rPr lang="en-US" smtClean="0"/>
-              <a:t>10/18/2026</a:t>
+              <a:t>10/24/2026</a:t>
             </a:fld>
             <a:endParaRPr lang="en-US"/>
           </a:p>
@@ -2642,7 +3306,7 @@
           <a:p>
             <a:fld id="{CEB632EC-697C-46E2-86FC-E2DD52DD9F70}" type="datetimeFigureOut">
               <a:rPr lang="en-US" smtClean="0"/>
-              <a:t>10/18/2026</a:t>
+              <a:t>10/24/2026</a:t>
             </a:fld>
             <a:endParaRPr lang="en-US"/>
           </a:p>
@@ -2953,7 +3617,7 @@
           <a:p>
             <a:fld id="{CEB632EC-697C-46E2-86FC-E2DD52DD9F70}" type="datetimeFigureOut">
               <a:rPr lang="en-US" smtClean="0"/>
-              <a:t>10/18/2026</a:t>
+              <a:t>10/24/2026</a:t>
             </a:fld>
             <a:endParaRPr lang="en-US"/>
           </a:p>
@@ -3241,7 +3905,7 @@
           <a:p>
             <a:fld id="{CEB632EC-697C-46E2-86FC-E2DD52DD9F70}" type="datetimeFigureOut">
               <a:rPr lang="en-US" smtClean="0"/>
-              <a:t>10/18/2026</a:t>
+              <a:t>10/24/2026</a:t>
             </a:fld>
             <a:endParaRPr lang="en-US"/>
           </a:p>
@@ -3482,7 +4146,7 @@
           <a:p>
             <a:fld id="{CEB632EC-697C-46E2-86FC-E2DD52DD9F70}" type="datetimeFigureOut">
               <a:rPr lang="en-US" smtClean="0"/>
-              <a:t>10/18/2026</a:t>
+              <a:t>10/24/2026</a:t>
             </a:fld>
             <a:endParaRPr lang="en-US"/>
           </a:p>
@@ -6194,17 +6858,17 @@
           <a:p>
             <a:r>
               <a:rPr lang="en-US" dirty="0"/>
-              <a:t>Eigen Syntax</a:t>
+              <a:t>Syntax Part 1</a:t>
             </a:r>
           </a:p>
         </p:txBody>
       </p:sp>
       <p:pic>
         <p:nvPicPr>
-          <p:cNvPr id="4" name="Picture 3">
-            <a:extLst>
-              <a:ext uri="{FF2B5EF4-FFF2-40B4-BE49-F238E27FC236}">
-                <a16:creationId xmlns:a16="http://schemas.microsoft.com/office/drawing/2014/main" id="{0C3EA623-F2F9-00F3-3743-E0E0B9423D2E}"/>
+          <p:cNvPr id="9" name="Picture 8">
+            <a:extLst>
+              <a:ext uri="{FF2B5EF4-FFF2-40B4-BE49-F238E27FC236}">
+                <a16:creationId xmlns:a16="http://schemas.microsoft.com/office/drawing/2014/main" id="{0C6F3249-7F90-CEFF-DBDE-CA777688CE53}"/>
               </a:ext>
             </a:extLst>
           </p:cNvPr>
@@ -6221,8 +6885,38 @@
         </p:blipFill>
         <p:spPr>
           <a:xfrm>
-            <a:off x="2968116" y="1754763"/>
-            <a:ext cx="5844111" cy="4908568"/>
+            <a:off x="7186600" y="208665"/>
+            <a:ext cx="4240090" cy="6284210"/>
+          </a:xfrm>
+          <a:prstGeom prst="rect">
+            <a:avLst/>
+          </a:prstGeom>
+        </p:spPr>
+      </p:pic>
+      <p:pic>
+        <p:nvPicPr>
+          <p:cNvPr id="11" name="Picture 10">
+            <a:extLst>
+              <a:ext uri="{FF2B5EF4-FFF2-40B4-BE49-F238E27FC236}">
+                <a16:creationId xmlns:a16="http://schemas.microsoft.com/office/drawing/2014/main" id="{253A1191-70B2-9489-0C0C-27778377D678}"/>
+              </a:ext>
+            </a:extLst>
+          </p:cNvPr>
+          <p:cNvPicPr>
+            <a:picLocks noChangeAspect="1"/>
+          </p:cNvPicPr>
+          <p:nvPr/>
+        </p:nvPicPr>
+        <p:blipFill>
+          <a:blip r:embed="rId3"/>
+          <a:stretch>
+            <a:fillRect/>
+          </a:stretch>
+        </p:blipFill>
+        <p:spPr>
+          <a:xfrm>
+            <a:off x="335090" y="1473764"/>
+            <a:ext cx="6412073" cy="5051936"/>
           </a:xfrm>
           <a:prstGeom prst="rect">
             <a:avLst/>
@@ -6233,6 +6927,218 @@
     <p:extLst>
       <p:ext uri="{BB962C8B-B14F-4D97-AF65-F5344CB8AC3E}">
         <p14:creationId xmlns:p14="http://schemas.microsoft.com/office/powerpoint/2010/main" val="1893937781"/>
+      </p:ext>
+    </p:extLst>
+  </p:cSld>
+  <p:clrMapOvr>
+    <a:masterClrMapping/>
+  </p:clrMapOvr>
+</p:sld>
+</file>
+
+<file path=ppt/slides/slide33.xml><?xml version="1.0" encoding="utf-8"?>
+<p:sld xmlns:a="http://schemas.openxmlformats.org/drawingml/2006/main" xmlns:r="http://schemas.openxmlformats.org/officeDocument/2006/relationships" xmlns:p="http://schemas.openxmlformats.org/presentationml/2006/main">
+  <p:cSld>
+    <p:spTree>
+      <p:nvGrpSpPr>
+        <p:cNvPr id="1" name=""/>
+        <p:cNvGrpSpPr/>
+        <p:nvPr/>
+      </p:nvGrpSpPr>
+      <p:grpSpPr>
+        <a:xfrm>
+          <a:off x="0" y="0"/>
+          <a:ext cx="0" cy="0"/>
+          <a:chOff x="0" y="0"/>
+          <a:chExt cx="0" cy="0"/>
+        </a:xfrm>
+      </p:grpSpPr>
+      <p:sp>
+        <p:nvSpPr>
+          <p:cNvPr id="2" name="Title 1">
+            <a:extLst>
+              <a:ext uri="{FF2B5EF4-FFF2-40B4-BE49-F238E27FC236}">
+                <a16:creationId xmlns:a16="http://schemas.microsoft.com/office/drawing/2014/main" id="{333C5CDE-5BD3-A296-A418-C7E25E5817A3}"/>
+              </a:ext>
+            </a:extLst>
+          </p:cNvPr>
+          <p:cNvSpPr>
+            <a:spLocks noGrp="1"/>
+          </p:cNvSpPr>
+          <p:nvPr>
+            <p:ph type="title"/>
+          </p:nvPr>
+        </p:nvSpPr>
+        <p:spPr/>
+        <p:txBody>
+          <a:bodyPr/>
+          <a:lstStyle/>
+          <a:p>
+            <a:r>
+              <a:rPr lang="en-US" dirty="0"/>
+              <a:t>Syntax Part 2</a:t>
+            </a:r>
+          </a:p>
+        </p:txBody>
+      </p:sp>
+      <p:pic>
+        <p:nvPicPr>
+          <p:cNvPr id="8" name="Picture 7">
+            <a:extLst>
+              <a:ext uri="{FF2B5EF4-FFF2-40B4-BE49-F238E27FC236}">
+                <a16:creationId xmlns:a16="http://schemas.microsoft.com/office/drawing/2014/main" id="{22BDC7EA-F222-8AFF-83C9-EAB752C2B0AB}"/>
+              </a:ext>
+            </a:extLst>
+          </p:cNvPr>
+          <p:cNvPicPr>
+            <a:picLocks noChangeAspect="1"/>
+          </p:cNvPicPr>
+          <p:nvPr/>
+        </p:nvPicPr>
+        <p:blipFill>
+          <a:blip r:embed="rId3"/>
+          <a:stretch>
+            <a:fillRect/>
+          </a:stretch>
+        </p:blipFill>
+        <p:spPr>
+          <a:xfrm>
+            <a:off x="6636175" y="468449"/>
+            <a:ext cx="4953151" cy="6112106"/>
+          </a:xfrm>
+          <a:prstGeom prst="rect">
+            <a:avLst/>
+          </a:prstGeom>
+        </p:spPr>
+      </p:pic>
+      <p:pic>
+        <p:nvPicPr>
+          <p:cNvPr id="10" name="Picture 9">
+            <a:extLst>
+              <a:ext uri="{FF2B5EF4-FFF2-40B4-BE49-F238E27FC236}">
+                <a16:creationId xmlns:a16="http://schemas.microsoft.com/office/drawing/2014/main" id="{C545E555-F82E-7CB5-E6DD-04C4FCA7772F}"/>
+              </a:ext>
+            </a:extLst>
+          </p:cNvPr>
+          <p:cNvPicPr>
+            <a:picLocks noChangeAspect="1"/>
+          </p:cNvPicPr>
+          <p:nvPr/>
+        </p:nvPicPr>
+        <p:blipFill>
+          <a:blip r:embed="rId4"/>
+          <a:stretch>
+            <a:fillRect/>
+          </a:stretch>
+        </p:blipFill>
+        <p:spPr>
+          <a:xfrm>
+            <a:off x="1683327" y="1357730"/>
+            <a:ext cx="4218709" cy="5399947"/>
+          </a:xfrm>
+          <a:prstGeom prst="rect">
+            <a:avLst/>
+          </a:prstGeom>
+        </p:spPr>
+      </p:pic>
+    </p:spTree>
+    <p:extLst>
+      <p:ext uri="{BB962C8B-B14F-4D97-AF65-F5344CB8AC3E}">
+        <p14:creationId xmlns:p14="http://schemas.microsoft.com/office/powerpoint/2010/main" val="1877038678"/>
+      </p:ext>
+    </p:extLst>
+  </p:cSld>
+  <p:clrMapOvr>
+    <a:masterClrMapping/>
+  </p:clrMapOvr>
+</p:sld>
+</file>
+
+<file path=ppt/slides/slide34.xml><?xml version="1.0" encoding="utf-8"?>
+<p:sld xmlns:a="http://schemas.openxmlformats.org/drawingml/2006/main" xmlns:r="http://schemas.openxmlformats.org/officeDocument/2006/relationships" xmlns:p="http://schemas.openxmlformats.org/presentationml/2006/main">
+  <p:cSld>
+    <p:spTree>
+      <p:nvGrpSpPr>
+        <p:cNvPr id="1" name="">
+          <a:extLst>
+            <a:ext uri="{FF2B5EF4-FFF2-40B4-BE49-F238E27FC236}">
+              <a16:creationId xmlns:a16="http://schemas.microsoft.com/office/drawing/2014/main" id="{7C037B68-3DFE-37E1-407F-4514B7D16B95}"/>
+            </a:ext>
+          </a:extLst>
+        </p:cNvPr>
+        <p:cNvGrpSpPr/>
+        <p:nvPr/>
+      </p:nvGrpSpPr>
+      <p:grpSpPr>
+        <a:xfrm>
+          <a:off x="0" y="0"/>
+          <a:ext cx="0" cy="0"/>
+          <a:chOff x="0" y="0"/>
+          <a:chExt cx="0" cy="0"/>
+        </a:xfrm>
+      </p:grpSpPr>
+      <p:sp>
+        <p:nvSpPr>
+          <p:cNvPr id="2" name="Title 1">
+            <a:extLst>
+              <a:ext uri="{FF2B5EF4-FFF2-40B4-BE49-F238E27FC236}">
+                <a16:creationId xmlns:a16="http://schemas.microsoft.com/office/drawing/2014/main" id="{1CF6D8CE-FF4F-4958-EB05-39F5EA5D8BD2}"/>
+              </a:ext>
+            </a:extLst>
+          </p:cNvPr>
+          <p:cNvSpPr>
+            <a:spLocks noGrp="1"/>
+          </p:cNvSpPr>
+          <p:nvPr>
+            <p:ph type="title"/>
+          </p:nvPr>
+        </p:nvSpPr>
+        <p:spPr/>
+        <p:txBody>
+          <a:bodyPr/>
+          <a:lstStyle/>
+          <a:p>
+            <a:r>
+              <a:rPr lang="en-US" dirty="0"/>
+              <a:t>Syntax Part 3</a:t>
+            </a:r>
+          </a:p>
+        </p:txBody>
+      </p:sp>
+      <p:pic>
+        <p:nvPicPr>
+          <p:cNvPr id="4" name="Picture 3">
+            <a:extLst>
+              <a:ext uri="{FF2B5EF4-FFF2-40B4-BE49-F238E27FC236}">
+                <a16:creationId xmlns:a16="http://schemas.microsoft.com/office/drawing/2014/main" id="{5F7C9C87-3D06-D5CF-1FCC-BC4EF4BD2AC6}"/>
+              </a:ext>
+            </a:extLst>
+          </p:cNvPr>
+          <p:cNvPicPr>
+            <a:picLocks noChangeAspect="1"/>
+          </p:cNvPicPr>
+          <p:nvPr/>
+        </p:nvPicPr>
+        <p:blipFill>
+          <a:blip r:embed="rId3"/>
+          <a:stretch>
+            <a:fillRect/>
+          </a:stretch>
+        </p:blipFill>
+        <p:spPr>
+          <a:xfrm>
+            <a:off x="4692777" y="152376"/>
+            <a:ext cx="4829210" cy="6553248"/>
+          </a:xfrm>
+          <a:prstGeom prst="rect">
+            <a:avLst/>
+          </a:prstGeom>
+        </p:spPr>
+      </p:pic>
+    </p:spTree>
+    <p:extLst>
+      <p:ext uri="{BB962C8B-B14F-4D97-AF65-F5344CB8AC3E}">
+        <p14:creationId xmlns:p14="http://schemas.microsoft.com/office/powerpoint/2010/main" val="782185433"/>
       </p:ext>
     </p:extLst>
   </p:cSld>
@@ -7362,4 +8268,319 @@
     </a:ext>
   </a:extLst>
 </a:theme>
+</file>
+
+<file path=ppt/theme/theme2.xml><?xml version="1.0" encoding="utf-8"?>
+<a:theme xmlns:a="http://schemas.openxmlformats.org/drawingml/2006/main" name="Office Theme">
+  <a:themeElements>
+    <a:clrScheme name="Office">
+      <a:dk1>
+        <a:sysClr val="windowText" lastClr="000000"/>
+      </a:dk1>
+      <a:lt1>
+        <a:sysClr val="window" lastClr="FFFFFF"/>
+      </a:lt1>
+      <a:dk2>
+        <a:srgbClr val="0E2841"/>
+      </a:dk2>
+      <a:lt2>
+        <a:srgbClr val="E8E8E8"/>
+      </a:lt2>
+      <a:accent1>
+        <a:srgbClr val="156082"/>
+      </a:accent1>
+      <a:accent2>
+        <a:srgbClr val="E97132"/>
+      </a:accent2>
+      <a:accent3>
+        <a:srgbClr val="196B24"/>
+      </a:accent3>
+      <a:accent4>
+        <a:srgbClr val="0F9ED5"/>
+      </a:accent4>
+      <a:accent5>
+        <a:srgbClr val="A02B93"/>
+      </a:accent5>
+      <a:accent6>
+        <a:srgbClr val="4EA72E"/>
+      </a:accent6>
+      <a:hlink>
+        <a:srgbClr val="467886"/>
+      </a:hlink>
+      <a:folHlink>
+        <a:srgbClr val="96607D"/>
+      </a:folHlink>
+    </a:clrScheme>
+    <a:fontScheme name="Office">
+      <a:majorFont>
+        <a:latin typeface="Aptos Display" panose="02110004020202020204"/>
+        <a:ea typeface=""/>
+        <a:cs typeface=""/>
+        <a:font script="Jpan" typeface="游ゴシック Light"/>
+        <a:font script="Hang" typeface="맑은 고딕"/>
+        <a:font script="Hans" typeface="等线 Light"/>
+        <a:font script="Hant" typeface="新細明體"/>
+        <a:font script="Arab" typeface="Times New Roman"/>
+        <a:font script="Hebr" typeface="Times New Roman"/>
+        <a:font script="Thai" typeface="Angsana New"/>
+        <a:font script="Ethi" typeface="Nyala"/>
+        <a:font script="Beng" typeface="Vrinda"/>
+        <a:font script="Gujr" typeface="Shruti"/>
+        <a:font script="Khmr" typeface="MoolBoran"/>
+        <a:font script="Knda" typeface="Tunga"/>
+        <a:font script="Guru" typeface="Raavi"/>
+        <a:font script="Cans" typeface="Euphemia"/>
+        <a:font script="Cher" typeface="Plantagenet Cherokee"/>
+        <a:font script="Yiii" typeface="Microsoft Yi Baiti"/>
+        <a:font script="Tibt" typeface="Microsoft Himalaya"/>
+        <a:font script="Thaa" typeface="MV Boli"/>
+        <a:font script="Deva" typeface="Mangal"/>
+        <a:font script="Telu" typeface="Gautami"/>
+        <a:font script="Taml" typeface="Latha"/>
+        <a:font script="Syrc" typeface="Estrangelo Edessa"/>
+        <a:font script="Orya" typeface="Kalinga"/>
+        <a:font script="Mlym" typeface="Kartika"/>
+        <a:font script="Laoo" typeface="DokChampa"/>
+        <a:font script="Sinh" typeface="Iskoola Pota"/>
+        <a:font script="Mong" typeface="Mongolian Baiti"/>
+        <a:font script="Viet" typeface="Times New Roman"/>
+        <a:font script="Uigh" typeface="Microsoft Uighur"/>
+        <a:font script="Geor" typeface="Sylfaen"/>
+        <a:font script="Armn" typeface="Arial"/>
+        <a:font script="Bugi" typeface="Leelawadee UI"/>
+        <a:font script="Bopo" typeface="Microsoft JhengHei"/>
+        <a:font script="Java" typeface="Javanese Text"/>
+        <a:font script="Lisu" typeface="Segoe UI"/>
+        <a:font script="Mymr" typeface="Myanmar Text"/>
+        <a:font script="Nkoo" typeface="Ebrima"/>
+        <a:font script="Olck" typeface="Nirmala UI"/>
+        <a:font script="Osma" typeface="Ebrima"/>
+        <a:font script="Phag" typeface="Phagspa"/>
+        <a:font script="Syrn" typeface="Estrangelo Edessa"/>
+        <a:font script="Syrj" typeface="Estrangelo Edessa"/>
+        <a:font script="Syre" typeface="Estrangelo Edessa"/>
+        <a:font script="Sora" typeface="Nirmala UI"/>
+        <a:font script="Tale" typeface="Microsoft Tai Le"/>
+        <a:font script="Talu" typeface="Microsoft New Tai Lue"/>
+        <a:font script="Tfng" typeface="Ebrima"/>
+      </a:majorFont>
+      <a:minorFont>
+        <a:latin typeface="Aptos" panose="02110004020202020204"/>
+        <a:ea typeface=""/>
+        <a:cs typeface=""/>
+        <a:font script="Jpan" typeface="游ゴシック"/>
+        <a:font script="Hang" typeface="맑은 고딕"/>
+        <a:font script="Hans" typeface="等线"/>
+        <a:font script="Hant" typeface="新細明體"/>
+        <a:font script="Arab" typeface="Arial"/>
+        <a:font script="Hebr" typeface="Arial"/>
+        <a:font script="Thai" typeface="Cordia New"/>
+        <a:font script="Ethi" typeface="Nyala"/>
+        <a:font script="Beng" typeface="Vrinda"/>
+        <a:font script="Gujr" typeface="Shruti"/>
+        <a:font script="Khmr" typeface="DaunPenh"/>
+        <a:font script="Knda" typeface="Tunga"/>
+        <a:font script="Guru" typeface="Raavi"/>
+        <a:font script="Cans" typeface="Euphemia"/>
+        <a:font script="Cher" typeface="Plantagenet Cherokee"/>
+        <a:font script="Yiii" typeface="Microsoft Yi Baiti"/>
+        <a:font script="Tibt" typeface="Microsoft Himalaya"/>
+        <a:font script="Thaa" typeface="MV Boli"/>
+        <a:font script="Deva" typeface="Mangal"/>
+        <a:font script="Telu" typeface="Gautami"/>
+        <a:font script="Taml" typeface="Latha"/>
+        <a:font script="Syrc" typeface="Estrangelo Edessa"/>
+        <a:font script="Orya" typeface="Kalinga"/>
+        <a:font script="Mlym" typeface="Kartika"/>
+        <a:font script="Laoo" typeface="DokChampa"/>
+        <a:font script="Sinh" typeface="Iskoola Pota"/>
+        <a:font script="Mong" typeface="Mongolian Baiti"/>
+        <a:font script="Viet" typeface="Arial"/>
+        <a:font script="Uigh" typeface="Microsoft Uighur"/>
+        <a:font script="Geor" typeface="Sylfaen"/>
+        <a:font script="Armn" typeface="Arial"/>
+        <a:font script="Bugi" typeface="Leelawadee UI"/>
+        <a:font script="Bopo" typeface="Microsoft JhengHei"/>
+        <a:font script="Java" typeface="Javanese Text"/>
+        <a:font script="Lisu" typeface="Segoe UI"/>
+        <a:font script="Mymr" typeface="Myanmar Text"/>
+        <a:font script="Nkoo" typeface="Ebrima"/>
+        <a:font script="Olck" typeface="Nirmala UI"/>
+        <a:font script="Osma" typeface="Ebrima"/>
+        <a:font script="Phag" typeface="Phagspa"/>
+        <a:font script="Syrn" typeface="Estrangelo Edessa"/>
+        <a:font script="Syrj" typeface="Estrangelo Edessa"/>
+        <a:font script="Syre" typeface="Estrangelo Edessa"/>
+        <a:font script="Sora" typeface="Nirmala UI"/>
+        <a:font script="Tale" typeface="Microsoft Tai Le"/>
+        <a:font script="Talu" typeface="Microsoft New Tai Lue"/>
+        <a:font script="Tfng" typeface="Ebrima"/>
+      </a:minorFont>
+    </a:fontScheme>
+    <a:fmtScheme name="Office">
+      <a:fillStyleLst>
+        <a:solidFill>
+          <a:schemeClr val="phClr"/>
+        </a:solidFill>
+        <a:gradFill rotWithShape="1">
+          <a:gsLst>
+            <a:gs pos="0">
+              <a:schemeClr val="phClr">
+                <a:lumMod val="110000"/>
+                <a:satMod val="105000"/>
+                <a:tint val="67000"/>
+              </a:schemeClr>
+            </a:gs>
+            <a:gs pos="50000">
+              <a:schemeClr val="phClr">
+                <a:lumMod val="105000"/>
+                <a:satMod val="103000"/>
+                <a:tint val="73000"/>
+              </a:schemeClr>
+            </a:gs>
+            <a:gs pos="100000">
+              <a:schemeClr val="phClr">
+                <a:lumMod val="105000"/>
+                <a:satMod val="109000"/>
+                <a:tint val="81000"/>
+              </a:schemeClr>
+            </a:gs>
+          </a:gsLst>
+          <a:lin ang="5400000" scaled="0"/>
+        </a:gradFill>
+        <a:gradFill rotWithShape="1">
+          <a:gsLst>
+            <a:gs pos="0">
+              <a:schemeClr val="phClr">
+                <a:satMod val="103000"/>
+                <a:lumMod val="102000"/>
+                <a:tint val="94000"/>
+              </a:schemeClr>
+            </a:gs>
+            <a:gs pos="50000">
+              <a:schemeClr val="phClr">
+                <a:satMod val="110000"/>
+                <a:lumMod val="100000"/>
+                <a:shade val="100000"/>
+              </a:schemeClr>
+            </a:gs>
+            <a:gs pos="100000">
+              <a:schemeClr val="phClr">
+                <a:lumMod val="99000"/>
+                <a:satMod val="120000"/>
+                <a:shade val="78000"/>
+              </a:schemeClr>
+            </a:gs>
+          </a:gsLst>
+          <a:lin ang="5400000" scaled="0"/>
+        </a:gradFill>
+      </a:fillStyleLst>
+      <a:lnStyleLst>
+        <a:ln w="12700" cap="flat" cmpd="sng" algn="ctr">
+          <a:solidFill>
+            <a:schemeClr val="phClr"/>
+          </a:solidFill>
+          <a:prstDash val="solid"/>
+          <a:miter lim="800000"/>
+        </a:ln>
+        <a:ln w="19050" cap="flat" cmpd="sng" algn="ctr">
+          <a:solidFill>
+            <a:schemeClr val="phClr"/>
+          </a:solidFill>
+          <a:prstDash val="solid"/>
+          <a:miter lim="800000"/>
+        </a:ln>
+        <a:ln w="25400" cap="flat" cmpd="sng" algn="ctr">
+          <a:solidFill>
+            <a:schemeClr val="phClr"/>
+          </a:solidFill>
+          <a:prstDash val="solid"/>
+          <a:miter lim="800000"/>
+        </a:ln>
+      </a:lnStyleLst>
+      <a:effectStyleLst>
+        <a:effectStyle>
+          <a:effectLst/>
+        </a:effectStyle>
+        <a:effectStyle>
+          <a:effectLst/>
+        </a:effectStyle>
+        <a:effectStyle>
+          <a:effectLst>
+            <a:outerShdw blurRad="57150" dist="19050" dir="5400000" algn="ctr" rotWithShape="0">
+              <a:srgbClr val="000000">
+                <a:alpha val="63000"/>
+              </a:srgbClr>
+            </a:outerShdw>
+          </a:effectLst>
+        </a:effectStyle>
+      </a:effectStyleLst>
+      <a:bgFillStyleLst>
+        <a:solidFill>
+          <a:schemeClr val="phClr"/>
+        </a:solidFill>
+        <a:solidFill>
+          <a:schemeClr val="phClr">
+            <a:tint val="95000"/>
+            <a:satMod val="170000"/>
+          </a:schemeClr>
+        </a:solidFill>
+        <a:gradFill rotWithShape="1">
+          <a:gsLst>
+            <a:gs pos="0">
+              <a:schemeClr val="phClr">
+                <a:tint val="93000"/>
+                <a:satMod val="150000"/>
+                <a:shade val="98000"/>
+                <a:lumMod val="102000"/>
+              </a:schemeClr>
+            </a:gs>
+            <a:gs pos="50000">
+              <a:schemeClr val="phClr">
+                <a:tint val="98000"/>
+                <a:satMod val="130000"/>
+                <a:shade val="90000"/>
+                <a:lumMod val="103000"/>
+              </a:schemeClr>
+            </a:gs>
+            <a:gs pos="100000">
+              <a:schemeClr val="phClr">
+                <a:shade val="63000"/>
+                <a:satMod val="120000"/>
+              </a:schemeClr>
+            </a:gs>
+          </a:gsLst>
+          <a:lin ang="5400000" scaled="0"/>
+        </a:gradFill>
+      </a:bgFillStyleLst>
+    </a:fmtScheme>
+  </a:themeElements>
+  <a:objectDefaults>
+    <a:lnDef>
+      <a:spPr/>
+      <a:bodyPr/>
+      <a:lstStyle/>
+      <a:style>
+        <a:lnRef idx="2">
+          <a:schemeClr val="accent1"/>
+        </a:lnRef>
+        <a:fillRef idx="0">
+          <a:schemeClr val="accent1"/>
+        </a:fillRef>
+        <a:effectRef idx="1">
+          <a:schemeClr val="accent1"/>
+        </a:effectRef>
+        <a:fontRef idx="minor">
+          <a:schemeClr val="tx1"/>
+        </a:fontRef>
+      </a:style>
+    </a:lnDef>
+  </a:objectDefaults>
+  <a:extraClrSchemeLst/>
+  <a:extLst>
+    <a:ext uri="{05A4C25C-085E-4340-85A3-A5531E510DB2}">
+      <thm15:themeFamily xmlns:thm15="http://schemas.microsoft.com/office/thememl/2012/main" name="Office Theme" id="{2E142A2C-CD16-42D6-873A-C26D2A0506FA}" vid="{1BDDFF52-6CD6-40A5-AB3C-68EB2F1E4D0A}"/>
+    </a:ext>
+  </a:extLst>
+</a:theme>
 </file>
</xml_diff>